<commit_message>
feat: update presentation and demo script for BizWizard project
</commit_message>
<xml_diff>
--- a/output/presentation/BizWizard-Presentation.pptx
+++ b/output/presentation/BizWizard-Presentation.pptx
@@ -2,27 +2,27 @@
 <file path=ppt/presentation.xml><?xml version="1.0" encoding="utf-8"?>
 <p:presentation xmlns:p="http://schemas.openxmlformats.org/presentationml/2006/main">
   <p:sldMasterIdLst>
-    <p:sldMasterId xmlns:r="http://schemas.openxmlformats.org/officeDocument/2006/relationships" id="2147483648" r:id="R750dc35553914904"/>
+    <p:sldMasterId xmlns:r="http://schemas.openxmlformats.org/officeDocument/2006/relationships" id="2147483648" r:id="Radd70485a44c4d68"/>
   </p:sldMasterIdLst>
   <p:notesMasterIdLst>
-    <p:notesMasterId xmlns:r="http://schemas.openxmlformats.org/officeDocument/2006/relationships" r:id="R1a52e235e47d4b6e"/>
+    <p:notesMasterId xmlns:r="http://schemas.openxmlformats.org/officeDocument/2006/relationships" r:id="R822dfc2541ef4d8f"/>
   </p:notesMasterIdLst>
   <p:sldIdLst>
-    <p:sldId xmlns:r="http://schemas.openxmlformats.org/officeDocument/2006/relationships" id="256" r:id="Rbeaae75410ef4d43"/>
-    <p:sldId xmlns:r="http://schemas.openxmlformats.org/officeDocument/2006/relationships" id="257" r:id="R087d6a5be62043ac"/>
-    <p:sldId xmlns:r="http://schemas.openxmlformats.org/officeDocument/2006/relationships" id="258" r:id="Rfd3a3ed39be445d8"/>
-    <p:sldId xmlns:r="http://schemas.openxmlformats.org/officeDocument/2006/relationships" id="259" r:id="Rc900e7c2f46643aa"/>
-    <p:sldId xmlns:r="http://schemas.openxmlformats.org/officeDocument/2006/relationships" id="260" r:id="R06fac6f942a74dcd"/>
-    <p:sldId xmlns:r="http://schemas.openxmlformats.org/officeDocument/2006/relationships" id="261" r:id="R6b1bab5303404212"/>
-    <p:sldId xmlns:r="http://schemas.openxmlformats.org/officeDocument/2006/relationships" id="262" r:id="R2f24bbbd755d4cbf"/>
-    <p:sldId xmlns:r="http://schemas.openxmlformats.org/officeDocument/2006/relationships" id="263" r:id="Rc7b807463f2e43bc"/>
-    <p:sldId xmlns:r="http://schemas.openxmlformats.org/officeDocument/2006/relationships" id="264" r:id="Rfd04138151464d9d"/>
-    <p:sldId xmlns:r="http://schemas.openxmlformats.org/officeDocument/2006/relationships" id="265" r:id="R026239dfc57c4657"/>
-    <p:sldId xmlns:r="http://schemas.openxmlformats.org/officeDocument/2006/relationships" id="266" r:id="Rad9b116bc9ab4791"/>
-    <p:sldId xmlns:r="http://schemas.openxmlformats.org/officeDocument/2006/relationships" id="267" r:id="Rc655e7c398d04ae6"/>
-    <p:sldId xmlns:r="http://schemas.openxmlformats.org/officeDocument/2006/relationships" id="268" r:id="Rf9305f570dcb4b57"/>
-    <p:sldId xmlns:r="http://schemas.openxmlformats.org/officeDocument/2006/relationships" id="269" r:id="R0566600853be4db0"/>
-    <p:sldId xmlns:r="http://schemas.openxmlformats.org/officeDocument/2006/relationships" id="270" r:id="Raa657667b16d4b1a"/>
+    <p:sldId xmlns:r="http://schemas.openxmlformats.org/officeDocument/2006/relationships" id="256" r:id="R0ac4d34065844303"/>
+    <p:sldId xmlns:r="http://schemas.openxmlformats.org/officeDocument/2006/relationships" id="257" r:id="Rc908cd955c394b13"/>
+    <p:sldId xmlns:r="http://schemas.openxmlformats.org/officeDocument/2006/relationships" id="258" r:id="R991956e7027a4732"/>
+    <p:sldId xmlns:r="http://schemas.openxmlformats.org/officeDocument/2006/relationships" id="259" r:id="R59ac8c3613cd45e7"/>
+    <p:sldId xmlns:r="http://schemas.openxmlformats.org/officeDocument/2006/relationships" id="260" r:id="R9873060d98ba47af"/>
+    <p:sldId xmlns:r="http://schemas.openxmlformats.org/officeDocument/2006/relationships" id="261" r:id="R2a5449cc940243f4"/>
+    <p:sldId xmlns:r="http://schemas.openxmlformats.org/officeDocument/2006/relationships" id="262" r:id="Rda56f1eb5ddc495c"/>
+    <p:sldId xmlns:r="http://schemas.openxmlformats.org/officeDocument/2006/relationships" id="263" r:id="R81f94bb3cfb24da8"/>
+    <p:sldId xmlns:r="http://schemas.openxmlformats.org/officeDocument/2006/relationships" id="264" r:id="R203ca2bf26854412"/>
+    <p:sldId xmlns:r="http://schemas.openxmlformats.org/officeDocument/2006/relationships" id="265" r:id="R245a82b0e4fc4760"/>
+    <p:sldId xmlns:r="http://schemas.openxmlformats.org/officeDocument/2006/relationships" id="266" r:id="Rb69ea08056bf4f4c"/>
+    <p:sldId xmlns:r="http://schemas.openxmlformats.org/officeDocument/2006/relationships" id="267" r:id="R6d8aa5d3d6a648ff"/>
+    <p:sldId xmlns:r="http://schemas.openxmlformats.org/officeDocument/2006/relationships" id="268" r:id="Rb10480f7deea4085"/>
+    <p:sldId xmlns:r="http://schemas.openxmlformats.org/officeDocument/2006/relationships" id="269" r:id="Re59165e63cef4c21"/>
+    <p:sldId xmlns:r="http://schemas.openxmlformats.org/officeDocument/2006/relationships" id="270" r:id="R4172f40f7cc64665"/>
   </p:sldIdLst>
   <p:sldSz cx="15240000" cy="8572500"/>
   <p:notesSz cx="6858000" cy="9144000"/>
@@ -456,7 +456,7 @@
           <a:lstStyle xmlns:a="http://schemas.openxmlformats.org/drawingml/2006/main"/>
           <a:p xmlns:a="http://schemas.openxmlformats.org/drawingml/2006/main">
             <a:r>
-              <a:t>Suggested speaking time: 20 seconds.</a:t>
+              <a:t>Suggested speaking time: 30 seconds.</a:t>
             </a:r>
           </a:p>
           <a:p xmlns:a="http://schemas.openxmlformats.org/drawingml/2006/main">
@@ -466,7 +466,7 @@
           </a:p>
           <a:p xmlns:a="http://schemas.openxmlformats.org/drawingml/2006/main">
             <a:r>
-              <a:t>BizWizard helps a small-business owner make financing and cash decisions using the records the shop already keeps. We will follow an owner from a cash concern to a proposed action, then show the controls and evidence behind that action.</a:t>
+              <a:t>We are BongoForge: Sadman Sakib, Mahfuz Saim and Sunan Rabbi. All three of us study CSE in the fourth year, second semester at Rajshahi University of Engineering &amp; Technology, RUET. BizWizard helps a small-business owner make financing and cash decisions using the records the shop already keeps. We will follow an owner from a cash concern to a proposed action, then show the controls and evidence behind that action.</a:t>
             </a:r>
           </a:p>
           <a:p xmlns:a="http://schemas.openxmlformats.org/drawingml/2006/main">
@@ -502,6 +502,11 @@
           <a:p xmlns:a="http://schemas.openxmlformats.org/drawingml/2006/main">
             <a:r>
               <a:t>submission/presentation/assets/provenance.json</a:t>
+            </a:r>
+          </a:p>
+          <a:p xmlns:a="http://schemas.openxmlformats.org/drawingml/2006/main">
+            <a:r>
+              <a:t>Team names and academic affiliation supplied by the team.</a:t>
             </a:r>
           </a:p>
         </p:txBody>
@@ -2168,7 +2173,7 @@
           <p:cNvPr id="3" name="Title">
             <a:extLst xmlns:a="http://schemas.openxmlformats.org/drawingml/2006/main">
               <a:ext uri="{FF2B5EF4-FFF2-40B4-BE49-F238E27FC236}">
-                <a16:creationId xmlns:a16="http://schemas.microsoft.com/office/drawing/2014/main" id="{C67AC62C-46B1-4BA3-87A9-9C597EB5CC1D}"/>
+                <a16:creationId xmlns:a16="http://schemas.microsoft.com/office/drawing/2014/main" id="{270B416E-3487-4DB2-A3E5-2C149888CF38}"/>
               </a:ext>
             </a:extLst>
           </p:cNvPr>
@@ -2325,7 +2330,7 @@
           <p:cNvPr id="2" name="Subtitle">
             <a:extLst xmlns:a="http://schemas.openxmlformats.org/drawingml/2006/main">
               <a:ext uri="{FF2B5EF4-FFF2-40B4-BE49-F238E27FC236}">
-                <a16:creationId xmlns:a16="http://schemas.microsoft.com/office/drawing/2014/main" id="{BAE0AACE-4460-40B6-B056-27B44DC54A35}"/>
+                <a16:creationId xmlns:a16="http://schemas.microsoft.com/office/drawing/2014/main" id="{26890296-E1DD-487A-99F7-051147AB744A}"/>
               </a:ext>
             </a:extLst>
           </p:cNvPr>
@@ -2499,7 +2504,7 @@
           <p:cNvPr id="2" name="Section title">
             <a:extLst xmlns:a="http://schemas.openxmlformats.org/drawingml/2006/main">
               <a:ext uri="{FF2B5EF4-FFF2-40B4-BE49-F238E27FC236}">
-                <a16:creationId xmlns:a16="http://schemas.microsoft.com/office/drawing/2014/main" id="{7EF70B10-C298-47EF-8E4E-C0975796B62C}"/>
+                <a16:creationId xmlns:a16="http://schemas.microsoft.com/office/drawing/2014/main" id="{C43E9661-1892-4009-9FDB-A2538737F71F}"/>
               </a:ext>
             </a:extLst>
           </p:cNvPr>
@@ -2673,7 +2678,7 @@
           <p:cNvPr id="3" name="Title">
             <a:extLst xmlns:a="http://schemas.openxmlformats.org/drawingml/2006/main">
               <a:ext uri="{FF2B5EF4-FFF2-40B4-BE49-F238E27FC236}">
-                <a16:creationId xmlns:a16="http://schemas.microsoft.com/office/drawing/2014/main" id="{B41D3D16-7349-43EC-977A-C455500F0018}"/>
+                <a16:creationId xmlns:a16="http://schemas.microsoft.com/office/drawing/2014/main" id="{AEDA1657-0E62-4209-BED7-2A405624AF9B}"/>
               </a:ext>
             </a:extLst>
           </p:cNvPr>
@@ -2830,7 +2835,7 @@
           <p:cNvPr id="2" name="Body">
             <a:extLst xmlns:a="http://schemas.openxmlformats.org/drawingml/2006/main">
               <a:ext uri="{FF2B5EF4-FFF2-40B4-BE49-F238E27FC236}">
-                <a16:creationId xmlns:a16="http://schemas.microsoft.com/office/drawing/2014/main" id="{6F4C0AA0-EACA-4236-9D85-F464AB526518}"/>
+                <a16:creationId xmlns:a16="http://schemas.microsoft.com/office/drawing/2014/main" id="{0DC57002-F1E4-4569-9565-CA4AB382EF52}"/>
               </a:ext>
             </a:extLst>
           </p:cNvPr>
@@ -3004,7 +3009,7 @@
           <p:cNvPr id="4" name="Title">
             <a:extLst xmlns:a="http://schemas.openxmlformats.org/drawingml/2006/main">
               <a:ext uri="{FF2B5EF4-FFF2-40B4-BE49-F238E27FC236}">
-                <a16:creationId xmlns:a16="http://schemas.microsoft.com/office/drawing/2014/main" id="{AB046ADA-A837-4AE2-891A-9011142CB91E}"/>
+                <a16:creationId xmlns:a16="http://schemas.microsoft.com/office/drawing/2014/main" id="{5A46CB8C-4064-426A-ABE8-59BEFE79D46A}"/>
               </a:ext>
             </a:extLst>
           </p:cNvPr>
@@ -3161,7 +3166,7 @@
           <p:cNvPr id="2" name="Left column">
             <a:extLst xmlns:a="http://schemas.openxmlformats.org/drawingml/2006/main">
               <a:ext uri="{FF2B5EF4-FFF2-40B4-BE49-F238E27FC236}">
-                <a16:creationId xmlns:a16="http://schemas.microsoft.com/office/drawing/2014/main" id="{5BD7641A-FADC-4709-B044-4FBDE4CA54EB}"/>
+                <a16:creationId xmlns:a16="http://schemas.microsoft.com/office/drawing/2014/main" id="{7E275686-C44B-4C7C-9D8E-C24FAD6263C4}"/>
               </a:ext>
             </a:extLst>
           </p:cNvPr>
@@ -3318,7 +3323,7 @@
           <p:cNvPr id="3" name="Right column">
             <a:extLst xmlns:a="http://schemas.openxmlformats.org/drawingml/2006/main">
               <a:ext uri="{FF2B5EF4-FFF2-40B4-BE49-F238E27FC236}">
-                <a16:creationId xmlns:a16="http://schemas.microsoft.com/office/drawing/2014/main" id="{FDA7E572-B7DF-443E-9B4D-F1C1273C0FAE}"/>
+                <a16:creationId xmlns:a16="http://schemas.microsoft.com/office/drawing/2014/main" id="{2619E7A7-8789-4D2A-AFEB-85A2A3235517}"/>
               </a:ext>
             </a:extLst>
           </p:cNvPr>
@@ -3492,7 +3497,7 @@
           <p:cNvPr id="3" name="Title">
             <a:extLst xmlns:a="http://schemas.openxmlformats.org/drawingml/2006/main">
               <a:ext uri="{FF2B5EF4-FFF2-40B4-BE49-F238E27FC236}">
-                <a16:creationId xmlns:a16="http://schemas.microsoft.com/office/drawing/2014/main" id="{E01BB4CD-5E14-464B-BBB0-F9BD098461F2}"/>
+                <a16:creationId xmlns:a16="http://schemas.microsoft.com/office/drawing/2014/main" id="{F1C79F76-773B-41F5-8124-1FD5AE48850C}"/>
               </a:ext>
             </a:extLst>
           </p:cNvPr>
@@ -3649,7 +3654,7 @@
           <p:cNvPr id="2" name="Left column">
             <a:extLst xmlns:a="http://schemas.openxmlformats.org/drawingml/2006/main">
               <a:ext uri="{FF2B5EF4-FFF2-40B4-BE49-F238E27FC236}">
-                <a16:creationId xmlns:a16="http://schemas.microsoft.com/office/drawing/2014/main" id="{11594BC3-B53B-4588-BD4C-09A6C9DE1D91}"/>
+                <a16:creationId xmlns:a16="http://schemas.microsoft.com/office/drawing/2014/main" id="{482AB839-1DAC-47A6-B957-E23FAE6718FB}"/>
               </a:ext>
             </a:extLst>
           </p:cNvPr>
@@ -3844,12 +3849,12 @@
   </p:cSld>
   <p:clrMap bg1="lt1" tx1="dk1" bg2="lt2" tx2="dk2" accent1="accent1" accent2="accent2" accent3="accent3" accent4="accent4" accent5="accent5" accent6="accent6" hlink="hlink" folHlink="folHlink"/>
   <p:sldLayoutIdLst>
-    <p:sldLayoutId xmlns:r="http://schemas.openxmlformats.org/officeDocument/2006/relationships" id="2147483649" r:id="Re45129cf6a5147e0"/>
-    <p:sldLayoutId xmlns:r="http://schemas.openxmlformats.org/officeDocument/2006/relationships" id="2147483650" r:id="Rbfdc81efc5354fd1"/>
-    <p:sldLayoutId xmlns:r="http://schemas.openxmlformats.org/officeDocument/2006/relationships" id="2147483651" r:id="R01ed7d7fbfe2428e"/>
-    <p:sldLayoutId xmlns:r="http://schemas.openxmlformats.org/officeDocument/2006/relationships" id="2147483652" r:id="R17b62052549645c1"/>
-    <p:sldLayoutId xmlns:r="http://schemas.openxmlformats.org/officeDocument/2006/relationships" id="2147483653" r:id="R4e0db10536554c6c"/>
-    <p:sldLayoutId xmlns:r="http://schemas.openxmlformats.org/officeDocument/2006/relationships" id="2147483654" r:id="R1a7bea92961e42d7"/>
+    <p:sldLayoutId xmlns:r="http://schemas.openxmlformats.org/officeDocument/2006/relationships" id="2147483649" r:id="R0596041c0f174afa"/>
+    <p:sldLayoutId xmlns:r="http://schemas.openxmlformats.org/officeDocument/2006/relationships" id="2147483650" r:id="Rde14518306af4071"/>
+    <p:sldLayoutId xmlns:r="http://schemas.openxmlformats.org/officeDocument/2006/relationships" id="2147483651" r:id="R8f4764e35f1e4772"/>
+    <p:sldLayoutId xmlns:r="http://schemas.openxmlformats.org/officeDocument/2006/relationships" id="2147483652" r:id="Ra0c5a047b2354868"/>
+    <p:sldLayoutId xmlns:r="http://schemas.openxmlformats.org/officeDocument/2006/relationships" id="2147483653" r:id="R41718c51a9f44752"/>
+    <p:sldLayoutId xmlns:r="http://schemas.openxmlformats.org/officeDocument/2006/relationships" id="2147483654" r:id="Rf5a34ef71a5e4b81"/>
   </p:sldLayoutIdLst>
   <p:txStyles>
     <p:titleStyle>
@@ -4824,10 +4829,10 @@
       </p:grpSpPr>
       <p:sp>
         <p:nvSpPr>
-          <p:cNvPr id="10" name="BizWizard">
-            <a:extLst xmlns:a="http://schemas.openxmlformats.org/drawingml/2006/main">
-              <a:ext uri="{FF2B5EF4-FFF2-40B4-BE49-F238E27FC236}">
-                <a16:creationId xmlns:a16="http://schemas.microsoft.com/office/drawing/2014/main" id="{BC5875DE-CE68-4DCE-85EC-93BE2197D48C}"/>
+          <p:cNvPr id="14" name="BizWizard">
+            <a:extLst xmlns:a="http://schemas.openxmlformats.org/drawingml/2006/main">
+              <a:ext uri="{FF2B5EF4-FFF2-40B4-BE49-F238E27FC236}">
+                <a16:creationId xmlns:a16="http://schemas.microsoft.com/office/drawing/2014/main" id="{945BB614-A718-4EC6-86C5-8BD192CDA2F0}"/>
               </a:ext>
             </a:extLst>
           </p:cNvPr>
@@ -4895,7 +4900,7 @@
           <p:cNvPr id="2" name="01">
             <a:extLst xmlns:a="http://schemas.openxmlformats.org/drawingml/2006/main">
               <a:ext uri="{FF2B5EF4-FFF2-40B4-BE49-F238E27FC236}">
-                <a16:creationId xmlns:a16="http://schemas.microsoft.com/office/drawing/2014/main" id="{5D4927F3-7EA6-4656-9AE4-BAE0256952C5}"/>
+                <a16:creationId xmlns:a16="http://schemas.microsoft.com/office/drawing/2014/main" id="{184DD00F-662F-49B2-AD99-D0EC62F80CDB}"/>
               </a:ext>
             </a:extLst>
           </p:cNvPr>
@@ -4963,7 +4968,7 @@
           <p:cNvPr id="3" name="SME FINANCE COPILOT">
             <a:extLst xmlns:a="http://schemas.openxmlformats.org/drawingml/2006/main">
               <a:ext uri="{FF2B5EF4-FFF2-40B4-BE49-F238E27FC236}">
-                <a16:creationId xmlns:a16="http://schemas.microsoft.com/office/drawing/2014/main" id="{665B7FBC-43BB-4E5B-8A27-CC9ADCBC8938}"/>
+                <a16:creationId xmlns:a16="http://schemas.microsoft.com/office/drawing/2014/main" id="{4A5DD7F0-B464-42A6-A4D4-109AFD1A8613}"/>
               </a:ext>
             </a:extLst>
           </p:cNvPr>
@@ -5031,7 +5036,7 @@
           <p:cNvPr id="4" name="BizWizard">
             <a:extLst xmlns:a="http://schemas.openxmlformats.org/drawingml/2006/main">
               <a:ext uri="{FF2B5EF4-FFF2-40B4-BE49-F238E27FC236}">
-                <a16:creationId xmlns:a16="http://schemas.microsoft.com/office/drawing/2014/main" id="{5EC22386-2F98-4A9F-B106-11CB63CA9128}"/>
+                <a16:creationId xmlns:a16="http://schemas.microsoft.com/office/drawing/2014/main" id="{28EE7FD6-6164-4A81-87E0-24952FDF6DA0}"/>
               </a:ext>
             </a:extLst>
           </p:cNvPr>
@@ -5099,7 +5104,7 @@
           <p:cNvPr id="5" name="Financial decisions for the shop owner">
             <a:extLst xmlns:a="http://schemas.openxmlformats.org/drawingml/2006/main">
               <a:ext uri="{FF2B5EF4-FFF2-40B4-BE49-F238E27FC236}">
-                <a16:creationId xmlns:a16="http://schemas.microsoft.com/office/drawing/2014/main" id="{885AE325-839E-4D23-B520-61B925D30939}"/>
+                <a16:creationId xmlns:a16="http://schemas.microsoft.com/office/drawing/2014/main" id="{7ADEA70D-4E63-486E-8B81-74579751002C}"/>
               </a:ext>
             </a:extLst>
           </p:cNvPr>
@@ -5190,7 +5195,7 @@
           <p:cNvPr id="6" name="Financing options, cash alerts and business analysis in one ">
             <a:extLst xmlns:a="http://schemas.openxmlformats.org/drawingml/2006/main">
               <a:ext uri="{FF2B5EF4-FFF2-40B4-BE49-F238E27FC236}">
-                <a16:creationId xmlns:a16="http://schemas.microsoft.com/office/drawing/2014/main" id="{30E39D90-B6B3-4FB9-B4E6-79D2F3E315EB}"/>
+                <a16:creationId xmlns:a16="http://schemas.microsoft.com/office/drawing/2014/main" id="{D7F559D2-E513-4298-8B3E-AEEE64202139}"/>
               </a:ext>
             </a:extLst>
           </p:cNvPr>
@@ -5281,7 +5286,7 @@
           <p:cNvPr id="7" name="">
             <a:extLst xmlns:a="http://schemas.openxmlformats.org/drawingml/2006/main">
               <a:ext uri="{FF2B5EF4-FFF2-40B4-BE49-F238E27FC236}">
-                <a16:creationId xmlns:a16="http://schemas.microsoft.com/office/drawing/2014/main" id="{01EF039A-30D7-4267-9811-831FDEE220F2}"/>
+                <a16:creationId xmlns:a16="http://schemas.microsoft.com/office/drawing/2014/main" id="{B2327586-AF53-4490-9233-7AFC87D08523}"/>
               </a:ext>
             </a:extLst>
           </p:cNvPr>
@@ -5291,7 +5296,7 @@
           <p:nvPr/>
         </p:nvPicPr>
         <p:blipFill>
-          <a:blip xmlns:r="http://schemas.openxmlformats.org/officeDocument/2006/relationships" xmlns:a="http://schemas.openxmlformats.org/drawingml/2006/main" r:embed="R867a97d5d7c8455b"/>
+          <a:blip xmlns:r="http://schemas.openxmlformats.org/officeDocument/2006/relationships" xmlns:a="http://schemas.openxmlformats.org/drawingml/2006/main" r:embed="R8733e3c587794863"/>
           <a:stretch xmlns:a="http://schemas.openxmlformats.org/drawingml/2006/main"/>
         </p:blipFill>
         <p:spPr>
@@ -5309,7 +5314,7 @@
           <p:cNvPr id="8" name="Current product UI with illustrative demo data">
             <a:extLst xmlns:a="http://schemas.openxmlformats.org/drawingml/2006/main">
               <a:ext uri="{FF2B5EF4-FFF2-40B4-BE49-F238E27FC236}">
-                <a16:creationId xmlns:a16="http://schemas.microsoft.com/office/drawing/2014/main" id="{FDC73EF3-61DE-4514-AAB2-B4AC92334982}"/>
+                <a16:creationId xmlns:a16="http://schemas.microsoft.com/office/drawing/2014/main" id="{0AC74559-7F5A-4251-921C-8DAC46D9DCDE}"/>
               </a:ext>
             </a:extLst>
           </p:cNvPr>
@@ -5374,10 +5379,10 @@
       </p:sp>
       <p:sp>
         <p:nvSpPr>
-          <p:cNvPr id="9" name="2026 FinTechathon International Track">
-            <a:extLst xmlns:a="http://schemas.openxmlformats.org/drawingml/2006/main">
-              <a:ext uri="{FF2B5EF4-FFF2-40B4-BE49-F238E27FC236}">
-                <a16:creationId xmlns:a16="http://schemas.microsoft.com/office/drawing/2014/main" id="{E9A9DAD3-88D8-4286-BE6C-86D6575C022D}"/>
+          <p:cNvPr id="9" name="BongoForge">
+            <a:extLst xmlns:a="http://schemas.openxmlformats.org/drawingml/2006/main">
+              <a:ext uri="{FF2B5EF4-FFF2-40B4-BE49-F238E27FC236}">
+                <a16:creationId xmlns:a16="http://schemas.microsoft.com/office/drawing/2014/main" id="{82B876B1-21D4-4545-BE83-5EAE6F9D8C4C}"/>
               </a:ext>
             </a:extLst>
           </p:cNvPr>
@@ -5388,8 +5393,8 @@
         </p:nvSpPr>
         <p:spPr>
           <a:xfrm xmlns:a="http://schemas.openxmlformats.org/drawingml/2006/main">
-            <a:off x="723900" y="7820025"/>
-            <a:ext cx="9525000" cy="304800"/>
+            <a:off x="723900" y="7029450"/>
+            <a:ext cx="6381750" cy="333375"/>
           </a:xfrm>
           <a:prstGeom xmlns:a="http://schemas.openxmlformats.org/drawingml/2006/main" prst="rect">
             <a:avLst/>
@@ -5405,9 +5410,9 @@
           </a:bodyPr>
           <a:lstStyle xmlns:a="http://schemas.openxmlformats.org/drawingml/2006/main">
             <a:defPPr algn="l">
-              <a:defRPr sz="1650" b="0">
-                <a:solidFill>
-                  <a:srgbClr val="ADBBD2"/>
+              <a:defRPr sz="2025" b="1">
+                <a:solidFill>
+                  <a:srgbClr val="FFFFFF"/>
                 </a:solidFill>
                 <a:latin typeface="Arial"/>
                 <a:ea typeface="Arial"/>
@@ -5417,7 +5422,131 @@
           </a:lstStyle>
           <a:p xmlns:a="http://schemas.openxmlformats.org/drawingml/2006/main">
             <a:pPr algn="l">
-              <a:defRPr sz="1650" b="0">
+              <a:defRPr sz="2025" b="1">
+                <a:solidFill>
+                  <a:srgbClr val="FFFFFF"/>
+                </a:solidFill>
+                <a:latin typeface="Arial"/>
+                <a:ea typeface="Arial"/>
+                <a:cs typeface="Arial"/>
+              </a:defRPr>
+            </a:pPr>
+            <a:r>
+              <a:rPr sz="2025" b="1">
+                <a:solidFill>
+                  <a:srgbClr val="FFFFFF"/>
+                </a:solidFill>
+                <a:latin typeface="Arial"/>
+                <a:ea typeface="Arial"/>
+                <a:cs typeface="Arial"/>
+              </a:rPr>
+              <a:t>BongoForge</a:t>
+            </a:r>
+          </a:p>
+        </p:txBody>
+      </p:sp>
+      <p:sp>
+        <p:nvSpPr>
+          <p:cNvPr id="10" name="Sadman Sakib / Mahfuz Saim / Sunan Rabbi">
+            <a:extLst xmlns:a="http://schemas.openxmlformats.org/drawingml/2006/main">
+              <a:ext uri="{FF2B5EF4-FFF2-40B4-BE49-F238E27FC236}">
+                <a16:creationId xmlns:a16="http://schemas.microsoft.com/office/drawing/2014/main" id="{923B62E9-E1D2-4ECD-A948-773236CFC302}"/>
+              </a:ext>
+            </a:extLst>
+          </p:cNvPr>
+          <p:cNvSpPr>
+            <a:spLocks xmlns:a="http://schemas.openxmlformats.org/drawingml/2006/main" noGrp="1"/>
+          </p:cNvSpPr>
+          <p:nvPr/>
+        </p:nvSpPr>
+        <p:spPr>
+          <a:xfrm xmlns:a="http://schemas.openxmlformats.org/drawingml/2006/main">
+            <a:off x="723900" y="7419975"/>
+            <a:ext cx="13811250" cy="314325"/>
+          </a:xfrm>
+          <a:prstGeom xmlns:a="http://schemas.openxmlformats.org/drawingml/2006/main" prst="rect">
+            <a:avLst/>
+          </a:prstGeom>
+          <a:noFill xmlns:a="http://schemas.openxmlformats.org/drawingml/2006/main"/>
+          <a:ln xmlns:a="http://schemas.openxmlformats.org/drawingml/2006/main" w="0">
+            <a:noFill/>
+          </a:ln>
+        </p:spPr>
+        <p:txBody>
+          <a:bodyPr xmlns:a="http://schemas.openxmlformats.org/drawingml/2006/main" wrap="square" lIns="0" tIns="0" rIns="0" bIns="0" anchor="t">
+            <a:noAutofit/>
+          </a:bodyPr>
+          <a:lstStyle xmlns:a="http://schemas.openxmlformats.org/drawingml/2006/main">
+            <a:defPPr algn="l">
+              <a:defRPr sz="1800" b="0">
+                <a:solidFill>
+                  <a:srgbClr val="FFFFFF"/>
+                </a:solidFill>
+                <a:latin typeface="Arial"/>
+                <a:ea typeface="Arial"/>
+                <a:cs typeface="Arial"/>
+              </a:defRPr>
+            </a:defPPr>
+          </a:lstStyle>
+          <a:p xmlns:a="http://schemas.openxmlformats.org/drawingml/2006/main">
+            <a:pPr algn="l">
+              <a:defRPr sz="1800" b="0">
+                <a:solidFill>
+                  <a:srgbClr val="FFFFFF"/>
+                </a:solidFill>
+                <a:latin typeface="Arial"/>
+                <a:ea typeface="Arial"/>
+                <a:cs typeface="Arial"/>
+              </a:defRPr>
+            </a:pPr>
+            <a:r>
+              <a:rPr sz="1800" b="0">
+                <a:solidFill>
+                  <a:srgbClr val="FFFFFF"/>
+                </a:solidFill>
+                <a:latin typeface="Arial"/>
+                <a:ea typeface="Arial"/>
+                <a:cs typeface="Arial"/>
+              </a:rPr>
+              <a:t>Sadman Sakib  /  Mahfuz Saim  /  Sunan Rabbi</a:t>
+            </a:r>
+          </a:p>
+        </p:txBody>
+      </p:sp>
+      <p:sp>
+        <p:nvSpPr>
+          <p:cNvPr id="11" name="Rajshahi University of Engineering &amp; Technology (RUET)">
+            <a:extLst xmlns:a="http://schemas.openxmlformats.org/drawingml/2006/main">
+              <a:ext uri="{FF2B5EF4-FFF2-40B4-BE49-F238E27FC236}">
+                <a16:creationId xmlns:a16="http://schemas.microsoft.com/office/drawing/2014/main" id="{2FEB8CD7-B35C-4FB7-9467-48A355BC19B7}"/>
+              </a:ext>
+            </a:extLst>
+          </p:cNvPr>
+          <p:cNvSpPr>
+            <a:spLocks xmlns:a="http://schemas.openxmlformats.org/drawingml/2006/main" noGrp="1"/>
+          </p:cNvSpPr>
+          <p:nvPr/>
+        </p:nvSpPr>
+        <p:spPr>
+          <a:xfrm xmlns:a="http://schemas.openxmlformats.org/drawingml/2006/main">
+            <a:off x="723900" y="7810500"/>
+            <a:ext cx="13811250" cy="295275"/>
+          </a:xfrm>
+          <a:prstGeom xmlns:a="http://schemas.openxmlformats.org/drawingml/2006/main" prst="rect">
+            <a:avLst/>
+          </a:prstGeom>
+          <a:noFill xmlns:a="http://schemas.openxmlformats.org/drawingml/2006/main"/>
+          <a:ln xmlns:a="http://schemas.openxmlformats.org/drawingml/2006/main" w="0">
+            <a:noFill/>
+          </a:ln>
+        </p:spPr>
+        <p:txBody>
+          <a:bodyPr xmlns:a="http://schemas.openxmlformats.org/drawingml/2006/main" wrap="square" lIns="0" tIns="0" rIns="0" bIns="0" anchor="t">
+            <a:noAutofit/>
+          </a:bodyPr>
+          <a:lstStyle xmlns:a="http://schemas.openxmlformats.org/drawingml/2006/main">
+            <a:defPPr algn="l">
+              <a:defRPr sz="1725" b="0">
                 <a:solidFill>
                   <a:srgbClr val="ADBBD2"/>
                 </a:solidFill>
@@ -5425,9 +5554,157 @@
                 <a:ea typeface="Arial"/>
                 <a:cs typeface="Arial"/>
               </a:defRPr>
+            </a:defPPr>
+          </a:lstStyle>
+          <a:p xmlns:a="http://schemas.openxmlformats.org/drawingml/2006/main">
+            <a:pPr algn="l">
+              <a:defRPr sz="1725" b="0">
+                <a:solidFill>
+                  <a:srgbClr val="ADBBD2"/>
+                </a:solidFill>
+                <a:latin typeface="Arial"/>
+                <a:ea typeface="Arial"/>
+                <a:cs typeface="Arial"/>
+              </a:defRPr>
             </a:pPr>
             <a:r>
-              <a:rPr sz="1650" b="0">
+              <a:rPr sz="1725" b="0">
+                <a:solidFill>
+                  <a:srgbClr val="ADBBD2"/>
+                </a:solidFill>
+                <a:latin typeface="Arial"/>
+                <a:ea typeface="Arial"/>
+                <a:cs typeface="Arial"/>
+              </a:rPr>
+              <a:t>Rajshahi University of Engineering &amp; Technology (RUET)</a:t>
+            </a:r>
+          </a:p>
+        </p:txBody>
+      </p:sp>
+      <p:sp>
+        <p:nvSpPr>
+          <p:cNvPr id="12" name="CSE, 4th year, 2nd semester">
+            <a:extLst xmlns:a="http://schemas.openxmlformats.org/drawingml/2006/main">
+              <a:ext uri="{FF2B5EF4-FFF2-40B4-BE49-F238E27FC236}">
+                <a16:creationId xmlns:a16="http://schemas.microsoft.com/office/drawing/2014/main" id="{D71509A7-EBC2-4D89-837A-B0AC5D51373B}"/>
+              </a:ext>
+            </a:extLst>
+          </p:cNvPr>
+          <p:cNvSpPr>
+            <a:spLocks xmlns:a="http://schemas.openxmlformats.org/drawingml/2006/main" noGrp="1"/>
+          </p:cNvSpPr>
+          <p:nvPr/>
+        </p:nvSpPr>
+        <p:spPr>
+          <a:xfrm xmlns:a="http://schemas.openxmlformats.org/drawingml/2006/main">
+            <a:off x="723900" y="8153400"/>
+            <a:ext cx="13811250" cy="266700"/>
+          </a:xfrm>
+          <a:prstGeom xmlns:a="http://schemas.openxmlformats.org/drawingml/2006/main" prst="rect">
+            <a:avLst/>
+          </a:prstGeom>
+          <a:noFill xmlns:a="http://schemas.openxmlformats.org/drawingml/2006/main"/>
+          <a:ln xmlns:a="http://schemas.openxmlformats.org/drawingml/2006/main" w="0">
+            <a:noFill/>
+          </a:ln>
+        </p:spPr>
+        <p:txBody>
+          <a:bodyPr xmlns:a="http://schemas.openxmlformats.org/drawingml/2006/main" wrap="square" lIns="0" tIns="0" rIns="0" bIns="0" anchor="t">
+            <a:noAutofit/>
+          </a:bodyPr>
+          <a:lstStyle xmlns:a="http://schemas.openxmlformats.org/drawingml/2006/main">
+            <a:defPPr algn="l">
+              <a:defRPr sz="1575" b="0">
+                <a:solidFill>
+                  <a:srgbClr val="ADBBD2"/>
+                </a:solidFill>
+                <a:latin typeface="Arial"/>
+                <a:ea typeface="Arial"/>
+                <a:cs typeface="Arial"/>
+              </a:defRPr>
+            </a:defPPr>
+          </a:lstStyle>
+          <a:p xmlns:a="http://schemas.openxmlformats.org/drawingml/2006/main">
+            <a:pPr algn="l">
+              <a:defRPr sz="1575" b="0">
+                <a:solidFill>
+                  <a:srgbClr val="ADBBD2"/>
+                </a:solidFill>
+                <a:latin typeface="Arial"/>
+                <a:ea typeface="Arial"/>
+                <a:cs typeface="Arial"/>
+              </a:defRPr>
+            </a:pPr>
+            <a:r>
+              <a:rPr sz="1575" b="0">
+                <a:solidFill>
+                  <a:srgbClr val="ADBBD2"/>
+                </a:solidFill>
+                <a:latin typeface="Arial"/>
+                <a:ea typeface="Arial"/>
+                <a:cs typeface="Arial"/>
+              </a:rPr>
+              <a:t>CSE, 4th year, 2nd semester</a:t>
+            </a:r>
+          </a:p>
+        </p:txBody>
+      </p:sp>
+      <p:sp>
+        <p:nvSpPr>
+          <p:cNvPr id="13" name="2026 FinTechathon International Track">
+            <a:extLst xmlns:a="http://schemas.openxmlformats.org/drawingml/2006/main">
+              <a:ext uri="{FF2B5EF4-FFF2-40B4-BE49-F238E27FC236}">
+                <a16:creationId xmlns:a16="http://schemas.microsoft.com/office/drawing/2014/main" id="{6A2C9445-DD16-4E56-B7EE-22E7107E540D}"/>
+              </a:ext>
+            </a:extLst>
+          </p:cNvPr>
+          <p:cNvSpPr>
+            <a:spLocks xmlns:a="http://schemas.openxmlformats.org/drawingml/2006/main" noGrp="1"/>
+          </p:cNvSpPr>
+          <p:nvPr/>
+        </p:nvSpPr>
+        <p:spPr>
+          <a:xfrm xmlns:a="http://schemas.openxmlformats.org/drawingml/2006/main">
+            <a:off x="7572375" y="7162800"/>
+            <a:ext cx="6981825" cy="314325"/>
+          </a:xfrm>
+          <a:prstGeom xmlns:a="http://schemas.openxmlformats.org/drawingml/2006/main" prst="rect">
+            <a:avLst/>
+          </a:prstGeom>
+          <a:noFill xmlns:a="http://schemas.openxmlformats.org/drawingml/2006/main"/>
+          <a:ln xmlns:a="http://schemas.openxmlformats.org/drawingml/2006/main" w="0">
+            <a:noFill/>
+          </a:ln>
+        </p:spPr>
+        <p:txBody>
+          <a:bodyPr xmlns:a="http://schemas.openxmlformats.org/drawingml/2006/main" wrap="square" lIns="0" tIns="0" rIns="0" bIns="0" anchor="t">
+            <a:noAutofit/>
+          </a:bodyPr>
+          <a:lstStyle xmlns:a="http://schemas.openxmlformats.org/drawingml/2006/main">
+            <a:defPPr algn="l">
+              <a:defRPr sz="1575" b="0">
+                <a:solidFill>
+                  <a:srgbClr val="ADBBD2"/>
+                </a:solidFill>
+                <a:latin typeface="Arial"/>
+                <a:ea typeface="Arial"/>
+                <a:cs typeface="Arial"/>
+              </a:defRPr>
+            </a:defPPr>
+          </a:lstStyle>
+          <a:p xmlns:a="http://schemas.openxmlformats.org/drawingml/2006/main">
+            <a:pPr algn="l">
+              <a:defRPr sz="1575" b="0">
+                <a:solidFill>
+                  <a:srgbClr val="ADBBD2"/>
+                </a:solidFill>
+                <a:latin typeface="Arial"/>
+                <a:ea typeface="Arial"/>
+                <a:cs typeface="Arial"/>
+              </a:defRPr>
+            </a:pPr>
+            <a:r>
+              <a:rPr sz="1575" b="0">
                 <a:solidFill>
                   <a:srgbClr val="ADBBD2"/>
                 </a:solidFill>
@@ -5443,7 +5720,7 @@
     </p:spTree>
     <p:extLst>
       <p:ext uri="{BB962C8B-B14F-4D97-AF65-F5344CB8AC3E}">
-        <p14:creationId xmlns:p14="http://schemas.microsoft.com/office/powerpoint/2010/main" val="1794823850"/>
+        <p14:creationId xmlns:p14="http://schemas.microsoft.com/office/powerpoint/2010/main" val="1106891823"/>
       </p:ext>
     </p:extLst>
   </p:cSld>
@@ -5474,7 +5751,7 @@
           <p:cNvPr id="11" name="BizWizard">
             <a:extLst xmlns:a="http://schemas.openxmlformats.org/drawingml/2006/main">
               <a:ext uri="{FF2B5EF4-FFF2-40B4-BE49-F238E27FC236}">
-                <a16:creationId xmlns:a16="http://schemas.microsoft.com/office/drawing/2014/main" id="{F140F8E4-B202-4D87-BCE6-D53E83BFB2E9}"/>
+                <a16:creationId xmlns:a16="http://schemas.microsoft.com/office/drawing/2014/main" id="{071C2A1F-BC81-43B8-9B2D-80E7AF1853B2}"/>
               </a:ext>
             </a:extLst>
           </p:cNvPr>
@@ -5542,7 +5819,7 @@
           <p:cNvPr id="2" name="10">
             <a:extLst xmlns:a="http://schemas.openxmlformats.org/drawingml/2006/main">
               <a:ext uri="{FF2B5EF4-FFF2-40B4-BE49-F238E27FC236}">
-                <a16:creationId xmlns:a16="http://schemas.microsoft.com/office/drawing/2014/main" id="{310E9B74-BBB9-41FB-9F7B-CAC1734B28D5}"/>
+                <a16:creationId xmlns:a16="http://schemas.microsoft.com/office/drawing/2014/main" id="{1818C837-C069-45CF-AD0E-CA0E2B601424}"/>
               </a:ext>
             </a:extLst>
           </p:cNvPr>
@@ -5610,7 +5887,7 @@
           <p:cNvPr id="3" name="Slide heading">
             <a:extLst xmlns:a="http://schemas.openxmlformats.org/drawingml/2006/main">
               <a:ext uri="{FF2B5EF4-FFF2-40B4-BE49-F238E27FC236}">
-                <a16:creationId xmlns:a16="http://schemas.microsoft.com/office/drawing/2014/main" id="{9F14A504-5535-4F66-B535-00FA5B8B1D0B}"/>
+                <a16:creationId xmlns:a16="http://schemas.microsoft.com/office/drawing/2014/main" id="{A0152C25-D014-475C-8FB2-DA01B897206E}"/>
               </a:ext>
             </a:extLst>
           </p:cNvPr>
@@ -5678,7 +5955,7 @@
           <p:cNvPr id="4" name="">
             <a:extLst xmlns:a="http://schemas.openxmlformats.org/drawingml/2006/main">
               <a:ext uri="{FF2B5EF4-FFF2-40B4-BE49-F238E27FC236}">
-                <a16:creationId xmlns:a16="http://schemas.microsoft.com/office/drawing/2014/main" id="{490FF8D0-4CF3-408D-8ED8-E5D4F1259961}"/>
+                <a16:creationId xmlns:a16="http://schemas.microsoft.com/office/drawing/2014/main" id="{D00B7196-F010-4390-93B3-855DA9DF64AE}"/>
               </a:ext>
             </a:extLst>
           </p:cNvPr>
@@ -6305,7 +6582,7 @@
           <p:cNvPr id="5" name="Backend checks">
             <a:extLst xmlns:a="http://schemas.openxmlformats.org/drawingml/2006/main">
               <a:ext uri="{FF2B5EF4-FFF2-40B4-BE49-F238E27FC236}">
-                <a16:creationId xmlns:a16="http://schemas.microsoft.com/office/drawing/2014/main" id="{7E56629B-5BE9-4E56-AD11-8CC02BE6EF2D}"/>
+                <a16:creationId xmlns:a16="http://schemas.microsoft.com/office/drawing/2014/main" id="{A23D4F73-30D4-40C0-BA5B-32A893BEEFB2}"/>
               </a:ext>
             </a:extLst>
           </p:cNvPr>
@@ -6373,7 +6650,7 @@
           <p:cNvPr id="6" name="Token, role, tenant membership and employee shop assignment.">
             <a:extLst xmlns:a="http://schemas.openxmlformats.org/drawingml/2006/main">
               <a:ext uri="{FF2B5EF4-FFF2-40B4-BE49-F238E27FC236}">
-                <a16:creationId xmlns:a16="http://schemas.microsoft.com/office/drawing/2014/main" id="{22D9E1EF-81BD-4213-B03F-682AC4596CB6}"/>
+                <a16:creationId xmlns:a16="http://schemas.microsoft.com/office/drawing/2014/main" id="{9DAEA530-E90D-44D0-9634-65744E16071A}"/>
               </a:ext>
             </a:extLst>
           </p:cNvPr>
@@ -6464,7 +6741,7 @@
           <p:cNvPr id="7" name="Financial safeguards">
             <a:extLst xmlns:a="http://schemas.openxmlformats.org/drawingml/2006/main">
               <a:ext uri="{FF2B5EF4-FFF2-40B4-BE49-F238E27FC236}">
-                <a16:creationId xmlns:a16="http://schemas.microsoft.com/office/drawing/2014/main" id="{F671B744-33D2-4D69-B766-68B8338DFB7D}"/>
+                <a16:creationId xmlns:a16="http://schemas.microsoft.com/office/drawing/2014/main" id="{DB5A297E-B1F3-46CD-ADEF-043D6BF5A0F2}"/>
               </a:ext>
             </a:extLst>
           </p:cNvPr>
@@ -6532,7 +6809,7 @@
           <p:cNvPr id="8" name="Scoped references, allowed IDs and transactional state chang">
             <a:extLst xmlns:a="http://schemas.openxmlformats.org/drawingml/2006/main">
               <a:ext uri="{FF2B5EF4-FFF2-40B4-BE49-F238E27FC236}">
-                <a16:creationId xmlns:a16="http://schemas.microsoft.com/office/drawing/2014/main" id="{FF3C2607-1E30-48B6-9BA2-2FDEE50C2CBA}"/>
+                <a16:creationId xmlns:a16="http://schemas.microsoft.com/office/drawing/2014/main" id="{746DC549-E52F-42F2-8C91-2A89E48F60AC}"/>
               </a:ext>
             </a:extLst>
           </p:cNvPr>
@@ -6623,7 +6900,7 @@
           <p:cNvPr id="9" name="Remaining risks">
             <a:extLst xmlns:a="http://schemas.openxmlformats.org/drawingml/2006/main">
               <a:ext uri="{FF2B5EF4-FFF2-40B4-BE49-F238E27FC236}">
-                <a16:creationId xmlns:a16="http://schemas.microsoft.com/office/drawing/2014/main" id="{4D34FE24-88EF-4A2A-93E2-00AA344E0C30}"/>
+                <a16:creationId xmlns:a16="http://schemas.microsoft.com/office/drawing/2014/main" id="{A42C14BC-1B19-4FCB-9B05-18956A7F8B56}"/>
               </a:ext>
             </a:extLst>
           </p:cNvPr>
@@ -6691,7 +6968,7 @@
           <p:cNvPr id="10" name="Browser token storage, incomplete redaction, audit gaps and ">
             <a:extLst xmlns:a="http://schemas.openxmlformats.org/drawingml/2006/main">
               <a:ext uri="{FF2B5EF4-FFF2-40B4-BE49-F238E27FC236}">
-                <a16:creationId xmlns:a16="http://schemas.microsoft.com/office/drawing/2014/main" id="{26EC666B-1033-434C-8D38-0A64025B6940}"/>
+                <a16:creationId xmlns:a16="http://schemas.microsoft.com/office/drawing/2014/main" id="{E3FB40C2-7E00-412D-BA27-FB44694DB34D}"/>
               </a:ext>
             </a:extLst>
           </p:cNvPr>
@@ -6757,7 +7034,7 @@
     </p:spTree>
     <p:extLst>
       <p:ext uri="{BB962C8B-B14F-4D97-AF65-F5344CB8AC3E}">
-        <p14:creationId xmlns:p14="http://schemas.microsoft.com/office/powerpoint/2010/main" val="873164030"/>
+        <p14:creationId xmlns:p14="http://schemas.microsoft.com/office/powerpoint/2010/main" val="930265429"/>
       </p:ext>
     </p:extLst>
   </p:cSld>
@@ -6788,7 +7065,7 @@
           <p:cNvPr id="13" name="BizWizard">
             <a:extLst xmlns:a="http://schemas.openxmlformats.org/drawingml/2006/main">
               <a:ext uri="{FF2B5EF4-FFF2-40B4-BE49-F238E27FC236}">
-                <a16:creationId xmlns:a16="http://schemas.microsoft.com/office/drawing/2014/main" id="{7C602470-984A-42A9-901E-9698D0D0F011}"/>
+                <a16:creationId xmlns:a16="http://schemas.microsoft.com/office/drawing/2014/main" id="{4EE09892-EA17-4C57-90D8-6A402D80D94B}"/>
               </a:ext>
             </a:extLst>
           </p:cNvPr>
@@ -6856,7 +7133,7 @@
           <p:cNvPr id="2" name="11">
             <a:extLst xmlns:a="http://schemas.openxmlformats.org/drawingml/2006/main">
               <a:ext uri="{FF2B5EF4-FFF2-40B4-BE49-F238E27FC236}">
-                <a16:creationId xmlns:a16="http://schemas.microsoft.com/office/drawing/2014/main" id="{98A5F0AE-769F-42DD-AE4F-5B4236D57726}"/>
+                <a16:creationId xmlns:a16="http://schemas.microsoft.com/office/drawing/2014/main" id="{0E8EA42B-40E6-4984-9094-9710F4C7A025}"/>
               </a:ext>
             </a:extLst>
           </p:cNvPr>
@@ -6924,7 +7201,7 @@
           <p:cNvPr id="3" name="Slide heading">
             <a:extLst xmlns:a="http://schemas.openxmlformats.org/drawingml/2006/main">
               <a:ext uri="{FF2B5EF4-FFF2-40B4-BE49-F238E27FC236}">
-                <a16:creationId xmlns:a16="http://schemas.microsoft.com/office/drawing/2014/main" id="{4084EF4F-E74C-49DA-B3A8-555B85D4BAB6}"/>
+                <a16:creationId xmlns:a16="http://schemas.microsoft.com/office/drawing/2014/main" id="{A230DEFB-B37A-4302-B68D-51AB41492603}"/>
               </a:ext>
             </a:extLst>
           </p:cNvPr>
@@ -6992,7 +7269,7 @@
           <p:cNvPr id="4" name="Live AI versus pinned rules">
             <a:extLst xmlns:a="http://schemas.openxmlformats.org/drawingml/2006/main">
               <a:ext uri="{FF2B5EF4-FFF2-40B4-BE49-F238E27FC236}">
-                <a16:creationId xmlns:a16="http://schemas.microsoft.com/office/drawing/2014/main" id="{2CFEC3C3-48E7-40DC-B956-8DF4DE5D3A33}"/>
+                <a16:creationId xmlns:a16="http://schemas.microsoft.com/office/drawing/2014/main" id="{8DCAD8B6-3404-4F91-BAF3-82F5EF1FC648}"/>
               </a:ext>
             </a:extLst>
           </p:cNvPr>
@@ -7060,7 +7337,7 @@
           <p:cNvPr id="5" name="Three synthetic risk cases across four roles">
             <a:extLst xmlns:a="http://schemas.openxmlformats.org/drawingml/2006/main">
               <a:ext uri="{FF2B5EF4-FFF2-40B4-BE49-F238E27FC236}">
-                <a16:creationId xmlns:a16="http://schemas.microsoft.com/office/drawing/2014/main" id="{39B2062F-EAF0-410F-ACEE-E75CF6D3CDBD}"/>
+                <a16:creationId xmlns:a16="http://schemas.microsoft.com/office/drawing/2014/main" id="{F74865EE-2406-4F67-8CEC-EB1E4E0A0EE2}"/>
               </a:ext>
             </a:extLst>
           </p:cNvPr>
@@ -7128,7 +7405,7 @@
           <p:cNvPr id="6" name="Chart">
             <a:extLst xmlns:a="http://schemas.openxmlformats.org/drawingml/2006/main">
               <a:ext uri="{FF2B5EF4-FFF2-40B4-BE49-F238E27FC236}">
-                <a16:creationId xmlns:a16="http://schemas.microsoft.com/office/drawing/2014/main" id="{F467B745-7DC6-43CE-9EE1-68E622ADC266}"/>
+                <a16:creationId xmlns:a16="http://schemas.microsoft.com/office/drawing/2014/main" id="{362AE4EA-DA42-470D-9EF6-22EF957A07BD}"/>
               </a:ext>
             </a:extLst>
           </p:cNvPr>
@@ -7141,7 +7418,7 @@
         </p:xfrm>
         <a:graphic xmlns:a="http://schemas.openxmlformats.org/drawingml/2006/main">
           <a:graphicData uri="http://schemas.openxmlformats.org/drawingml/2006/chart">
-            <c:chart xmlns:r="http://schemas.openxmlformats.org/officeDocument/2006/relationships" xmlns:c="http://schemas.openxmlformats.org/drawingml/2006/chart" r:id="Rb3a62fe5fe6c4924"/>
+            <c:chart xmlns:r="http://schemas.openxmlformats.org/officeDocument/2006/relationships" xmlns:c="http://schemas.openxmlformats.org/drawingml/2006/chart" r:id="R82afdf921c7c4d68"/>
           </a:graphicData>
         </a:graphic>
       </p:graphicFrame>
@@ -7150,7 +7427,7 @@
           <p:cNvPr id="7" name="Section rule">
             <a:extLst xmlns:a="http://schemas.openxmlformats.org/drawingml/2006/main">
               <a:ext uri="{FF2B5EF4-FFF2-40B4-BE49-F238E27FC236}">
-                <a16:creationId xmlns:a16="http://schemas.microsoft.com/office/drawing/2014/main" id="{9A26696C-4EE4-4191-83B1-F9980AE0A63C}"/>
+                <a16:creationId xmlns:a16="http://schemas.microsoft.com/office/drawing/2014/main" id="{93B4F898-6273-4A81-91D4-793418795945}"/>
               </a:ext>
             </a:extLst>
           </p:cNvPr>
@@ -7180,7 +7457,7 @@
           <p:cNvPr id="8" name="11">
             <a:extLst xmlns:a="http://schemas.openxmlformats.org/drawingml/2006/main">
               <a:ext uri="{FF2B5EF4-FFF2-40B4-BE49-F238E27FC236}">
-                <a16:creationId xmlns:a16="http://schemas.microsoft.com/office/drawing/2014/main" id="{C1C15AFF-38EC-40F7-8F72-978BC5DE1D0A}"/>
+                <a16:creationId xmlns:a16="http://schemas.microsoft.com/office/drawing/2014/main" id="{47CA1C7A-9A57-4520-8211-F84C304942D2}"/>
               </a:ext>
             </a:extLst>
           </p:cNvPr>
@@ -7248,7 +7525,7 @@
           <p:cNvPr id="9" name="integration tests passed">
             <a:extLst xmlns:a="http://schemas.openxmlformats.org/drawingml/2006/main">
               <a:ext uri="{FF2B5EF4-FFF2-40B4-BE49-F238E27FC236}">
-                <a16:creationId xmlns:a16="http://schemas.microsoft.com/office/drawing/2014/main" id="{96FC47EB-02CF-4F77-B803-D5D0E07075A6}"/>
+                <a16:creationId xmlns:a16="http://schemas.microsoft.com/office/drawing/2014/main" id="{C1FC9BDE-5ADC-47A7-AADA-3EAA0F06837E}"/>
               </a:ext>
             </a:extLst>
           </p:cNvPr>
@@ -7316,7 +7593,7 @@
           <p:cNvPr id="10" name="5 suites Zero failed or skipped Migrations applied">
             <a:extLst xmlns:a="http://schemas.openxmlformats.org/drawingml/2006/main">
               <a:ext uri="{FF2B5EF4-FFF2-40B4-BE49-F238E27FC236}">
-                <a16:creationId xmlns:a16="http://schemas.microsoft.com/office/drawing/2014/main" id="{FCA82662-B4AA-4218-9D6D-B4AB2CDAB167}"/>
+                <a16:creationId xmlns:a16="http://schemas.microsoft.com/office/drawing/2014/main" id="{78ED8B38-6732-4A80-A37C-A72A66EBB023}"/>
               </a:ext>
             </a:extLst>
           </p:cNvPr>
@@ -7430,7 +7707,7 @@
           <p:cNvPr id="11" name="Cash integrity, permissions, concurrency and isolation">
             <a:extLst xmlns:a="http://schemas.openxmlformats.org/drawingml/2006/main">
               <a:ext uri="{FF2B5EF4-FFF2-40B4-BE49-F238E27FC236}">
-                <a16:creationId xmlns:a16="http://schemas.microsoft.com/office/drawing/2014/main" id="{704E8BD8-AD1E-4CB9-AE0A-C015D0D009D1}"/>
+                <a16:creationId xmlns:a16="http://schemas.microsoft.com/office/drawing/2014/main" id="{8196CA97-80D4-4267-A876-0A912E36A37C}"/>
               </a:ext>
             </a:extLst>
           </p:cNvPr>
@@ -7521,7 +7798,7 @@
           <p:cNvPr id="12" name="4 AI wins, 5 rules wins, 3 ties. Synthetic outcomes do not e">
             <a:extLst xmlns:a="http://schemas.openxmlformats.org/drawingml/2006/main">
               <a:ext uri="{FF2B5EF4-FFF2-40B4-BE49-F238E27FC236}">
-                <a16:creationId xmlns:a16="http://schemas.microsoft.com/office/drawing/2014/main" id="{74B518CC-01F1-4746-A8E5-E10F2CE1DE25}"/>
+                <a16:creationId xmlns:a16="http://schemas.microsoft.com/office/drawing/2014/main" id="{158547D1-266C-4AD5-AA02-2D8E8F9B7CA1}"/>
               </a:ext>
             </a:extLst>
           </p:cNvPr>
@@ -7587,7 +7864,7 @@
     </p:spTree>
     <p:extLst>
       <p:ext uri="{BB962C8B-B14F-4D97-AF65-F5344CB8AC3E}">
-        <p14:creationId xmlns:p14="http://schemas.microsoft.com/office/powerpoint/2010/main" val="1951789735"/>
+        <p14:creationId xmlns:p14="http://schemas.microsoft.com/office/powerpoint/2010/main" val="142732075"/>
       </p:ext>
     </p:extLst>
   </p:cSld>
@@ -7618,7 +7895,7 @@
           <p:cNvPr id="8" name="BizWizard">
             <a:extLst xmlns:a="http://schemas.openxmlformats.org/drawingml/2006/main">
               <a:ext uri="{FF2B5EF4-FFF2-40B4-BE49-F238E27FC236}">
-                <a16:creationId xmlns:a16="http://schemas.microsoft.com/office/drawing/2014/main" id="{69FA8B06-1016-4720-A6D1-CB6F84149E10}"/>
+                <a16:creationId xmlns:a16="http://schemas.microsoft.com/office/drawing/2014/main" id="{F86F9A68-3259-4FE5-979E-230C08013C5F}"/>
               </a:ext>
             </a:extLst>
           </p:cNvPr>
@@ -7686,7 +7963,7 @@
           <p:cNvPr id="2" name="12">
             <a:extLst xmlns:a="http://schemas.openxmlformats.org/drawingml/2006/main">
               <a:ext uri="{FF2B5EF4-FFF2-40B4-BE49-F238E27FC236}">
-                <a16:creationId xmlns:a16="http://schemas.microsoft.com/office/drawing/2014/main" id="{96E1755F-9236-41A6-9A80-6C1F259A6349}"/>
+                <a16:creationId xmlns:a16="http://schemas.microsoft.com/office/drawing/2014/main" id="{349079B4-FC4A-4E63-B0AE-77D6F562F9E8}"/>
               </a:ext>
             </a:extLst>
           </p:cNvPr>
@@ -7754,7 +8031,7 @@
           <p:cNvPr id="3" name="Slide heading">
             <a:extLst xmlns:a="http://schemas.openxmlformats.org/drawingml/2006/main">
               <a:ext uri="{FF2B5EF4-FFF2-40B4-BE49-F238E27FC236}">
-                <a16:creationId xmlns:a16="http://schemas.microsoft.com/office/drawing/2014/main" id="{006C4869-94B7-492B-AC43-776BC9A911ED}"/>
+                <a16:creationId xmlns:a16="http://schemas.microsoft.com/office/drawing/2014/main" id="{58057A78-FFD3-48B6-A344-29C4CC252633}"/>
               </a:ext>
             </a:extLst>
           </p:cNvPr>
@@ -7822,7 +8099,7 @@
           <p:cNvPr id="4" name="Business records become a decision the owner can inspect.">
             <a:extLst xmlns:a="http://schemas.openxmlformats.org/drawingml/2006/main">
               <a:ext uri="{FF2B5EF4-FFF2-40B4-BE49-F238E27FC236}">
-                <a16:creationId xmlns:a16="http://schemas.microsoft.com/office/drawing/2014/main" id="{23FC498F-A92E-4366-B6C9-D293840D2444}"/>
+                <a16:creationId xmlns:a16="http://schemas.microsoft.com/office/drawing/2014/main" id="{05967241-BB41-4991-B020-2002BBB34159}"/>
               </a:ext>
             </a:extLst>
           </p:cNvPr>
@@ -7913,7 +8190,7 @@
           <p:cNvPr id="5" name="Compare financing. Review a cash alert. Inspect the evidence">
             <a:extLst xmlns:a="http://schemas.openxmlformats.org/drawingml/2006/main">
               <a:ext uri="{FF2B5EF4-FFF2-40B4-BE49-F238E27FC236}">
-                <a16:creationId xmlns:a16="http://schemas.microsoft.com/office/drawing/2014/main" id="{BB3B0ECE-EA17-4A81-805E-EB0D43503478}"/>
+                <a16:creationId xmlns:a16="http://schemas.microsoft.com/office/drawing/2014/main" id="{4319D8B9-9E26-45A1-AC70-D1FF3F1765E3}"/>
               </a:ext>
             </a:extLst>
           </p:cNvPr>
@@ -8004,7 +8281,7 @@
           <p:cNvPr id="6" name="bizwizard.sadman.app">
             <a:extLst xmlns:a="http://schemas.openxmlformats.org/drawingml/2006/main">
               <a:ext uri="{FF2B5EF4-FFF2-40B4-BE49-F238E27FC236}">
-                <a16:creationId xmlns:a16="http://schemas.microsoft.com/office/drawing/2014/main" id="{7B83ED1B-9DD8-4F38-ABD8-8694CFB80206}"/>
+                <a16:creationId xmlns:a16="http://schemas.microsoft.com/office/drawing/2014/main" id="{E37CCF58-0F11-41E7-BFCD-2349E72196D5}"/>
               </a:ext>
             </a:extLst>
           </p:cNvPr>
@@ -8061,7 +8338,7 @@
                 <a:latin typeface="Arial"/>
                 <a:ea typeface="Arial"/>
                 <a:cs typeface="Arial"/>
-                <a:hlinkClick xmlns:r="http://schemas.openxmlformats.org/officeDocument/2006/relationships" r:id="R8f96833b18a24cbf"/>
+                <a:hlinkClick xmlns:r="http://schemas.openxmlformats.org/officeDocument/2006/relationships" r:id="R462d817a1df04cac"/>
               </a:rPr>
               <a:t>bizwizard.sadman.app</a:t>
             </a:r>
@@ -8073,7 +8350,7 @@
           <p:cNvPr id="7" name="Working sandbox. No external lender contact or bank transfer">
             <a:extLst xmlns:a="http://schemas.openxmlformats.org/drawingml/2006/main">
               <a:ext uri="{FF2B5EF4-FFF2-40B4-BE49-F238E27FC236}">
-                <a16:creationId xmlns:a16="http://schemas.microsoft.com/office/drawing/2014/main" id="{3940F1C3-091A-4E2B-A474-500C3CF2DD3D}"/>
+                <a16:creationId xmlns:a16="http://schemas.microsoft.com/office/drawing/2014/main" id="{7646C193-052F-47B1-9919-099645DC2D68}"/>
               </a:ext>
             </a:extLst>
           </p:cNvPr>
@@ -8139,7 +8416,7 @@
     </p:spTree>
     <p:extLst>
       <p:ext uri="{BB962C8B-B14F-4D97-AF65-F5344CB8AC3E}">
-        <p14:creationId xmlns:p14="http://schemas.microsoft.com/office/powerpoint/2010/main" val="1811703638"/>
+        <p14:creationId xmlns:p14="http://schemas.microsoft.com/office/powerpoint/2010/main" val="1072347135"/>
       </p:ext>
     </p:extLst>
   </p:cSld>
@@ -8170,7 +8447,7 @@
           <p:cNvPr id="8" name="BizWizard">
             <a:extLst xmlns:a="http://schemas.openxmlformats.org/drawingml/2006/main">
               <a:ext uri="{FF2B5EF4-FFF2-40B4-BE49-F238E27FC236}">
-                <a16:creationId xmlns:a16="http://schemas.microsoft.com/office/drawing/2014/main" id="{ABA4E24C-0AB2-436E-B733-DF38CD73C619}"/>
+                <a16:creationId xmlns:a16="http://schemas.microsoft.com/office/drawing/2014/main" id="{15C470A9-2AF9-425C-8C59-527BE7980320}"/>
               </a:ext>
             </a:extLst>
           </p:cNvPr>
@@ -8238,7 +8515,7 @@
           <p:cNvPr id="2" name="Technical backup">
             <a:extLst xmlns:a="http://schemas.openxmlformats.org/drawingml/2006/main">
               <a:ext uri="{FF2B5EF4-FFF2-40B4-BE49-F238E27FC236}">
-                <a16:creationId xmlns:a16="http://schemas.microsoft.com/office/drawing/2014/main" id="{1CB112BE-AA65-4E2F-8FFF-AB6540DDF538}"/>
+                <a16:creationId xmlns:a16="http://schemas.microsoft.com/office/drawing/2014/main" id="{3356E43E-5CD4-44EC-879A-D0895A34DFAB}"/>
               </a:ext>
             </a:extLst>
           </p:cNvPr>
@@ -8306,7 +8583,7 @@
           <p:cNvPr id="3" name="Slide heading">
             <a:extLst xmlns:a="http://schemas.openxmlformats.org/drawingml/2006/main">
               <a:ext uri="{FF2B5EF4-FFF2-40B4-BE49-F238E27FC236}">
-                <a16:creationId xmlns:a16="http://schemas.microsoft.com/office/drawing/2014/main" id="{F7456037-266F-4230-9F2A-138EDFA05D5B}"/>
+                <a16:creationId xmlns:a16="http://schemas.microsoft.com/office/drawing/2014/main" id="{F0BEEC4E-437B-4FA5-A407-DD13987B1452}"/>
               </a:ext>
             </a:extLst>
           </p:cNvPr>
@@ -8374,7 +8651,7 @@
           <p:cNvPr id="4" name="Eight paired paths on one frozen shop snapshot">
             <a:extLst xmlns:a="http://schemas.openxmlformats.org/drawingml/2006/main">
               <a:ext uri="{FF2B5EF4-FFF2-40B4-BE49-F238E27FC236}">
-                <a16:creationId xmlns:a16="http://schemas.microsoft.com/office/drawing/2014/main" id="{0A44ED88-4F8B-41EA-91E6-3154CB0E5FC4}"/>
+                <a16:creationId xmlns:a16="http://schemas.microsoft.com/office/drawing/2014/main" id="{0D4CC506-C52A-474E-A32E-9A07206C54C1}"/>
               </a:ext>
             </a:extLst>
           </p:cNvPr>
@@ -8442,7 +8719,7 @@
           <p:cNvPr id="5" name="">
             <a:extLst xmlns:a="http://schemas.openxmlformats.org/drawingml/2006/main">
               <a:ext uri="{FF2B5EF4-FFF2-40B4-BE49-F238E27FC236}">
-                <a16:creationId xmlns:a16="http://schemas.microsoft.com/office/drawing/2014/main" id="{D0434E6D-61CA-428E-8DC6-69EB9D5BA1C5}"/>
+                <a16:creationId xmlns:a16="http://schemas.microsoft.com/office/drawing/2014/main" id="{7A8DFB00-89FE-41DF-BD07-EA3DB3E70CEA}"/>
               </a:ext>
             </a:extLst>
           </p:cNvPr>
@@ -9256,7 +9533,7 @@
           <p:cNvPr id="6" name="Lender and borrower use full loan terms. Treasurer and analy">
             <a:extLst xmlns:a="http://schemas.openxmlformats.org/drawingml/2006/main">
               <a:ext uri="{FF2B5EF4-FFF2-40B4-BE49-F238E27FC236}">
-                <a16:creationId xmlns:a16="http://schemas.microsoft.com/office/drawing/2014/main" id="{EFFA9343-5FB5-48D9-B92B-F0B0403BAF56}"/>
+                <a16:creationId xmlns:a16="http://schemas.microsoft.com/office/drawing/2014/main" id="{00F8785F-C54D-4E76-8ABF-16D339376950}"/>
               </a:ext>
             </a:extLst>
           </p:cNvPr>
@@ -9324,7 +9601,7 @@
           <p:cNvPr id="7" name="Same draws for both policies. Offline replay matched the out">
             <a:extLst xmlns:a="http://schemas.openxmlformats.org/drawingml/2006/main">
               <a:ext uri="{FF2B5EF4-FFF2-40B4-BE49-F238E27FC236}">
-                <a16:creationId xmlns:a16="http://schemas.microsoft.com/office/drawing/2014/main" id="{BFB90854-1FE7-4303-9043-1807543E29C5}"/>
+                <a16:creationId xmlns:a16="http://schemas.microsoft.com/office/drawing/2014/main" id="{BF392001-DB45-43B6-A9AA-E47511760849}"/>
               </a:ext>
             </a:extLst>
           </p:cNvPr>
@@ -9390,7 +9667,7 @@
     </p:spTree>
     <p:extLst>
       <p:ext uri="{BB962C8B-B14F-4D97-AF65-F5344CB8AC3E}">
-        <p14:creationId xmlns:p14="http://schemas.microsoft.com/office/powerpoint/2010/main" val="386426641"/>
+        <p14:creationId xmlns:p14="http://schemas.microsoft.com/office/powerpoint/2010/main" val="2044729500"/>
       </p:ext>
     </p:extLst>
   </p:cSld>
@@ -9421,7 +9698,7 @@
           <p:cNvPr id="7" name="BizWizard">
             <a:extLst xmlns:a="http://schemas.openxmlformats.org/drawingml/2006/main">
               <a:ext uri="{FF2B5EF4-FFF2-40B4-BE49-F238E27FC236}">
-                <a16:creationId xmlns:a16="http://schemas.microsoft.com/office/drawing/2014/main" id="{81F1512A-3428-4F95-BB7B-781ACA7631B8}"/>
+                <a16:creationId xmlns:a16="http://schemas.microsoft.com/office/drawing/2014/main" id="{E3BD9F1D-7703-4A57-B71E-448FDDCA612E}"/>
               </a:ext>
             </a:extLst>
           </p:cNvPr>
@@ -9489,7 +9766,7 @@
           <p:cNvPr id="2" name="Technical backup">
             <a:extLst xmlns:a="http://schemas.openxmlformats.org/drawingml/2006/main">
               <a:ext uri="{FF2B5EF4-FFF2-40B4-BE49-F238E27FC236}">
-                <a16:creationId xmlns:a16="http://schemas.microsoft.com/office/drawing/2014/main" id="{4CE59E2B-3C01-440D-8B46-925CDD03219B}"/>
+                <a16:creationId xmlns:a16="http://schemas.microsoft.com/office/drawing/2014/main" id="{684CE1C6-2335-4AC0-BFCA-8E17AFF0B807}"/>
               </a:ext>
             </a:extLst>
           </p:cNvPr>
@@ -9557,7 +9834,7 @@
           <p:cNvPr id="3" name="Slide heading">
             <a:extLst xmlns:a="http://schemas.openxmlformats.org/drawingml/2006/main">
               <a:ext uri="{FF2B5EF4-FFF2-40B4-BE49-F238E27FC236}">
-                <a16:creationId xmlns:a16="http://schemas.microsoft.com/office/drawing/2014/main" id="{E1548BE1-26FF-416D-AC86-7804A5E9D52B}"/>
+                <a16:creationId xmlns:a16="http://schemas.microsoft.com/office/drawing/2014/main" id="{E20F65B2-C7DD-4DB9-8674-FB1571FE9DE1}"/>
               </a:ext>
             </a:extLst>
           </p:cNvPr>
@@ -9625,7 +9902,7 @@
           <p:cNvPr id="4" name="">
             <a:extLst xmlns:a="http://schemas.openxmlformats.org/drawingml/2006/main">
               <a:ext uri="{FF2B5EF4-FFF2-40B4-BE49-F238E27FC236}">
-                <a16:creationId xmlns:a16="http://schemas.microsoft.com/office/drawing/2014/main" id="{C7CCBB91-7265-49B2-A86A-043F0AD43C5C}"/>
+                <a16:creationId xmlns:a16="http://schemas.microsoft.com/office/drawing/2014/main" id="{5CB46DFD-F57A-40E4-807A-C004A75A274A}"/>
               </a:ext>
             </a:extLst>
           </p:cNvPr>
@@ -10252,7 +10529,7 @@
           <p:cNvPr id="5" name="Evidence reports retain the tested revision, inputs and outc">
             <a:extLst xmlns:a="http://schemas.openxmlformats.org/drawingml/2006/main">
               <a:ext uri="{FF2B5EF4-FFF2-40B4-BE49-F238E27FC236}">
-                <a16:creationId xmlns:a16="http://schemas.microsoft.com/office/drawing/2014/main" id="{3EAC0F1C-29E6-4CC6-A7FE-7DFB31DEFCC9}"/>
+                <a16:creationId xmlns:a16="http://schemas.microsoft.com/office/drawing/2014/main" id="{4BD426B4-721F-48CD-AD25-EE05536B7B01}"/>
               </a:ext>
             </a:extLst>
           </p:cNvPr>
@@ -10320,7 +10597,7 @@
           <p:cNvPr id="6" name="Live keys stay in the environment or Git-ignored .env.benchm">
             <a:extLst xmlns:a="http://schemas.openxmlformats.org/drawingml/2006/main">
               <a:ext uri="{FF2B5EF4-FFF2-40B4-BE49-F238E27FC236}">
-                <a16:creationId xmlns:a16="http://schemas.microsoft.com/office/drawing/2014/main" id="{98365299-0642-4F61-997F-2A40B619CAE3}"/>
+                <a16:creationId xmlns:a16="http://schemas.microsoft.com/office/drawing/2014/main" id="{AC225FE1-130E-45E1-8610-F55D07A5F958}"/>
               </a:ext>
             </a:extLst>
           </p:cNvPr>
@@ -10386,7 +10663,7 @@
     </p:spTree>
     <p:extLst>
       <p:ext uri="{BB962C8B-B14F-4D97-AF65-F5344CB8AC3E}">
-        <p14:creationId xmlns:p14="http://schemas.microsoft.com/office/powerpoint/2010/main" val="594073790"/>
+        <p14:creationId xmlns:p14="http://schemas.microsoft.com/office/powerpoint/2010/main" val="194700443"/>
       </p:ext>
     </p:extLst>
   </p:cSld>
@@ -10417,7 +10694,7 @@
           <p:cNvPr id="11" name="BizWizard">
             <a:extLst xmlns:a="http://schemas.openxmlformats.org/drawingml/2006/main">
               <a:ext uri="{FF2B5EF4-FFF2-40B4-BE49-F238E27FC236}">
-                <a16:creationId xmlns:a16="http://schemas.microsoft.com/office/drawing/2014/main" id="{5751FC15-DABD-4AFB-8FA9-7A804915AB3C}"/>
+                <a16:creationId xmlns:a16="http://schemas.microsoft.com/office/drawing/2014/main" id="{9D8F23AC-3586-469D-BD82-E7BE5711B41A}"/>
               </a:ext>
             </a:extLst>
           </p:cNvPr>
@@ -10485,7 +10762,7 @@
           <p:cNvPr id="2" name="Technical backup">
             <a:extLst xmlns:a="http://schemas.openxmlformats.org/drawingml/2006/main">
               <a:ext uri="{FF2B5EF4-FFF2-40B4-BE49-F238E27FC236}">
-                <a16:creationId xmlns:a16="http://schemas.microsoft.com/office/drawing/2014/main" id="{B43B52CE-2FF4-4BED-9C5D-506A48317A8E}"/>
+                <a16:creationId xmlns:a16="http://schemas.microsoft.com/office/drawing/2014/main" id="{94C63B2A-B02C-4EE1-9F4C-CDBD0A358475}"/>
               </a:ext>
             </a:extLst>
           </p:cNvPr>
@@ -10553,7 +10830,7 @@
           <p:cNvPr id="3" name="Slide heading">
             <a:extLst xmlns:a="http://schemas.openxmlformats.org/drawingml/2006/main">
               <a:ext uri="{FF2B5EF4-FFF2-40B4-BE49-F238E27FC236}">
-                <a16:creationId xmlns:a16="http://schemas.microsoft.com/office/drawing/2014/main" id="{55C71C15-BB26-4151-8EBE-ABD6D09CA814}"/>
+                <a16:creationId xmlns:a16="http://schemas.microsoft.com/office/drawing/2014/main" id="{0712AF56-400D-46FD-A780-F9D5DE5B41A5}"/>
               </a:ext>
             </a:extLst>
           </p:cNvPr>
@@ -10621,7 +10898,7 @@
           <p:cNvPr id="4" name="Demonstrated">
             <a:extLst xmlns:a="http://schemas.openxmlformats.org/drawingml/2006/main">
               <a:ext uri="{FF2B5EF4-FFF2-40B4-BE49-F238E27FC236}">
-                <a16:creationId xmlns:a16="http://schemas.microsoft.com/office/drawing/2014/main" id="{A59F52E2-A415-40A5-B218-A162F230F2C8}"/>
+                <a16:creationId xmlns:a16="http://schemas.microsoft.com/office/drawing/2014/main" id="{6AC04D40-BEB7-40D4-BCD5-091A4F8FD63B}"/>
               </a:ext>
             </a:extLst>
           </p:cNvPr>
@@ -10689,7 +10966,7 @@
           <p:cNvPr id="5" name="Scoped finance workflows, financial guards, local integratio">
             <a:extLst xmlns:a="http://schemas.openxmlformats.org/drawingml/2006/main">
               <a:ext uri="{FF2B5EF4-FFF2-40B4-BE49-F238E27FC236}">
-                <a16:creationId xmlns:a16="http://schemas.microsoft.com/office/drawing/2014/main" id="{5A84B4EB-1EE7-4198-AF1A-B431F65042AC}"/>
+                <a16:creationId xmlns:a16="http://schemas.microsoft.com/office/drawing/2014/main" id="{89DA8F67-3F41-4731-AE6A-F7618E47B3EE}"/>
               </a:ext>
             </a:extLst>
           </p:cNvPr>
@@ -10780,7 +11057,7 @@
           <p:cNvPr id="6" name="Section rule">
             <a:extLst xmlns:a="http://schemas.openxmlformats.org/drawingml/2006/main">
               <a:ext uri="{FF2B5EF4-FFF2-40B4-BE49-F238E27FC236}">
-                <a16:creationId xmlns:a16="http://schemas.microsoft.com/office/drawing/2014/main" id="{3D9D3C1C-0643-4BE5-B3CF-E2C2EED4C5DA}"/>
+                <a16:creationId xmlns:a16="http://schemas.microsoft.com/office/drawing/2014/main" id="{FE55E875-D6B9-4E76-A3F0-DAF1414833A6}"/>
               </a:ext>
             </a:extLst>
           </p:cNvPr>
@@ -10810,7 +11087,7 @@
           <p:cNvPr id="7" name="Before sensitive production use">
             <a:extLst xmlns:a="http://schemas.openxmlformats.org/drawingml/2006/main">
               <a:ext uri="{FF2B5EF4-FFF2-40B4-BE49-F238E27FC236}">
-                <a16:creationId xmlns:a16="http://schemas.microsoft.com/office/drawing/2014/main" id="{864B4004-4C7D-40BD-A7E3-EC359EF9DB2A}"/>
+                <a16:creationId xmlns:a16="http://schemas.microsoft.com/office/drawing/2014/main" id="{AC24A4E1-8B8C-4BAF-B47C-14D3D3A81BD3}"/>
               </a:ext>
             </a:extLst>
           </p:cNvPr>
@@ -10878,7 +11155,7 @@
           <p:cNvPr id="8" name="Review browser sessions and provider data handling. Strength">
             <a:extLst xmlns:a="http://schemas.openxmlformats.org/drawingml/2006/main">
               <a:ext uri="{FF2B5EF4-FFF2-40B4-BE49-F238E27FC236}">
-                <a16:creationId xmlns:a16="http://schemas.microsoft.com/office/drawing/2014/main" id="{741DC6C5-1AF1-46EB-857C-3081BBE26575}"/>
+                <a16:creationId xmlns:a16="http://schemas.microsoft.com/office/drawing/2014/main" id="{49E8B1E8-8881-4A86-BD0C-49AC1663905A}"/>
               </a:ext>
             </a:extLst>
           </p:cNvPr>
@@ -10969,7 +11246,7 @@
           <p:cNvPr id="9" name="Before any real lending">
             <a:extLst xmlns:a="http://schemas.openxmlformats.org/drawingml/2006/main">
               <a:ext uri="{FF2B5EF4-FFF2-40B4-BE49-F238E27FC236}">
-                <a16:creationId xmlns:a16="http://schemas.microsoft.com/office/drawing/2014/main" id="{CA2A8BC6-3E8F-4AA9-A9B0-02C1116AEDB9}"/>
+                <a16:creationId xmlns:a16="http://schemas.microsoft.com/office/drawing/2014/main" id="{66F5232C-3FE0-43DF-912F-C15CBA4FAA15}"/>
               </a:ext>
             </a:extLst>
           </p:cNvPr>
@@ -11037,7 +11314,7 @@
           <p:cNvPr id="10" name="Revalidate final terms and current affordability. Assess leg">
             <a:extLst xmlns:a="http://schemas.openxmlformats.org/drawingml/2006/main">
               <a:ext uri="{FF2B5EF4-FFF2-40B4-BE49-F238E27FC236}">
-                <a16:creationId xmlns:a16="http://schemas.microsoft.com/office/drawing/2014/main" id="{B113D87B-E21D-47BC-B1ED-6607473962D1}"/>
+                <a16:creationId xmlns:a16="http://schemas.microsoft.com/office/drawing/2014/main" id="{503ACE67-73DD-4582-8219-BE46453752F7}"/>
               </a:ext>
             </a:extLst>
           </p:cNvPr>
@@ -11126,7 +11403,7 @@
     </p:spTree>
     <p:extLst>
       <p:ext uri="{BB962C8B-B14F-4D97-AF65-F5344CB8AC3E}">
-        <p14:creationId xmlns:p14="http://schemas.microsoft.com/office/powerpoint/2010/main" val="2039537818"/>
+        <p14:creationId xmlns:p14="http://schemas.microsoft.com/office/powerpoint/2010/main" val="428728535"/>
       </p:ext>
     </p:extLst>
   </p:cSld>
@@ -11157,7 +11434,7 @@
           <p:cNvPr id="15" name="">
             <a:extLst xmlns:a="http://schemas.openxmlformats.org/drawingml/2006/main">
               <a:ext uri="{FF2B5EF4-FFF2-40B4-BE49-F238E27FC236}">
-                <a16:creationId xmlns:a16="http://schemas.microsoft.com/office/drawing/2014/main" id="{A82A6E5C-1CCE-485E-B17A-8D73D26E5777}"/>
+                <a16:creationId xmlns:a16="http://schemas.microsoft.com/office/drawing/2014/main" id="{4AF704C3-AD54-4496-AB05-1115E50A9C2C}"/>
               </a:ext>
             </a:extLst>
           </p:cNvPr>
@@ -11189,7 +11466,7 @@
           <p:cNvPr id="14" name="">
             <a:extLst xmlns:a="http://schemas.openxmlformats.org/drawingml/2006/main">
               <a:ext uri="{FF2B5EF4-FFF2-40B4-BE49-F238E27FC236}">
-                <a16:creationId xmlns:a16="http://schemas.microsoft.com/office/drawing/2014/main" id="{98031BF8-93B0-4FC5-BBEA-BF178FB7ECA8}"/>
+                <a16:creationId xmlns:a16="http://schemas.microsoft.com/office/drawing/2014/main" id="{7F30F450-8712-43B2-A6BF-A7EC5A9C346A}"/>
               </a:ext>
             </a:extLst>
           </p:cNvPr>
@@ -11221,7 +11498,7 @@
           <p:cNvPr id="21" name="BizWizard">
             <a:extLst xmlns:a="http://schemas.openxmlformats.org/drawingml/2006/main">
               <a:ext uri="{FF2B5EF4-FFF2-40B4-BE49-F238E27FC236}">
-                <a16:creationId xmlns:a16="http://schemas.microsoft.com/office/drawing/2014/main" id="{0A6B0C75-41F7-46CB-84C6-C1AD58C06B56}"/>
+                <a16:creationId xmlns:a16="http://schemas.microsoft.com/office/drawing/2014/main" id="{B2594DE5-2103-48BA-994D-4984FB4F02F4}"/>
               </a:ext>
             </a:extLst>
           </p:cNvPr>
@@ -11289,7 +11566,7 @@
           <p:cNvPr id="2" name="02">
             <a:extLst xmlns:a="http://schemas.openxmlformats.org/drawingml/2006/main">
               <a:ext uri="{FF2B5EF4-FFF2-40B4-BE49-F238E27FC236}">
-                <a16:creationId xmlns:a16="http://schemas.microsoft.com/office/drawing/2014/main" id="{3FA13A59-DFB6-4648-A7FD-F3590A587F13}"/>
+                <a16:creationId xmlns:a16="http://schemas.microsoft.com/office/drawing/2014/main" id="{62753040-C147-44E2-B63F-08C69876615A}"/>
               </a:ext>
             </a:extLst>
           </p:cNvPr>
@@ -11357,7 +11634,7 @@
           <p:cNvPr id="3" name="Slide heading">
             <a:extLst xmlns:a="http://schemas.openxmlformats.org/drawingml/2006/main">
               <a:ext uri="{FF2B5EF4-FFF2-40B4-BE49-F238E27FC236}">
-                <a16:creationId xmlns:a16="http://schemas.microsoft.com/office/drawing/2014/main" id="{CCC6AD52-C7AB-4754-A206-4829DF9F0471}"/>
+                <a16:creationId xmlns:a16="http://schemas.microsoft.com/office/drawing/2014/main" id="{DCF6F101-9204-4F7A-B354-85F0868BF448}"/>
               </a:ext>
             </a:extLst>
           </p:cNvPr>
@@ -11425,7 +11702,7 @@
           <p:cNvPr id="4" name="An illustrative owner scenario">
             <a:extLst xmlns:a="http://schemas.openxmlformats.org/drawingml/2006/main">
               <a:ext uri="{FF2B5EF4-FFF2-40B4-BE49-F238E27FC236}">
-                <a16:creationId xmlns:a16="http://schemas.microsoft.com/office/drawing/2014/main" id="{E98E89C8-A7C7-4235-9413-A06CC5978C03}"/>
+                <a16:creationId xmlns:a16="http://schemas.microsoft.com/office/drawing/2014/main" id="{B1628C76-7A38-4F50-8A54-65BDDC81A607}"/>
               </a:ext>
             </a:extLst>
           </p:cNvPr>
@@ -11493,7 +11770,7 @@
           <p:cNvPr id="5" name="Stock on the shelf">
             <a:extLst xmlns:a="http://schemas.openxmlformats.org/drawingml/2006/main">
               <a:ext uri="{FF2B5EF4-FFF2-40B4-BE49-F238E27FC236}">
-                <a16:creationId xmlns:a16="http://schemas.microsoft.com/office/drawing/2014/main" id="{0A9728B8-BC84-4FF3-8F46-2E18F87223C8}"/>
+                <a16:creationId xmlns:a16="http://schemas.microsoft.com/office/drawing/2014/main" id="{7CD83855-E7A4-4E2D-94B9-30B94E98C9CD}"/>
               </a:ext>
             </a:extLst>
           </p:cNvPr>
@@ -11525,7 +11802,7 @@
           <p:cNvPr id="6" name="Stock on the shelf">
             <a:extLst xmlns:a="http://schemas.openxmlformats.org/drawingml/2006/main">
               <a:ext uri="{FF2B5EF4-FFF2-40B4-BE49-F238E27FC236}">
-                <a16:creationId xmlns:a16="http://schemas.microsoft.com/office/drawing/2014/main" id="{0E068780-2ED2-421E-9000-FF28FBF18213}"/>
+                <a16:creationId xmlns:a16="http://schemas.microsoft.com/office/drawing/2014/main" id="{BE2E1F9C-A379-4BC0-BCD6-67534FEEBE67}"/>
               </a:ext>
             </a:extLst>
           </p:cNvPr>
@@ -11593,7 +11870,7 @@
           <p:cNvPr id="7" name="Cash has already paid for inventory">
             <a:extLst xmlns:a="http://schemas.openxmlformats.org/drawingml/2006/main">
               <a:ext uri="{FF2B5EF4-FFF2-40B4-BE49-F238E27FC236}">
-                <a16:creationId xmlns:a16="http://schemas.microsoft.com/office/drawing/2014/main" id="{8CFAF69A-14B0-4C4E-9D4E-0C62AE4F2386}"/>
+                <a16:creationId xmlns:a16="http://schemas.microsoft.com/office/drawing/2014/main" id="{4CEF29FE-AD93-46D2-8F06-245ED63040E4}"/>
               </a:ext>
             </a:extLst>
           </p:cNvPr>
@@ -11684,7 +11961,7 @@
           <p:cNvPr id="8" name="Sales on credit">
             <a:extLst xmlns:a="http://schemas.openxmlformats.org/drawingml/2006/main">
               <a:ext uri="{FF2B5EF4-FFF2-40B4-BE49-F238E27FC236}">
-                <a16:creationId xmlns:a16="http://schemas.microsoft.com/office/drawing/2014/main" id="{393B1C08-DEAD-4ECD-9A44-51A4E802196C}"/>
+                <a16:creationId xmlns:a16="http://schemas.microsoft.com/office/drawing/2014/main" id="{237B070D-CF8A-46EC-8B29-BFE69EF92C3F}"/>
               </a:ext>
             </a:extLst>
           </p:cNvPr>
@@ -11716,7 +11993,7 @@
           <p:cNvPr id="9" name="Sales on credit">
             <a:extLst xmlns:a="http://schemas.openxmlformats.org/drawingml/2006/main">
               <a:ext uri="{FF2B5EF4-FFF2-40B4-BE49-F238E27FC236}">
-                <a16:creationId xmlns:a16="http://schemas.microsoft.com/office/drawing/2014/main" id="{1C645857-BC72-41A9-BC9E-525BAFD75C58}"/>
+                <a16:creationId xmlns:a16="http://schemas.microsoft.com/office/drawing/2014/main" id="{E3960D25-A7D8-479C-9842-1771D0964DB2}"/>
               </a:ext>
             </a:extLst>
           </p:cNvPr>
@@ -11784,7 +12061,7 @@
           <p:cNvPr id="10" name="Customers still owe the shop">
             <a:extLst xmlns:a="http://schemas.openxmlformats.org/drawingml/2006/main">
               <a:ext uri="{FF2B5EF4-FFF2-40B4-BE49-F238E27FC236}">
-                <a16:creationId xmlns:a16="http://schemas.microsoft.com/office/drawing/2014/main" id="{6D451124-F4C0-4527-83C9-A6CA00859E6A}"/>
+                <a16:creationId xmlns:a16="http://schemas.microsoft.com/office/drawing/2014/main" id="{F2A72F83-3224-44AB-A902-A68AA6BB5DBA}"/>
               </a:ext>
             </a:extLst>
           </p:cNvPr>
@@ -11875,7 +12152,7 @@
           <p:cNvPr id="11" name="Bills approaching">
             <a:extLst xmlns:a="http://schemas.openxmlformats.org/drawingml/2006/main">
               <a:ext uri="{FF2B5EF4-FFF2-40B4-BE49-F238E27FC236}">
-                <a16:creationId xmlns:a16="http://schemas.microsoft.com/office/drawing/2014/main" id="{6D5F2D4F-A0E9-417C-B86A-D7AE19DA13F2}"/>
+                <a16:creationId xmlns:a16="http://schemas.microsoft.com/office/drawing/2014/main" id="{98E946F6-33E4-4555-B0D4-0AB3750713C8}"/>
               </a:ext>
             </a:extLst>
           </p:cNvPr>
@@ -11907,7 +12184,7 @@
           <p:cNvPr id="12" name="Bills approaching">
             <a:extLst xmlns:a="http://schemas.openxmlformats.org/drawingml/2006/main">
               <a:ext uri="{FF2B5EF4-FFF2-40B4-BE49-F238E27FC236}">
-                <a16:creationId xmlns:a16="http://schemas.microsoft.com/office/drawing/2014/main" id="{70D51A0E-2336-403A-A247-B66E198B5801}"/>
+                <a16:creationId xmlns:a16="http://schemas.microsoft.com/office/drawing/2014/main" id="{7961D1F9-2A20-4DCB-B42D-49E4B56E488C}"/>
               </a:ext>
             </a:extLst>
           </p:cNvPr>
@@ -11975,7 +12252,7 @@
           <p:cNvPr id="13" name="Rent and suppliers need payment">
             <a:extLst xmlns:a="http://schemas.openxmlformats.org/drawingml/2006/main">
               <a:ext uri="{FF2B5EF4-FFF2-40B4-BE49-F238E27FC236}">
-                <a16:creationId xmlns:a16="http://schemas.microsoft.com/office/drawing/2014/main" id="{AB352CC3-1075-41DD-90F9-9159A608A92E}"/>
+                <a16:creationId xmlns:a16="http://schemas.microsoft.com/office/drawing/2014/main" id="{00B31C29-6643-4210-8551-02B7FB7032C4}"/>
               </a:ext>
             </a:extLst>
           </p:cNvPr>
@@ -12066,7 +12343,7 @@
           <p:cNvPr id="16" name="The owner’s question">
             <a:extLst xmlns:a="http://schemas.openxmlformats.org/drawingml/2006/main">
               <a:ext uri="{FF2B5EF4-FFF2-40B4-BE49-F238E27FC236}">
-                <a16:creationId xmlns:a16="http://schemas.microsoft.com/office/drawing/2014/main" id="{EBE07B24-7DCA-4A78-BB05-3AC590899DB1}"/>
+                <a16:creationId xmlns:a16="http://schemas.microsoft.com/office/drawing/2014/main" id="{F6A92C15-CC05-467E-A4E4-16C5435368B7}"/>
               </a:ext>
             </a:extLst>
           </p:cNvPr>
@@ -12134,7 +12411,7 @@
           <p:cNvPr id="17" name="“Can I pay and restock?”">
             <a:extLst xmlns:a="http://schemas.openxmlformats.org/drawingml/2006/main">
               <a:ext uri="{FF2B5EF4-FFF2-40B4-BE49-F238E27FC236}">
-                <a16:creationId xmlns:a16="http://schemas.microsoft.com/office/drawing/2014/main" id="{FA932AA6-80CD-42D7-AFDA-BEA871CBCD32}"/>
+                <a16:creationId xmlns:a16="http://schemas.microsoft.com/office/drawing/2014/main" id="{AA75D83D-5887-447C-AEB2-729A2A11A8D1}"/>
               </a:ext>
             </a:extLst>
           </p:cNvPr>
@@ -12225,7 +12502,7 @@
           <p:cNvPr id="18" name="Section rule">
             <a:extLst xmlns:a="http://schemas.openxmlformats.org/drawingml/2006/main">
               <a:ext uri="{FF2B5EF4-FFF2-40B4-BE49-F238E27FC236}">
-                <a16:creationId xmlns:a16="http://schemas.microsoft.com/office/drawing/2014/main" id="{A5D96862-1D3D-4C36-B7EF-1FBFEDA18DB7}"/>
+                <a16:creationId xmlns:a16="http://schemas.microsoft.com/office/drawing/2014/main" id="{289D0B41-A712-4B2F-BBCC-C5BD2ECDD0E2}"/>
               </a:ext>
             </a:extLst>
           </p:cNvPr>
@@ -12255,7 +12532,7 @@
           <p:cNvPr id="19" name="Sales, stock and cash answer different questions.">
             <a:extLst xmlns:a="http://schemas.openxmlformats.org/drawingml/2006/main">
               <a:ext uri="{FF2B5EF4-FFF2-40B4-BE49-F238E27FC236}">
-                <a16:creationId xmlns:a16="http://schemas.microsoft.com/office/drawing/2014/main" id="{38D47F28-C924-45C4-8A28-25DEF4D4A73C}"/>
+                <a16:creationId xmlns:a16="http://schemas.microsoft.com/office/drawing/2014/main" id="{EFE4B658-C307-4287-A7E0-9409D949DA35}"/>
               </a:ext>
             </a:extLst>
           </p:cNvPr>
@@ -12323,7 +12600,7 @@
           <p:cNvPr id="20" name="The decision needs payment timing, financing terms and produ">
             <a:extLst xmlns:a="http://schemas.openxmlformats.org/drawingml/2006/main">
               <a:ext uri="{FF2B5EF4-FFF2-40B4-BE49-F238E27FC236}">
-                <a16:creationId xmlns:a16="http://schemas.microsoft.com/office/drawing/2014/main" id="{B598D0C6-EFD2-4801-BEBE-5DB15B16344E}"/>
+                <a16:creationId xmlns:a16="http://schemas.microsoft.com/office/drawing/2014/main" id="{75D7A8EC-C471-450D-91CF-B57EF4DB2689}"/>
               </a:ext>
             </a:extLst>
           </p:cNvPr>
@@ -12389,7 +12666,7 @@
     </p:spTree>
     <p:extLst>
       <p:ext uri="{BB962C8B-B14F-4D97-AF65-F5344CB8AC3E}">
-        <p14:creationId xmlns:p14="http://schemas.microsoft.com/office/powerpoint/2010/main" val="1256559149"/>
+        <p14:creationId xmlns:p14="http://schemas.microsoft.com/office/powerpoint/2010/main" val="578085584"/>
       </p:ext>
     </p:extLst>
   </p:cSld>
@@ -12420,7 +12697,7 @@
           <p:cNvPr id="13" name="BizWizard">
             <a:extLst xmlns:a="http://schemas.openxmlformats.org/drawingml/2006/main">
               <a:ext uri="{FF2B5EF4-FFF2-40B4-BE49-F238E27FC236}">
-                <a16:creationId xmlns:a16="http://schemas.microsoft.com/office/drawing/2014/main" id="{5C1846B8-ACE8-4956-AA3E-26E6B98A6971}"/>
+                <a16:creationId xmlns:a16="http://schemas.microsoft.com/office/drawing/2014/main" id="{BBD3CF00-E5D1-4040-BC7D-DAF9FE378708}"/>
               </a:ext>
             </a:extLst>
           </p:cNvPr>
@@ -12488,7 +12765,7 @@
           <p:cNvPr id="2" name="03">
             <a:extLst xmlns:a="http://schemas.openxmlformats.org/drawingml/2006/main">
               <a:ext uri="{FF2B5EF4-FFF2-40B4-BE49-F238E27FC236}">
-                <a16:creationId xmlns:a16="http://schemas.microsoft.com/office/drawing/2014/main" id="{33435572-4E93-4795-8933-9DC4EA40B193}"/>
+                <a16:creationId xmlns:a16="http://schemas.microsoft.com/office/drawing/2014/main" id="{E5B5E302-92A3-4C8E-A9A5-6175FEC38BB9}"/>
               </a:ext>
             </a:extLst>
           </p:cNvPr>
@@ -12556,7 +12833,7 @@
           <p:cNvPr id="3" name="Slide heading">
             <a:extLst xmlns:a="http://schemas.openxmlformats.org/drawingml/2006/main">
               <a:ext uri="{FF2B5EF4-FFF2-40B4-BE49-F238E27FC236}">
-                <a16:creationId xmlns:a16="http://schemas.microsoft.com/office/drawing/2014/main" id="{C86CE4CA-36D1-48DF-B1A2-C813326F782F}"/>
+                <a16:creationId xmlns:a16="http://schemas.microsoft.com/office/drawing/2014/main" id="{5DB27BE5-9132-437A-BEF0-FA017A2236E9}"/>
               </a:ext>
             </a:extLst>
           </p:cNvPr>
@@ -12624,7 +12901,7 @@
           <p:cNvPr id="4" name="Which financing fits?">
             <a:extLst xmlns:a="http://schemas.openxmlformats.org/drawingml/2006/main">
               <a:ext uri="{FF2B5EF4-FFF2-40B4-BE49-F238E27FC236}">
-                <a16:creationId xmlns:a16="http://schemas.microsoft.com/office/drawing/2014/main" id="{3896D2BC-D1CA-4EC0-8E35-BF163A34CCE5}"/>
+                <a16:creationId xmlns:a16="http://schemas.microsoft.com/office/drawing/2014/main" id="{3BC9EB9D-F39C-4E39-92DF-FC2C94C8DAFA}"/>
               </a:ext>
             </a:extLst>
           </p:cNvPr>
@@ -12692,7 +12969,7 @@
           <p:cNvPr id="5" name="Compare eligibility, cost and repayment capacity.">
             <a:extLst xmlns:a="http://schemas.openxmlformats.org/drawingml/2006/main">
               <a:ext uri="{FF2B5EF4-FFF2-40B4-BE49-F238E27FC236}">
-                <a16:creationId xmlns:a16="http://schemas.microsoft.com/office/drawing/2014/main" id="{30B308BC-946D-49A6-97B0-E2AAA1892A52}"/>
+                <a16:creationId xmlns:a16="http://schemas.microsoft.com/office/drawing/2014/main" id="{886326DB-9CF4-40D0-8C48-162F61F4D515}"/>
               </a:ext>
             </a:extLst>
           </p:cNvPr>
@@ -12783,7 +13060,7 @@
           <p:cNvPr id="6" name="Will cash run short?">
             <a:extLst xmlns:a="http://schemas.openxmlformats.org/drawingml/2006/main">
               <a:ext uri="{FF2B5EF4-FFF2-40B4-BE49-F238E27FC236}">
-                <a16:creationId xmlns:a16="http://schemas.microsoft.com/office/drawing/2014/main" id="{5E907727-6702-4EE4-A5C7-14BD7EB106AE}"/>
+                <a16:creationId xmlns:a16="http://schemas.microsoft.com/office/drawing/2014/main" id="{7C379A2A-045A-456C-9970-DDAE6B4ADCAC}"/>
               </a:ext>
             </a:extLst>
           </p:cNvPr>
@@ -12851,7 +13128,7 @@
           <p:cNvPr id="7" name="Project dated balances and review alerts.">
             <a:extLst xmlns:a="http://schemas.openxmlformats.org/drawingml/2006/main">
               <a:ext uri="{FF2B5EF4-FFF2-40B4-BE49-F238E27FC236}">
-                <a16:creationId xmlns:a16="http://schemas.microsoft.com/office/drawing/2014/main" id="{736A29AF-9EE5-450B-BE24-65F3207E4C2D}"/>
+                <a16:creationId xmlns:a16="http://schemas.microsoft.com/office/drawing/2014/main" id="{3F3B639C-4258-4DBB-8269-CC05CCC19F42}"/>
               </a:ext>
             </a:extLst>
           </p:cNvPr>
@@ -12942,7 +13219,7 @@
           <p:cNvPr id="8" name="Where is cash tied up?">
             <a:extLst xmlns:a="http://schemas.openxmlformats.org/drawingml/2006/main">
               <a:ext uri="{FF2B5EF4-FFF2-40B4-BE49-F238E27FC236}">
-                <a16:creationId xmlns:a16="http://schemas.microsoft.com/office/drawing/2014/main" id="{EE966902-BC2B-4627-84D2-956C3108F3FF}"/>
+                <a16:creationId xmlns:a16="http://schemas.microsoft.com/office/drawing/2014/main" id="{3F60327D-522B-4EBE-B863-7274DA96C5D7}"/>
               </a:ext>
             </a:extLst>
           </p:cNvPr>
@@ -13010,7 +13287,7 @@
           <p:cNvPr id="9" name="Inspect product margins and working capital.">
             <a:extLst xmlns:a="http://schemas.openxmlformats.org/drawingml/2006/main">
               <a:ext uri="{FF2B5EF4-FFF2-40B4-BE49-F238E27FC236}">
-                <a16:creationId xmlns:a16="http://schemas.microsoft.com/office/drawing/2014/main" id="{6095820D-1942-4149-AA46-C615161EE31A}"/>
+                <a16:creationId xmlns:a16="http://schemas.microsoft.com/office/drawing/2014/main" id="{BE047EB2-0E48-4F2A-88E5-0705D0B066EC}"/>
               </a:ext>
             </a:extLst>
           </p:cNvPr>
@@ -13101,7 +13378,7 @@
           <p:cNvPr id="10" name="">
             <a:extLst xmlns:a="http://schemas.openxmlformats.org/drawingml/2006/main">
               <a:ext uri="{FF2B5EF4-FFF2-40B4-BE49-F238E27FC236}">
-                <a16:creationId xmlns:a16="http://schemas.microsoft.com/office/drawing/2014/main" id="{55EDE245-D91D-42C7-AFCF-AD96C4AFE79C}"/>
+                <a16:creationId xmlns:a16="http://schemas.microsoft.com/office/drawing/2014/main" id="{64F3ECF4-DD88-4335-A46B-D90BCE5B1106}"/>
               </a:ext>
             </a:extLst>
           </p:cNvPr>
@@ -13111,7 +13388,7 @@
           <p:nvPr/>
         </p:nvPicPr>
         <p:blipFill>
-          <a:blip xmlns:r="http://schemas.openxmlformats.org/officeDocument/2006/relationships" xmlns:a="http://schemas.openxmlformats.org/drawingml/2006/main" r:embed="R561934d884ec46f7"/>
+          <a:blip xmlns:r="http://schemas.openxmlformats.org/officeDocument/2006/relationships" xmlns:a="http://schemas.openxmlformats.org/drawingml/2006/main" r:embed="R4db7aff1e51443b4"/>
           <a:stretch xmlns:a="http://schemas.openxmlformats.org/drawingml/2006/main"/>
         </p:blipFill>
         <p:spPr>
@@ -13129,7 +13406,7 @@
           <p:cNvPr id="11" name="">
             <a:extLst xmlns:a="http://schemas.openxmlformats.org/drawingml/2006/main">
               <a:ext uri="{FF2B5EF4-FFF2-40B4-BE49-F238E27FC236}">
-                <a16:creationId xmlns:a16="http://schemas.microsoft.com/office/drawing/2014/main" id="{DCA0861D-3DBA-4EAE-A47F-8C3AC102F7A8}"/>
+                <a16:creationId xmlns:a16="http://schemas.microsoft.com/office/drawing/2014/main" id="{1678FEAB-C235-4CE7-ACA3-5C8EE4322739}"/>
               </a:ext>
             </a:extLst>
           </p:cNvPr>
@@ -13139,7 +13416,7 @@
           <p:nvPr/>
         </p:nvPicPr>
         <p:blipFill>
-          <a:blip xmlns:r="http://schemas.openxmlformats.org/officeDocument/2006/relationships" xmlns:a="http://schemas.openxmlformats.org/drawingml/2006/main" r:embed="R876ac1effd6946a4"/>
+          <a:blip xmlns:r="http://schemas.openxmlformats.org/officeDocument/2006/relationships" xmlns:a="http://schemas.openxmlformats.org/drawingml/2006/main" r:embed="R19e501a84382480a"/>
           <a:stretch xmlns:a="http://schemas.openxmlformats.org/drawingml/2006/main"/>
         </p:blipFill>
         <p:spPr>
@@ -13157,7 +13434,7 @@
           <p:cNvPr id="12" name="Existing shop records feed the finance workflows. Screens sh">
             <a:extLst xmlns:a="http://schemas.openxmlformats.org/drawingml/2006/main">
               <a:ext uri="{FF2B5EF4-FFF2-40B4-BE49-F238E27FC236}">
-                <a16:creationId xmlns:a16="http://schemas.microsoft.com/office/drawing/2014/main" id="{468BE3EB-FB53-405D-AA0A-9C523C8AD6A7}"/>
+                <a16:creationId xmlns:a16="http://schemas.microsoft.com/office/drawing/2014/main" id="{1BDD69B2-F217-417E-B7E6-9110155D7B3D}"/>
               </a:ext>
             </a:extLst>
           </p:cNvPr>
@@ -13223,7 +13500,7 @@
     </p:spTree>
     <p:extLst>
       <p:ext uri="{BB962C8B-B14F-4D97-AF65-F5344CB8AC3E}">
-        <p14:creationId xmlns:p14="http://schemas.microsoft.com/office/powerpoint/2010/main" val="1658363524"/>
+        <p14:creationId xmlns:p14="http://schemas.microsoft.com/office/powerpoint/2010/main" val="568039812"/>
       </p:ext>
     </p:extLst>
   </p:cSld>
@@ -13254,7 +13531,7 @@
           <p:cNvPr id="22" name="">
             <a:extLst xmlns:a="http://schemas.openxmlformats.org/drawingml/2006/main">
               <a:ext uri="{FF2B5EF4-FFF2-40B4-BE49-F238E27FC236}">
-                <a16:creationId xmlns:a16="http://schemas.microsoft.com/office/drawing/2014/main" id="{61940418-DA97-4FDC-BDB0-BDA67A1C7041}"/>
+                <a16:creationId xmlns:a16="http://schemas.microsoft.com/office/drawing/2014/main" id="{E602BA68-1F5A-4D96-B42D-606D725EEEF3}"/>
               </a:ext>
             </a:extLst>
           </p:cNvPr>
@@ -13286,7 +13563,7 @@
           <p:cNvPr id="21" name="">
             <a:extLst xmlns:a="http://schemas.openxmlformats.org/drawingml/2006/main">
               <a:ext uri="{FF2B5EF4-FFF2-40B4-BE49-F238E27FC236}">
-                <a16:creationId xmlns:a16="http://schemas.microsoft.com/office/drawing/2014/main" id="{F4166191-0945-4505-8F84-0AD6A18DE941}"/>
+                <a16:creationId xmlns:a16="http://schemas.microsoft.com/office/drawing/2014/main" id="{646A2C82-42FE-40F9-B011-8B1C871345D7}"/>
               </a:ext>
             </a:extLst>
           </p:cNvPr>
@@ -13318,7 +13595,7 @@
           <p:cNvPr id="20" name="">
             <a:extLst xmlns:a="http://schemas.openxmlformats.org/drawingml/2006/main">
               <a:ext uri="{FF2B5EF4-FFF2-40B4-BE49-F238E27FC236}">
-                <a16:creationId xmlns:a16="http://schemas.microsoft.com/office/drawing/2014/main" id="{5DB95715-7C60-4F28-B84E-640C803AF5B1}"/>
+                <a16:creationId xmlns:a16="http://schemas.microsoft.com/office/drawing/2014/main" id="{31123DB2-2202-43AB-B70E-F23351DA6396}"/>
               </a:ext>
             </a:extLst>
           </p:cNvPr>
@@ -13350,7 +13627,7 @@
           <p:cNvPr id="19" name="">
             <a:extLst xmlns:a="http://schemas.openxmlformats.org/drawingml/2006/main">
               <a:ext uri="{FF2B5EF4-FFF2-40B4-BE49-F238E27FC236}">
-                <a16:creationId xmlns:a16="http://schemas.microsoft.com/office/drawing/2014/main" id="{62A6BAAC-48B1-468C-A005-8CF3B8537D70}"/>
+                <a16:creationId xmlns:a16="http://schemas.microsoft.com/office/drawing/2014/main" id="{0FE8BDD0-FE6E-47F4-95E2-5AF8DB4E1179}"/>
               </a:ext>
             </a:extLst>
           </p:cNvPr>
@@ -13382,7 +13659,7 @@
           <p:cNvPr id="26" name="BizWizard">
             <a:extLst xmlns:a="http://schemas.openxmlformats.org/drawingml/2006/main">
               <a:ext uri="{FF2B5EF4-FFF2-40B4-BE49-F238E27FC236}">
-                <a16:creationId xmlns:a16="http://schemas.microsoft.com/office/drawing/2014/main" id="{A8FE2A2B-13CA-40AD-9687-EAD50313C3F5}"/>
+                <a16:creationId xmlns:a16="http://schemas.microsoft.com/office/drawing/2014/main" id="{BD93117D-F46B-44B2-BEE2-9D26CB82AEC7}"/>
               </a:ext>
             </a:extLst>
           </p:cNvPr>
@@ -13450,7 +13727,7 @@
           <p:cNvPr id="2" name="04">
             <a:extLst xmlns:a="http://schemas.openxmlformats.org/drawingml/2006/main">
               <a:ext uri="{FF2B5EF4-FFF2-40B4-BE49-F238E27FC236}">
-                <a16:creationId xmlns:a16="http://schemas.microsoft.com/office/drawing/2014/main" id="{75E0B193-16B6-4A31-B8A2-7F3006FD5FC5}"/>
+                <a16:creationId xmlns:a16="http://schemas.microsoft.com/office/drawing/2014/main" id="{7B0D3466-FB2C-41EF-9F53-ADB0EC1C4790}"/>
               </a:ext>
             </a:extLst>
           </p:cNvPr>
@@ -13518,7 +13795,7 @@
           <p:cNvPr id="3" name="Slide heading">
             <a:extLst xmlns:a="http://schemas.openxmlformats.org/drawingml/2006/main">
               <a:ext uri="{FF2B5EF4-FFF2-40B4-BE49-F238E27FC236}">
-                <a16:creationId xmlns:a16="http://schemas.microsoft.com/office/drawing/2014/main" id="{C66110C4-00EF-4EDF-8557-075294068FCB}"/>
+                <a16:creationId xmlns:a16="http://schemas.microsoft.com/office/drawing/2014/main" id="{82D34B0C-46CB-4517-88FC-DEC4558B0D55}"/>
               </a:ext>
             </a:extLst>
           </p:cNvPr>
@@ -13586,7 +13863,7 @@
           <p:cNvPr id="4" name="Shop records">
             <a:extLst xmlns:a="http://schemas.openxmlformats.org/drawingml/2006/main">
               <a:ext uri="{FF2B5EF4-FFF2-40B4-BE49-F238E27FC236}">
-                <a16:creationId xmlns:a16="http://schemas.microsoft.com/office/drawing/2014/main" id="{52DE37A3-8193-460F-82B6-19CA052FAD4D}"/>
+                <a16:creationId xmlns:a16="http://schemas.microsoft.com/office/drawing/2014/main" id="{02F2A8ED-0494-49E4-BFE4-6A544F8BB92D}"/>
               </a:ext>
             </a:extLst>
           </p:cNvPr>
@@ -13618,7 +13895,7 @@
           <p:cNvPr id="5" name="Shop records">
             <a:extLst xmlns:a="http://schemas.openxmlformats.org/drawingml/2006/main">
               <a:ext uri="{FF2B5EF4-FFF2-40B4-BE49-F238E27FC236}">
-                <a16:creationId xmlns:a16="http://schemas.microsoft.com/office/drawing/2014/main" id="{0E8B8866-A334-482C-BBE4-AA997615BAB3}"/>
+                <a16:creationId xmlns:a16="http://schemas.microsoft.com/office/drawing/2014/main" id="{40F508D8-004E-40E4-ABF1-46AF2A40D714}"/>
               </a:ext>
             </a:extLst>
           </p:cNvPr>
@@ -13686,7 +13963,7 @@
           <p:cNvPr id="6" name="Sales, debt, stock and expenses">
             <a:extLst xmlns:a="http://schemas.openxmlformats.org/drawingml/2006/main">
               <a:ext uri="{FF2B5EF4-FFF2-40B4-BE49-F238E27FC236}">
-                <a16:creationId xmlns:a16="http://schemas.microsoft.com/office/drawing/2014/main" id="{77AE9689-863E-407B-BBD1-C8F36BD7AF4E}"/>
+                <a16:creationId xmlns:a16="http://schemas.microsoft.com/office/drawing/2014/main" id="{7AA19AF6-26EB-4C20-AFDB-2EDC5B72D48F}"/>
               </a:ext>
             </a:extLst>
           </p:cNvPr>
@@ -13777,7 +14054,7 @@
           <p:cNvPr id="7" name="Finance engines">
             <a:extLst xmlns:a="http://schemas.openxmlformats.org/drawingml/2006/main">
               <a:ext uri="{FF2B5EF4-FFF2-40B4-BE49-F238E27FC236}">
-                <a16:creationId xmlns:a16="http://schemas.microsoft.com/office/drawing/2014/main" id="{3C3BEC82-CC9E-42CA-A461-7ED434EB65F0}"/>
+                <a16:creationId xmlns:a16="http://schemas.microsoft.com/office/drawing/2014/main" id="{78A67C4F-E423-4CED-B79B-53D452FD45ED}"/>
               </a:ext>
             </a:extLst>
           </p:cNvPr>
@@ -13809,7 +14086,7 @@
           <p:cNvPr id="8" name="Finance engines">
             <a:extLst xmlns:a="http://schemas.openxmlformats.org/drawingml/2006/main">
               <a:ext uri="{FF2B5EF4-FFF2-40B4-BE49-F238E27FC236}">
-                <a16:creationId xmlns:a16="http://schemas.microsoft.com/office/drawing/2014/main" id="{331C7813-3A71-4710-9F63-11345EA8EC91}"/>
+                <a16:creationId xmlns:a16="http://schemas.microsoft.com/office/drawing/2014/main" id="{1C2BBDBB-DBE7-4783-A988-1A0A2930C4F2}"/>
               </a:ext>
             </a:extLst>
           </p:cNvPr>
@@ -13877,7 +14154,7 @@
           <p:cNvPr id="9" name="Cash forecast, metrics and eligibility">
             <a:extLst xmlns:a="http://schemas.openxmlformats.org/drawingml/2006/main">
               <a:ext uri="{FF2B5EF4-FFF2-40B4-BE49-F238E27FC236}">
-                <a16:creationId xmlns:a16="http://schemas.microsoft.com/office/drawing/2014/main" id="{445445E3-694F-4E45-9233-5DE17CF7742C}"/>
+                <a16:creationId xmlns:a16="http://schemas.microsoft.com/office/drawing/2014/main" id="{207D8437-AFBB-4D21-96E2-9525CDB19704}"/>
               </a:ext>
             </a:extLst>
           </p:cNvPr>
@@ -13968,7 +14245,7 @@
           <p:cNvPr id="10" name="AI choice">
             <a:extLst xmlns:a="http://schemas.openxmlformats.org/drawingml/2006/main">
               <a:ext uri="{FF2B5EF4-FFF2-40B4-BE49-F238E27FC236}">
-                <a16:creationId xmlns:a16="http://schemas.microsoft.com/office/drawing/2014/main" id="{FB7C8AE7-59D4-43B7-B3C0-748AF5467965}"/>
+                <a16:creationId xmlns:a16="http://schemas.microsoft.com/office/drawing/2014/main" id="{61C12860-6378-43C5-B5C0-D19821C6E5EE}"/>
               </a:ext>
             </a:extLst>
           </p:cNvPr>
@@ -14000,7 +14277,7 @@
           <p:cNvPr id="11" name="AI choice">
             <a:extLst xmlns:a="http://schemas.openxmlformats.org/drawingml/2006/main">
               <a:ext uri="{FF2B5EF4-FFF2-40B4-BE49-F238E27FC236}">
-                <a16:creationId xmlns:a16="http://schemas.microsoft.com/office/drawing/2014/main" id="{F822025B-35C5-4F89-B820-589720A22D1B}"/>
+                <a16:creationId xmlns:a16="http://schemas.microsoft.com/office/drawing/2014/main" id="{CC532B57-A400-414D-8A71-5C8430D93451}"/>
               </a:ext>
             </a:extLst>
           </p:cNvPr>
@@ -14068,7 +14345,7 @@
           <p:cNvPr id="12" name="Select or explain allowed options">
             <a:extLst xmlns:a="http://schemas.openxmlformats.org/drawingml/2006/main">
               <a:ext uri="{FF2B5EF4-FFF2-40B4-BE49-F238E27FC236}">
-                <a16:creationId xmlns:a16="http://schemas.microsoft.com/office/drawing/2014/main" id="{D671E59C-DD9F-4BD0-BE7B-6A2AF66FBE99}"/>
+                <a16:creationId xmlns:a16="http://schemas.microsoft.com/office/drawing/2014/main" id="{36E74FAF-E581-4FCA-BA6B-9957B22FBF94}"/>
               </a:ext>
             </a:extLst>
           </p:cNvPr>
@@ -14159,7 +14436,7 @@
           <p:cNvPr id="13" name="Owner review">
             <a:extLst xmlns:a="http://schemas.openxmlformats.org/drawingml/2006/main">
               <a:ext uri="{FF2B5EF4-FFF2-40B4-BE49-F238E27FC236}">
-                <a16:creationId xmlns:a16="http://schemas.microsoft.com/office/drawing/2014/main" id="{5783F45C-16D3-433F-ADB1-D2BC97968D0C}"/>
+                <a16:creationId xmlns:a16="http://schemas.microsoft.com/office/drawing/2014/main" id="{06BB97C3-355B-4889-B40B-09A94EF2EA74}"/>
               </a:ext>
             </a:extLst>
           </p:cNvPr>
@@ -14191,7 +14468,7 @@
           <p:cNvPr id="14" name="Owner review">
             <a:extLst xmlns:a="http://schemas.openxmlformats.org/drawingml/2006/main">
               <a:ext uri="{FF2B5EF4-FFF2-40B4-BE49-F238E27FC236}">
-                <a16:creationId xmlns:a16="http://schemas.microsoft.com/office/drawing/2014/main" id="{C1085855-9933-4FDB-84F9-CE8A1BF54677}"/>
+                <a16:creationId xmlns:a16="http://schemas.microsoft.com/office/drawing/2014/main" id="{D52A307E-62BC-4B33-A043-8847E91D05F7}"/>
               </a:ext>
             </a:extLst>
           </p:cNvPr>
@@ -14259,7 +14536,7 @@
           <p:cNvPr id="15" name="Approve or reject a proposed plan">
             <a:extLst xmlns:a="http://schemas.openxmlformats.org/drawingml/2006/main">
               <a:ext uri="{FF2B5EF4-FFF2-40B4-BE49-F238E27FC236}">
-                <a16:creationId xmlns:a16="http://schemas.microsoft.com/office/drawing/2014/main" id="{27777D7F-4B7A-4DF9-98B1-3829D06A941F}"/>
+                <a16:creationId xmlns:a16="http://schemas.microsoft.com/office/drawing/2014/main" id="{EE035374-B42A-4FE9-A31F-273A6EFAC7C2}"/>
               </a:ext>
             </a:extLst>
           </p:cNvPr>
@@ -14350,7 +14627,7 @@
           <p:cNvPr id="16" name="Outcome record">
             <a:extLst xmlns:a="http://schemas.openxmlformats.org/drawingml/2006/main">
               <a:ext uri="{FF2B5EF4-FFF2-40B4-BE49-F238E27FC236}">
-                <a16:creationId xmlns:a16="http://schemas.microsoft.com/office/drawing/2014/main" id="{557607F5-DE0B-430F-BADC-DA7621CD5BFE}"/>
+                <a16:creationId xmlns:a16="http://schemas.microsoft.com/office/drawing/2014/main" id="{1FB77848-FDF3-4744-AD3B-98AC75FFEB84}"/>
               </a:ext>
             </a:extLst>
           </p:cNvPr>
@@ -14382,7 +14659,7 @@
           <p:cNvPr id="17" name="Outcome record">
             <a:extLst xmlns:a="http://schemas.openxmlformats.org/drawingml/2006/main">
               <a:ext uri="{FF2B5EF4-FFF2-40B4-BE49-F238E27FC236}">
-                <a16:creationId xmlns:a16="http://schemas.microsoft.com/office/drawing/2014/main" id="{103EFC8D-F5F9-4A24-A5AC-4736DCB3812E}"/>
+                <a16:creationId xmlns:a16="http://schemas.microsoft.com/office/drawing/2014/main" id="{9B60FA61-78D4-4FE8-92D1-E9574190F7B4}"/>
               </a:ext>
             </a:extLst>
           </p:cNvPr>
@@ -14450,7 +14727,7 @@
           <p:cNvPr id="18" name="Link recorded events and inspect results">
             <a:extLst xmlns:a="http://schemas.openxmlformats.org/drawingml/2006/main">
               <a:ext uri="{FF2B5EF4-FFF2-40B4-BE49-F238E27FC236}">
-                <a16:creationId xmlns:a16="http://schemas.microsoft.com/office/drawing/2014/main" id="{28F1B8A4-664B-4324-8130-A398A90067FB}"/>
+                <a16:creationId xmlns:a16="http://schemas.microsoft.com/office/drawing/2014/main" id="{B7A888E2-FD86-4B24-9102-01E2E04C98EC}"/>
               </a:ext>
             </a:extLst>
           </p:cNvPr>
@@ -14541,7 +14818,7 @@
           <p:cNvPr id="23" name="Example: overdue customer payment">
             <a:extLst xmlns:a="http://schemas.openxmlformats.org/drawingml/2006/main">
               <a:ext uri="{FF2B5EF4-FFF2-40B4-BE49-F238E27FC236}">
-                <a16:creationId xmlns:a16="http://schemas.microsoft.com/office/drawing/2014/main" id="{19B0197D-E634-42FB-8DBF-9EBBA6041A7A}"/>
+                <a16:creationId xmlns:a16="http://schemas.microsoft.com/office/drawing/2014/main" id="{5AAB8A53-38D2-49C3-A061-973A78A496DD}"/>
               </a:ext>
             </a:extLst>
           </p:cNvPr>
@@ -14609,7 +14886,7 @@
           <p:cNvPr id="24" name="A cash alert leads to a proposed collection plan. The owner ">
             <a:extLst xmlns:a="http://schemas.openxmlformats.org/drawingml/2006/main">
               <a:ext uri="{FF2B5EF4-FFF2-40B4-BE49-F238E27FC236}">
-                <a16:creationId xmlns:a16="http://schemas.microsoft.com/office/drawing/2014/main" id="{846092E3-6096-45C9-A179-44DE0F513A44}"/>
+                <a16:creationId xmlns:a16="http://schemas.microsoft.com/office/drawing/2014/main" id="{AABB51C5-C436-4215-9306-A4D44B4CC5CB}"/>
               </a:ext>
             </a:extLst>
           </p:cNvPr>
@@ -14700,7 +14977,7 @@
           <p:cNvPr id="25" name="Approval records a decision. The application does not execut">
             <a:extLst xmlns:a="http://schemas.openxmlformats.org/drawingml/2006/main">
               <a:ext uri="{FF2B5EF4-FFF2-40B4-BE49-F238E27FC236}">
-                <a16:creationId xmlns:a16="http://schemas.microsoft.com/office/drawing/2014/main" id="{3BBEF3A0-280F-4291-A4C1-98E46B75C1D3}"/>
+                <a16:creationId xmlns:a16="http://schemas.microsoft.com/office/drawing/2014/main" id="{385ADCBD-7E56-4841-B05E-A55BC73E9DA3}"/>
               </a:ext>
             </a:extLst>
           </p:cNvPr>
@@ -14766,7 +15043,7 @@
     </p:spTree>
     <p:extLst>
       <p:ext uri="{BB962C8B-B14F-4D97-AF65-F5344CB8AC3E}">
-        <p14:creationId xmlns:p14="http://schemas.microsoft.com/office/powerpoint/2010/main" val="1305696459"/>
+        <p14:creationId xmlns:p14="http://schemas.microsoft.com/office/powerpoint/2010/main" val="1358093222"/>
       </p:ext>
     </p:extLst>
   </p:cSld>
@@ -14797,7 +15074,7 @@
           <p:cNvPr id="12" name="BizWizard">
             <a:extLst xmlns:a="http://schemas.openxmlformats.org/drawingml/2006/main">
               <a:ext uri="{FF2B5EF4-FFF2-40B4-BE49-F238E27FC236}">
-                <a16:creationId xmlns:a16="http://schemas.microsoft.com/office/drawing/2014/main" id="{A0BCF7AA-73D2-4B5D-9326-8C04C04B7461}"/>
+                <a16:creationId xmlns:a16="http://schemas.microsoft.com/office/drawing/2014/main" id="{DC3486D2-ECA6-4AB5-8014-28824F00D17C}"/>
               </a:ext>
             </a:extLst>
           </p:cNvPr>
@@ -14865,7 +15142,7 @@
           <p:cNvPr id="2" name="05">
             <a:extLst xmlns:a="http://schemas.openxmlformats.org/drawingml/2006/main">
               <a:ext uri="{FF2B5EF4-FFF2-40B4-BE49-F238E27FC236}">
-                <a16:creationId xmlns:a16="http://schemas.microsoft.com/office/drawing/2014/main" id="{CB70E806-9468-4A67-922D-71AC409D5183}"/>
+                <a16:creationId xmlns:a16="http://schemas.microsoft.com/office/drawing/2014/main" id="{6E739E6B-BF97-49C1-8A14-CCCF36B01F86}"/>
               </a:ext>
             </a:extLst>
           </p:cNvPr>
@@ -14933,7 +15210,7 @@
           <p:cNvPr id="3" name="Slide heading">
             <a:extLst xmlns:a="http://schemas.openxmlformats.org/drawingml/2006/main">
               <a:ext uri="{FF2B5EF4-FFF2-40B4-BE49-F238E27FC236}">
-                <a16:creationId xmlns:a16="http://schemas.microsoft.com/office/drawing/2014/main" id="{C9D51FE1-C459-43F9-A6E7-42B5191F365A}"/>
+                <a16:creationId xmlns:a16="http://schemas.microsoft.com/office/drawing/2014/main" id="{ECBB0FEC-C0E7-45DE-BCD9-56DDF317B1A4}"/>
               </a:ext>
             </a:extLst>
           </p:cNvPr>
@@ -15001,7 +15278,7 @@
           <p:cNvPr id="4" name="1 Check eligibility">
             <a:extLst xmlns:a="http://schemas.openxmlformats.org/drawingml/2006/main">
               <a:ext uri="{FF2B5EF4-FFF2-40B4-BE49-F238E27FC236}">
-                <a16:creationId xmlns:a16="http://schemas.microsoft.com/office/drawing/2014/main" id="{5E711AF8-7FAF-4E87-8992-42076D534421}"/>
+                <a16:creationId xmlns:a16="http://schemas.microsoft.com/office/drawing/2014/main" id="{1150A1EE-173A-4CC2-850B-E157D524A8F4}"/>
               </a:ext>
             </a:extLst>
           </p:cNvPr>
@@ -15069,7 +15346,7 @@
           <p:cNvPr id="5" name="Rules screen amount, tenor and business requirements.">
             <a:extLst xmlns:a="http://schemas.openxmlformats.org/drawingml/2006/main">
               <a:ext uri="{FF2B5EF4-FFF2-40B4-BE49-F238E27FC236}">
-                <a16:creationId xmlns:a16="http://schemas.microsoft.com/office/drawing/2014/main" id="{4F6B2E44-9C93-40D5-BD06-F26850EA5010}"/>
+                <a16:creationId xmlns:a16="http://schemas.microsoft.com/office/drawing/2014/main" id="{11387621-F4CA-45E3-9E9B-FEBC740D101D}"/>
               </a:ext>
             </a:extLst>
           </p:cNvPr>
@@ -15160,7 +15437,7 @@
           <p:cNvPr id="6" name="2 Compare feasible options">
             <a:extLst xmlns:a="http://schemas.openxmlformats.org/drawingml/2006/main">
               <a:ext uri="{FF2B5EF4-FFF2-40B4-BE49-F238E27FC236}">
-                <a16:creationId xmlns:a16="http://schemas.microsoft.com/office/drawing/2014/main" id="{29A1A0EF-8A12-4D77-A475-2FEEAA2DC945}"/>
+                <a16:creationId xmlns:a16="http://schemas.microsoft.com/office/drawing/2014/main" id="{DD89CEA6-DAC4-4422-8EDF-BC187AF9E7E7}"/>
               </a:ext>
             </a:extLst>
           </p:cNvPr>
@@ -15228,7 +15505,7 @@
           <p:cNvPr id="7" name="AI can enrich the ranking. Code prices the offer.">
             <a:extLst xmlns:a="http://schemas.openxmlformats.org/drawingml/2006/main">
               <a:ext uri="{FF2B5EF4-FFF2-40B4-BE49-F238E27FC236}">
-                <a16:creationId xmlns:a16="http://schemas.microsoft.com/office/drawing/2014/main" id="{490E8BBB-0A7D-4B81-A883-5F7934F5022D}"/>
+                <a16:creationId xmlns:a16="http://schemas.microsoft.com/office/drawing/2014/main" id="{E9438653-6F19-46FF-A2D3-6000267E7260}"/>
               </a:ext>
             </a:extLst>
           </p:cNvPr>
@@ -15319,7 +15596,7 @@
           <p:cNvPr id="8" name="3 Review the terms">
             <a:extLst xmlns:a="http://schemas.openxmlformats.org/drawingml/2006/main">
               <a:ext uri="{FF2B5EF4-FFF2-40B4-BE49-F238E27FC236}">
-                <a16:creationId xmlns:a16="http://schemas.microsoft.com/office/drawing/2014/main" id="{3A282774-42CC-43C9-8CC4-4AB33D89C926}"/>
+                <a16:creationId xmlns:a16="http://schemas.microsoft.com/office/drawing/2014/main" id="{1369661E-4D9F-4A4B-B52F-0A7189980407}"/>
               </a:ext>
             </a:extLst>
           </p:cNvPr>
@@ -15387,7 +15664,7 @@
           <p:cNvPr id="9" name="Deterministic policies negotiate for up to three rounds.">
             <a:extLst xmlns:a="http://schemas.openxmlformats.org/drawingml/2006/main">
               <a:ext uri="{FF2B5EF4-FFF2-40B4-BE49-F238E27FC236}">
-                <a16:creationId xmlns:a16="http://schemas.microsoft.com/office/drawing/2014/main" id="{60F4F367-F9FC-4544-A71F-C1D70BFE7E64}"/>
+                <a16:creationId xmlns:a16="http://schemas.microsoft.com/office/drawing/2014/main" id="{956DCA34-F3B2-4EBD-A3CA-EAA9EC29E881}"/>
               </a:ext>
             </a:extLst>
           </p:cNvPr>
@@ -15478,7 +15755,7 @@
           <p:cNvPr id="10" name="">
             <a:extLst xmlns:a="http://schemas.openxmlformats.org/drawingml/2006/main">
               <a:ext uri="{FF2B5EF4-FFF2-40B4-BE49-F238E27FC236}">
-                <a16:creationId xmlns:a16="http://schemas.microsoft.com/office/drawing/2014/main" id="{576CFE3A-DF06-4764-89A7-4A56ACACC542}"/>
+                <a16:creationId xmlns:a16="http://schemas.microsoft.com/office/drawing/2014/main" id="{E698AA22-AA7B-4342-94DB-0DD98A1925C7}"/>
               </a:ext>
             </a:extLst>
           </p:cNvPr>
@@ -15488,7 +15765,7 @@
           <p:nvPr/>
         </p:nvPicPr>
         <p:blipFill>
-          <a:blip xmlns:r="http://schemas.openxmlformats.org/officeDocument/2006/relationships" xmlns:a="http://schemas.openxmlformats.org/drawingml/2006/main" r:embed="R8addd21bf24c49ce"/>
+          <a:blip xmlns:r="http://schemas.openxmlformats.org/officeDocument/2006/relationships" xmlns:a="http://schemas.openxmlformats.org/drawingml/2006/main" r:embed="R21973b29cb6e4f7a"/>
           <a:stretch xmlns:a="http://schemas.openxmlformats.org/drawingml/2006/main"/>
         </p:blipFill>
         <p:spPr>
@@ -15506,7 +15783,7 @@
           <p:cNvPr id="11" name="Simulated lenders only. Acceptance creates an application an">
             <a:extLst xmlns:a="http://schemas.openxmlformats.org/drawingml/2006/main">
               <a:ext uri="{FF2B5EF4-FFF2-40B4-BE49-F238E27FC236}">
-                <a16:creationId xmlns:a16="http://schemas.microsoft.com/office/drawing/2014/main" id="{FF09DBBE-6D3E-41B4-8355-2C282DC53AC5}"/>
+                <a16:creationId xmlns:a16="http://schemas.microsoft.com/office/drawing/2014/main" id="{05668E4A-8BA4-411F-B467-144D8B63B1D1}"/>
               </a:ext>
             </a:extLst>
           </p:cNvPr>
@@ -15572,7 +15849,7 @@
     </p:spTree>
     <p:extLst>
       <p:ext uri="{BB962C8B-B14F-4D97-AF65-F5344CB8AC3E}">
-        <p14:creationId xmlns:p14="http://schemas.microsoft.com/office/powerpoint/2010/main" val="1797367431"/>
+        <p14:creationId xmlns:p14="http://schemas.microsoft.com/office/powerpoint/2010/main" val="77944555"/>
       </p:ext>
     </p:extLst>
   </p:cSld>
@@ -15603,7 +15880,7 @@
           <p:cNvPr id="12" name="BizWizard">
             <a:extLst xmlns:a="http://schemas.openxmlformats.org/drawingml/2006/main">
               <a:ext uri="{FF2B5EF4-FFF2-40B4-BE49-F238E27FC236}">
-                <a16:creationId xmlns:a16="http://schemas.microsoft.com/office/drawing/2014/main" id="{FE9613D3-EAF4-4520-94BB-A5B6C8D33E44}"/>
+                <a16:creationId xmlns:a16="http://schemas.microsoft.com/office/drawing/2014/main" id="{39BD59DE-223E-4F8A-A817-1C418C9946A0}"/>
               </a:ext>
             </a:extLst>
           </p:cNvPr>
@@ -15671,7 +15948,7 @@
           <p:cNvPr id="2" name="06">
             <a:extLst xmlns:a="http://schemas.openxmlformats.org/drawingml/2006/main">
               <a:ext uri="{FF2B5EF4-FFF2-40B4-BE49-F238E27FC236}">
-                <a16:creationId xmlns:a16="http://schemas.microsoft.com/office/drawing/2014/main" id="{FAB3153D-1409-4DD7-9735-9A044E1BC478}"/>
+                <a16:creationId xmlns:a16="http://schemas.microsoft.com/office/drawing/2014/main" id="{14326C7D-1826-4694-8C70-FB0DB98AB93D}"/>
               </a:ext>
             </a:extLst>
           </p:cNvPr>
@@ -15739,7 +16016,7 @@
           <p:cNvPr id="3" name="Slide heading">
             <a:extLst xmlns:a="http://schemas.openxmlformats.org/drawingml/2006/main">
               <a:ext uri="{FF2B5EF4-FFF2-40B4-BE49-F238E27FC236}">
-                <a16:creationId xmlns:a16="http://schemas.microsoft.com/office/drawing/2014/main" id="{C02FB203-A633-477A-85CF-55FBBF752DE4}"/>
+                <a16:creationId xmlns:a16="http://schemas.microsoft.com/office/drawing/2014/main" id="{4B9CE396-3127-4243-AC3E-852C7CEE3536}"/>
               </a:ext>
             </a:extLst>
           </p:cNvPr>
@@ -15807,7 +16084,7 @@
           <p:cNvPr id="4" name="">
             <a:extLst xmlns:a="http://schemas.openxmlformats.org/drawingml/2006/main">
               <a:ext uri="{FF2B5EF4-FFF2-40B4-BE49-F238E27FC236}">
-                <a16:creationId xmlns:a16="http://schemas.microsoft.com/office/drawing/2014/main" id="{B901E013-F350-49E7-AF53-90F5E2AF2D57}"/>
+                <a16:creationId xmlns:a16="http://schemas.microsoft.com/office/drawing/2014/main" id="{6DCA3160-5B12-4D5F-9080-17BE7FCE15E2}"/>
               </a:ext>
             </a:extLst>
           </p:cNvPr>
@@ -15817,7 +16094,7 @@
           <p:nvPr/>
         </p:nvPicPr>
         <p:blipFill>
-          <a:blip xmlns:r="http://schemas.openxmlformats.org/officeDocument/2006/relationships" xmlns:a="http://schemas.openxmlformats.org/drawingml/2006/main" r:embed="Rb4451bddf5f544fc"/>
+          <a:blip xmlns:r="http://schemas.openxmlformats.org/officeDocument/2006/relationships" xmlns:a="http://schemas.openxmlformats.org/drawingml/2006/main" r:embed="R20f154b9b4fb441c"/>
           <a:stretch xmlns:a="http://schemas.openxmlformats.org/drawingml/2006/main"/>
         </p:blipFill>
         <p:spPr>
@@ -15835,7 +16112,7 @@
           <p:cNvPr id="5" name="90-day projection">
             <a:extLst xmlns:a="http://schemas.openxmlformats.org/drawingml/2006/main">
               <a:ext uri="{FF2B5EF4-FFF2-40B4-BE49-F238E27FC236}">
-                <a16:creationId xmlns:a16="http://schemas.microsoft.com/office/drawing/2014/main" id="{88DFF0B0-D02F-41CB-BD2E-2C2A0DC17898}"/>
+                <a16:creationId xmlns:a16="http://schemas.microsoft.com/office/drawing/2014/main" id="{F0E65873-03CA-4623-8104-C558B546A9BB}"/>
               </a:ext>
             </a:extLst>
           </p:cNvPr>
@@ -15903,7 +16180,7 @@
           <p:cNvPr id="6" name="History, dated commitments and weighted receivables.">
             <a:extLst xmlns:a="http://schemas.openxmlformats.org/drawingml/2006/main">
               <a:ext uri="{FF2B5EF4-FFF2-40B4-BE49-F238E27FC236}">
-                <a16:creationId xmlns:a16="http://schemas.microsoft.com/office/drawing/2014/main" id="{8291DAE8-844C-4EBC-BD6D-D698D5CB4D2D}"/>
+                <a16:creationId xmlns:a16="http://schemas.microsoft.com/office/drawing/2014/main" id="{40E788AB-1588-4FD6-8753-061112C4CCE6}"/>
               </a:ext>
             </a:extLst>
           </p:cNvPr>
@@ -15994,7 +16271,7 @@
           <p:cNvPr id="7" name="Nine alert conditions">
             <a:extLst xmlns:a="http://schemas.openxmlformats.org/drawingml/2006/main">
               <a:ext uri="{FF2B5EF4-FFF2-40B4-BE49-F238E27FC236}">
-                <a16:creationId xmlns:a16="http://schemas.microsoft.com/office/drawing/2014/main" id="{AB540957-23DD-4F8A-A1DD-C3209EC7AE99}"/>
+                <a16:creationId xmlns:a16="http://schemas.microsoft.com/office/drawing/2014/main" id="{16C3F0DB-8EDE-4143-BC72-214F311F97A6}"/>
               </a:ext>
             </a:extLst>
           </p:cNvPr>
@@ -16062,7 +16339,7 @@
           <p:cNvPr id="8" name="Shortfalls, cash buffers, aging debt and unusual costs.">
             <a:extLst xmlns:a="http://schemas.openxmlformats.org/drawingml/2006/main">
               <a:ext uri="{FF2B5EF4-FFF2-40B4-BE49-F238E27FC236}">
-                <a16:creationId xmlns:a16="http://schemas.microsoft.com/office/drawing/2014/main" id="{121CE733-B37D-4D52-B741-805864F9C32B}"/>
+                <a16:creationId xmlns:a16="http://schemas.microsoft.com/office/drawing/2014/main" id="{F5F8DC22-D736-49C0-A8C5-B6EB5493ACB2}"/>
               </a:ext>
             </a:extLst>
           </p:cNvPr>
@@ -16153,7 +16430,7 @@
           <p:cNvPr id="9" name="A reviewable next step">
             <a:extLst xmlns:a="http://schemas.openxmlformats.org/drawingml/2006/main">
               <a:ext uri="{FF2B5EF4-FFF2-40B4-BE49-F238E27FC236}">
-                <a16:creationId xmlns:a16="http://schemas.microsoft.com/office/drawing/2014/main" id="{1A60171A-A83E-499B-9904-9B503E7FC9C2}"/>
+                <a16:creationId xmlns:a16="http://schemas.microsoft.com/office/drawing/2014/main" id="{3C6C7A6F-4303-4474-B559-2BD4761B1030}"/>
               </a:ext>
             </a:extLst>
           </p:cNvPr>
@@ -16221,7 +16498,7 @@
           <p:cNvPr id="10" name="The owner can inspect a plan before approving it.">
             <a:extLst xmlns:a="http://schemas.openxmlformats.org/drawingml/2006/main">
               <a:ext uri="{FF2B5EF4-FFF2-40B4-BE49-F238E27FC236}">
-                <a16:creationId xmlns:a16="http://schemas.microsoft.com/office/drawing/2014/main" id="{DC79B34D-27E6-4456-A744-B94F18A0B8CB}"/>
+                <a16:creationId xmlns:a16="http://schemas.microsoft.com/office/drawing/2014/main" id="{473E72FA-2A25-4342-939E-39224B7145BB}"/>
               </a:ext>
             </a:extLst>
           </p:cNvPr>
@@ -16312,7 +16589,7 @@
           <p:cNvPr id="11" name="Illustrative demo data. Projected cash and proposed actions ">
             <a:extLst xmlns:a="http://schemas.openxmlformats.org/drawingml/2006/main">
               <a:ext uri="{FF2B5EF4-FFF2-40B4-BE49-F238E27FC236}">
-                <a16:creationId xmlns:a16="http://schemas.microsoft.com/office/drawing/2014/main" id="{41F748B5-3870-4EBE-842C-8346A4112ED8}"/>
+                <a16:creationId xmlns:a16="http://schemas.microsoft.com/office/drawing/2014/main" id="{2AB061AD-9CCE-4679-BCA7-C2EE19C39EB0}"/>
               </a:ext>
             </a:extLst>
           </p:cNvPr>
@@ -16378,7 +16655,7 @@
     </p:spTree>
     <p:extLst>
       <p:ext uri="{BB962C8B-B14F-4D97-AF65-F5344CB8AC3E}">
-        <p14:creationId xmlns:p14="http://schemas.microsoft.com/office/powerpoint/2010/main" val="1137616585"/>
+        <p14:creationId xmlns:p14="http://schemas.microsoft.com/office/powerpoint/2010/main" val="1356003592"/>
       </p:ext>
     </p:extLst>
   </p:cSld>
@@ -16409,7 +16686,7 @@
           <p:cNvPr id="11" name="BizWizard">
             <a:extLst xmlns:a="http://schemas.openxmlformats.org/drawingml/2006/main">
               <a:ext uri="{FF2B5EF4-FFF2-40B4-BE49-F238E27FC236}">
-                <a16:creationId xmlns:a16="http://schemas.microsoft.com/office/drawing/2014/main" id="{421EF0CF-F2FC-4A9D-89FA-0E78909EDC90}"/>
+                <a16:creationId xmlns:a16="http://schemas.microsoft.com/office/drawing/2014/main" id="{199177AD-CAD7-4D53-918D-907A46589105}"/>
               </a:ext>
             </a:extLst>
           </p:cNvPr>
@@ -16477,7 +16754,7 @@
           <p:cNvPr id="2" name="07">
             <a:extLst xmlns:a="http://schemas.openxmlformats.org/drawingml/2006/main">
               <a:ext uri="{FF2B5EF4-FFF2-40B4-BE49-F238E27FC236}">
-                <a16:creationId xmlns:a16="http://schemas.microsoft.com/office/drawing/2014/main" id="{61490C73-63D3-41D1-BFB0-8DCF1A8F0FED}"/>
+                <a16:creationId xmlns:a16="http://schemas.microsoft.com/office/drawing/2014/main" id="{120C1ECA-7C88-4F8C-842B-AF475131AEF2}"/>
               </a:ext>
             </a:extLst>
           </p:cNvPr>
@@ -16545,7 +16822,7 @@
           <p:cNvPr id="3" name="Slide heading">
             <a:extLst xmlns:a="http://schemas.openxmlformats.org/drawingml/2006/main">
               <a:ext uri="{FF2B5EF4-FFF2-40B4-BE49-F238E27FC236}">
-                <a16:creationId xmlns:a16="http://schemas.microsoft.com/office/drawing/2014/main" id="{8B42186E-EC3B-48A7-B61A-B4D6711BF420}"/>
+                <a16:creationId xmlns:a16="http://schemas.microsoft.com/office/drawing/2014/main" id="{600D3510-2D96-4B0F-B143-886B61FC1632}"/>
               </a:ext>
             </a:extLst>
           </p:cNvPr>
@@ -16613,7 +16890,7 @@
           <p:cNvPr id="4" name="">
             <a:extLst xmlns:a="http://schemas.openxmlformats.org/drawingml/2006/main">
               <a:ext uri="{FF2B5EF4-FFF2-40B4-BE49-F238E27FC236}">
-                <a16:creationId xmlns:a16="http://schemas.microsoft.com/office/drawing/2014/main" id="{090EB531-62C4-46AC-BA7E-92B8E06F3D91}"/>
+                <a16:creationId xmlns:a16="http://schemas.microsoft.com/office/drawing/2014/main" id="{C9382D5A-4E56-43EC-995D-8C57B8687ED7}"/>
               </a:ext>
             </a:extLst>
           </p:cNvPr>
@@ -16623,7 +16900,7 @@
           <p:nvPr/>
         </p:nvPicPr>
         <p:blipFill>
-          <a:blip xmlns:r="http://schemas.openxmlformats.org/officeDocument/2006/relationships" xmlns:a="http://schemas.openxmlformats.org/drawingml/2006/main" r:embed="R50748e91c0fa4993"/>
+          <a:blip xmlns:r="http://schemas.openxmlformats.org/officeDocument/2006/relationships" xmlns:a="http://schemas.openxmlformats.org/drawingml/2006/main" r:embed="R481be6843a7a46df"/>
           <a:stretch xmlns:a="http://schemas.openxmlformats.org/drawingml/2006/main"/>
         </p:blipFill>
         <p:spPr>
@@ -16641,7 +16918,7 @@
           <p:cNvPr id="5" name="Candidate explanation">
             <a:extLst xmlns:a="http://schemas.openxmlformats.org/drawingml/2006/main">
               <a:ext uri="{FF2B5EF4-FFF2-40B4-BE49-F238E27FC236}">
-                <a16:creationId xmlns:a16="http://schemas.microsoft.com/office/drawing/2014/main" id="{D2A76BA2-2F79-47E1-84F3-72DF343389C4}"/>
+                <a16:creationId xmlns:a16="http://schemas.microsoft.com/office/drawing/2014/main" id="{7CC84576-EF33-4157-AA2E-B08EF8BAAB33}"/>
               </a:ext>
             </a:extLst>
           </p:cNvPr>
@@ -16709,7 +16986,7 @@
           <p:cNvPr id="6" name="Check the contribution to the observed gap">
             <a:extLst xmlns:a="http://schemas.openxmlformats.org/drawingml/2006/main">
               <a:ext uri="{FF2B5EF4-FFF2-40B4-BE49-F238E27FC236}">
-                <a16:creationId xmlns:a16="http://schemas.microsoft.com/office/drawing/2014/main" id="{305626D2-D437-4DBC-B843-46F8EB4E484E}"/>
+                <a16:creationId xmlns:a16="http://schemas.microsoft.com/office/drawing/2014/main" id="{7F0C0151-FF9A-4D94-B2B5-9B982BEDE590}"/>
               </a:ext>
             </a:extLst>
           </p:cNvPr>
@@ -16800,7 +17077,7 @@
           <p:cNvPr id="7" name="Residual gap ≤10%">
             <a:extLst xmlns:a="http://schemas.openxmlformats.org/drawingml/2006/main">
               <a:ext uri="{FF2B5EF4-FFF2-40B4-BE49-F238E27FC236}">
-                <a16:creationId xmlns:a16="http://schemas.microsoft.com/office/drawing/2014/main" id="{BD5DC6F9-4C8F-455A-AA4C-D4E0F814B24C}"/>
+                <a16:creationId xmlns:a16="http://schemas.microsoft.com/office/drawing/2014/main" id="{07A9F6C5-6F51-497F-8ADB-70F8BF722443}"/>
               </a:ext>
             </a:extLst>
           </p:cNvPr>
@@ -16868,7 +17145,7 @@
           <p:cNvPr id="8" name="Accounting attribution supports the “verified” label.">
             <a:extLst xmlns:a="http://schemas.openxmlformats.org/drawingml/2006/main">
               <a:ext uri="{FF2B5EF4-FFF2-40B4-BE49-F238E27FC236}">
-                <a16:creationId xmlns:a16="http://schemas.microsoft.com/office/drawing/2014/main" id="{5657927C-8A79-450F-9E89-CFE1E51A0A81}"/>
+                <a16:creationId xmlns:a16="http://schemas.microsoft.com/office/drawing/2014/main" id="{38907AF4-4AB3-4295-916E-6C14A4D0D2F2}"/>
               </a:ext>
             </a:extLst>
           </p:cNvPr>
@@ -16959,7 +17236,7 @@
           <p:cNvPr id="9" name="Scenarios explore changes before the owner commits.">
             <a:extLst xmlns:a="http://schemas.openxmlformats.org/drawingml/2006/main">
               <a:ext uri="{FF2B5EF4-FFF2-40B4-BE49-F238E27FC236}">
-                <a16:creationId xmlns:a16="http://schemas.microsoft.com/office/drawing/2014/main" id="{8BE70B2D-7BB4-4D28-9A48-85342BCD8F42}"/>
+                <a16:creationId xmlns:a16="http://schemas.microsoft.com/office/drawing/2014/main" id="{BB21E7E1-D405-4BEB-850D-83B46052C348}"/>
               </a:ext>
             </a:extLst>
           </p:cNvPr>
@@ -17050,7 +17327,7 @@
           <p:cNvPr id="10" name="Illustrative demo data. Verification checks accounting consi">
             <a:extLst xmlns:a="http://schemas.openxmlformats.org/drawingml/2006/main">
               <a:ext uri="{FF2B5EF4-FFF2-40B4-BE49-F238E27FC236}">
-                <a16:creationId xmlns:a16="http://schemas.microsoft.com/office/drawing/2014/main" id="{5B9FBFC5-14E5-47A7-9C6C-59F4FFB44ADE}"/>
+                <a16:creationId xmlns:a16="http://schemas.microsoft.com/office/drawing/2014/main" id="{8987D6CB-689E-4C66-BACD-EBAF61252615}"/>
               </a:ext>
             </a:extLst>
           </p:cNvPr>
@@ -17116,7 +17393,7 @@
     </p:spTree>
     <p:extLst>
       <p:ext uri="{BB962C8B-B14F-4D97-AF65-F5344CB8AC3E}">
-        <p14:creationId xmlns:p14="http://schemas.microsoft.com/office/powerpoint/2010/main" val="556848403"/>
+        <p14:creationId xmlns:p14="http://schemas.microsoft.com/office/powerpoint/2010/main" val="225229746"/>
       </p:ext>
     </p:extLst>
   </p:cSld>
@@ -17147,7 +17424,7 @@
           <p:cNvPr id="25" name="">
             <a:extLst xmlns:a="http://schemas.openxmlformats.org/drawingml/2006/main">
               <a:ext uri="{FF2B5EF4-FFF2-40B4-BE49-F238E27FC236}">
-                <a16:creationId xmlns:a16="http://schemas.microsoft.com/office/drawing/2014/main" id="{5996D56F-6D60-4367-9E85-37A4DFD56B84}"/>
+                <a16:creationId xmlns:a16="http://schemas.microsoft.com/office/drawing/2014/main" id="{422CEF2E-BFB1-4041-BE67-4BE3C55517A2}"/>
               </a:ext>
             </a:extLst>
           </p:cNvPr>
@@ -17179,7 +17456,7 @@
           <p:cNvPr id="24" name="">
             <a:extLst xmlns:a="http://schemas.openxmlformats.org/drawingml/2006/main">
               <a:ext uri="{FF2B5EF4-FFF2-40B4-BE49-F238E27FC236}">
-                <a16:creationId xmlns:a16="http://schemas.microsoft.com/office/drawing/2014/main" id="{A1C8FF38-90A0-4032-86ED-417B6E5D601C}"/>
+                <a16:creationId xmlns:a16="http://schemas.microsoft.com/office/drawing/2014/main" id="{70EF7A84-83CB-49EE-B7AA-817FFE05D9DC}"/>
               </a:ext>
             </a:extLst>
           </p:cNvPr>
@@ -17211,7 +17488,7 @@
           <p:cNvPr id="23" name="">
             <a:extLst xmlns:a="http://schemas.openxmlformats.org/drawingml/2006/main">
               <a:ext uri="{FF2B5EF4-FFF2-40B4-BE49-F238E27FC236}">
-                <a16:creationId xmlns:a16="http://schemas.microsoft.com/office/drawing/2014/main" id="{A4981D86-1E45-42B5-99EE-32809CFAA5B8}"/>
+                <a16:creationId xmlns:a16="http://schemas.microsoft.com/office/drawing/2014/main" id="{56038159-FFEC-485E-A6D0-E2C9E7595BBA}"/>
               </a:ext>
             </a:extLst>
           </p:cNvPr>
@@ -17243,7 +17520,7 @@
           <p:cNvPr id="22" name="">
             <a:extLst xmlns:a="http://schemas.openxmlformats.org/drawingml/2006/main">
               <a:ext uri="{FF2B5EF4-FFF2-40B4-BE49-F238E27FC236}">
-                <a16:creationId xmlns:a16="http://schemas.microsoft.com/office/drawing/2014/main" id="{19573EF4-7F67-4970-9F30-E20C189E1A8F}"/>
+                <a16:creationId xmlns:a16="http://schemas.microsoft.com/office/drawing/2014/main" id="{CB9AF240-D8B6-4B5C-BFEF-C398D6E4C96B}"/>
               </a:ext>
             </a:extLst>
           </p:cNvPr>
@@ -17275,7 +17552,7 @@
           <p:cNvPr id="32" name="BizWizard">
             <a:extLst xmlns:a="http://schemas.openxmlformats.org/drawingml/2006/main">
               <a:ext uri="{FF2B5EF4-FFF2-40B4-BE49-F238E27FC236}">
-                <a16:creationId xmlns:a16="http://schemas.microsoft.com/office/drawing/2014/main" id="{D5FD7B52-A1A4-42FA-8449-3D004155E9D8}"/>
+                <a16:creationId xmlns:a16="http://schemas.microsoft.com/office/drawing/2014/main" id="{1D2E68BF-6002-4A19-9C13-78D0FD3B50F7}"/>
               </a:ext>
             </a:extLst>
           </p:cNvPr>
@@ -17343,7 +17620,7 @@
           <p:cNvPr id="2" name="08">
             <a:extLst xmlns:a="http://schemas.openxmlformats.org/drawingml/2006/main">
               <a:ext uri="{FF2B5EF4-FFF2-40B4-BE49-F238E27FC236}">
-                <a16:creationId xmlns:a16="http://schemas.microsoft.com/office/drawing/2014/main" id="{AC5B7BD4-3CE2-44BB-80A3-77F3F3C40839}"/>
+                <a16:creationId xmlns:a16="http://schemas.microsoft.com/office/drawing/2014/main" id="{786AE710-18B4-442B-B143-4EF58F691E6C}"/>
               </a:ext>
             </a:extLst>
           </p:cNvPr>
@@ -17411,7 +17688,7 @@
           <p:cNvPr id="3" name="Slide heading">
             <a:extLst xmlns:a="http://schemas.openxmlformats.org/drawingml/2006/main">
               <a:ext uri="{FF2B5EF4-FFF2-40B4-BE49-F238E27FC236}">
-                <a16:creationId xmlns:a16="http://schemas.microsoft.com/office/drawing/2014/main" id="{1224513D-129B-42A1-9A28-F72A15964285}"/>
+                <a16:creationId xmlns:a16="http://schemas.microsoft.com/office/drawing/2014/main" id="{0D00678E-786C-48A1-A4F3-E4CF2B2CFD4D}"/>
               </a:ext>
             </a:extLst>
           </p:cNvPr>
@@ -17479,7 +17756,7 @@
           <p:cNvPr id="4" name="Next.js frontend">
             <a:extLst xmlns:a="http://schemas.openxmlformats.org/drawingml/2006/main">
               <a:ext uri="{FF2B5EF4-FFF2-40B4-BE49-F238E27FC236}">
-                <a16:creationId xmlns:a16="http://schemas.microsoft.com/office/drawing/2014/main" id="{D186A3F7-1239-41D9-B847-EA87A84712B1}"/>
+                <a16:creationId xmlns:a16="http://schemas.microsoft.com/office/drawing/2014/main" id="{F69B948C-1F23-4FF9-9B05-FA178BF8165B}"/>
               </a:ext>
             </a:extLst>
           </p:cNvPr>
@@ -17511,7 +17788,7 @@
           <p:cNvPr id="5" name="Next.js frontend">
             <a:extLst xmlns:a="http://schemas.openxmlformats.org/drawingml/2006/main">
               <a:ext uri="{FF2B5EF4-FFF2-40B4-BE49-F238E27FC236}">
-                <a16:creationId xmlns:a16="http://schemas.microsoft.com/office/drawing/2014/main" id="{1FFD5306-D751-415E-935F-D805E1A40382}"/>
+                <a16:creationId xmlns:a16="http://schemas.microsoft.com/office/drawing/2014/main" id="{118BA1AE-84E9-4140-96B2-5A93663F1C35}"/>
               </a:ext>
             </a:extLst>
           </p:cNvPr>
@@ -17579,7 +17856,7 @@
           <p:cNvPr id="6" name="React / Tailwind Vercel deployment">
             <a:extLst xmlns:a="http://schemas.openxmlformats.org/drawingml/2006/main">
               <a:ext uri="{FF2B5EF4-FFF2-40B4-BE49-F238E27FC236}">
-                <a16:creationId xmlns:a16="http://schemas.microsoft.com/office/drawing/2014/main" id="{A2C4AA68-2116-4881-96B1-21B22FE8DCB5}"/>
+                <a16:creationId xmlns:a16="http://schemas.microsoft.com/office/drawing/2014/main" id="{9B7A223F-B748-447F-8C6C-CB4DE18773A5}"/>
               </a:ext>
             </a:extLst>
           </p:cNvPr>
@@ -17670,7 +17947,7 @@
           <p:cNvPr id="7" name="Express API">
             <a:extLst xmlns:a="http://schemas.openxmlformats.org/drawingml/2006/main">
               <a:ext uri="{FF2B5EF4-FFF2-40B4-BE49-F238E27FC236}">
-                <a16:creationId xmlns:a16="http://schemas.microsoft.com/office/drawing/2014/main" id="{E6EF25F0-43B1-405A-ACD2-45E7A77765AD}"/>
+                <a16:creationId xmlns:a16="http://schemas.microsoft.com/office/drawing/2014/main" id="{3F05FCB3-BA52-4C80-B55A-5D60B9DC857B}"/>
               </a:ext>
             </a:extLst>
           </p:cNvPr>
@@ -17702,7 +17979,7 @@
           <p:cNvPr id="8" name="Express API">
             <a:extLst xmlns:a="http://schemas.openxmlformats.org/drawingml/2006/main">
               <a:ext uri="{FF2B5EF4-FFF2-40B4-BE49-F238E27FC236}">
-                <a16:creationId xmlns:a16="http://schemas.microsoft.com/office/drawing/2014/main" id="{CE8F0E6D-C626-4EDE-AD75-B2479D597592}"/>
+                <a16:creationId xmlns:a16="http://schemas.microsoft.com/office/drawing/2014/main" id="{9796AEB6-4067-4FAE-A170-DC48B10FF95D}"/>
               </a:ext>
             </a:extLst>
           </p:cNvPr>
@@ -17770,7 +18047,7 @@
           <p:cNvPr id="9" name="JWT, roles and scope Request validation">
             <a:extLst xmlns:a="http://schemas.openxmlformats.org/drawingml/2006/main">
               <a:ext uri="{FF2B5EF4-FFF2-40B4-BE49-F238E27FC236}">
-                <a16:creationId xmlns:a16="http://schemas.microsoft.com/office/drawing/2014/main" id="{87647F6A-64DD-44C9-B2A2-CBAE76A282E5}"/>
+                <a16:creationId xmlns:a16="http://schemas.microsoft.com/office/drawing/2014/main" id="{26D7FD32-5D46-4493-9308-16AF08DA79C9}"/>
               </a:ext>
             </a:extLst>
           </p:cNvPr>
@@ -17861,7 +18138,7 @@
           <p:cNvPr id="10" name="PostgreSQL">
             <a:extLst xmlns:a="http://schemas.openxmlformats.org/drawingml/2006/main">
               <a:ext uri="{FF2B5EF4-FFF2-40B4-BE49-F238E27FC236}">
-                <a16:creationId xmlns:a16="http://schemas.microsoft.com/office/drawing/2014/main" id="{54FDE856-238D-4895-89D7-CB76AA3BA626}"/>
+                <a16:creationId xmlns:a16="http://schemas.microsoft.com/office/drawing/2014/main" id="{DC20298B-71A0-4BFD-88D5-84E881836D31}"/>
               </a:ext>
             </a:extLst>
           </p:cNvPr>
@@ -17893,7 +18170,7 @@
           <p:cNvPr id="11" name="PostgreSQL">
             <a:extLst xmlns:a="http://schemas.openxmlformats.org/drawingml/2006/main">
               <a:ext uri="{FF2B5EF4-FFF2-40B4-BE49-F238E27FC236}">
-                <a16:creationId xmlns:a16="http://schemas.microsoft.com/office/drawing/2014/main" id="{C4ECA7B7-12FB-4CC4-AE12-1EFAF707C7A5}"/>
+                <a16:creationId xmlns:a16="http://schemas.microsoft.com/office/drawing/2014/main" id="{25DD0FA2-B4E3-4FCA-8C4C-1C464879C042}"/>
               </a:ext>
             </a:extLst>
           </p:cNvPr>
@@ -17961,7 +18238,7 @@
           <p:cNvPr id="12" name="Prisma migrations Scoped business records">
             <a:extLst xmlns:a="http://schemas.openxmlformats.org/drawingml/2006/main">
               <a:ext uri="{FF2B5EF4-FFF2-40B4-BE49-F238E27FC236}">
-                <a16:creationId xmlns:a16="http://schemas.microsoft.com/office/drawing/2014/main" id="{299C7C81-A296-4AF5-B0B7-7F21B84865A5}"/>
+                <a16:creationId xmlns:a16="http://schemas.microsoft.com/office/drawing/2014/main" id="{591BC7B3-6FF9-4727-B6A6-CA674D99C11E}"/>
               </a:ext>
             </a:extLst>
           </p:cNvPr>
@@ -18052,7 +18329,7 @@
           <p:cNvPr id="13" name="Finance engines">
             <a:extLst xmlns:a="http://schemas.openxmlformats.org/drawingml/2006/main">
               <a:ext uri="{FF2B5EF4-FFF2-40B4-BE49-F238E27FC236}">
-                <a16:creationId xmlns:a16="http://schemas.microsoft.com/office/drawing/2014/main" id="{190F64F7-E02E-4E03-A748-04160BF576C6}"/>
+                <a16:creationId xmlns:a16="http://schemas.microsoft.com/office/drawing/2014/main" id="{C02EA491-954B-40CC-8853-616103970283}"/>
               </a:ext>
             </a:extLst>
           </p:cNvPr>
@@ -18084,7 +18361,7 @@
           <p:cNvPr id="14" name="Finance engines">
             <a:extLst xmlns:a="http://schemas.openxmlformats.org/drawingml/2006/main">
               <a:ext uri="{FF2B5EF4-FFF2-40B4-BE49-F238E27FC236}">
-                <a16:creationId xmlns:a16="http://schemas.microsoft.com/office/drawing/2014/main" id="{2691FA11-1673-45AF-851F-00611F69FD23}"/>
+                <a16:creationId xmlns:a16="http://schemas.microsoft.com/office/drawing/2014/main" id="{710F1FF6-5616-4CF0-A40B-2900674487F6}"/>
               </a:ext>
             </a:extLst>
           </p:cNvPr>
@@ -18152,7 +18429,7 @@
           <p:cNvPr id="15" name="Calculations, forecasts and financial guards">
             <a:extLst xmlns:a="http://schemas.openxmlformats.org/drawingml/2006/main">
               <a:ext uri="{FF2B5EF4-FFF2-40B4-BE49-F238E27FC236}">
-                <a16:creationId xmlns:a16="http://schemas.microsoft.com/office/drawing/2014/main" id="{2378375F-D213-4CE0-A8D5-9B5D5208787C}"/>
+                <a16:creationId xmlns:a16="http://schemas.microsoft.com/office/drawing/2014/main" id="{5A4BC3AB-2FAF-4BDE-AA9A-014745E8133B}"/>
               </a:ext>
             </a:extLst>
           </p:cNvPr>
@@ -18243,7 +18520,7 @@
           <p:cNvPr id="16" name="AI runtime">
             <a:extLst xmlns:a="http://schemas.openxmlformats.org/drawingml/2006/main">
               <a:ext uri="{FF2B5EF4-FFF2-40B4-BE49-F238E27FC236}">
-                <a16:creationId xmlns:a16="http://schemas.microsoft.com/office/drawing/2014/main" id="{893FC0AB-DD44-4851-A3E2-AF8982EE43FC}"/>
+                <a16:creationId xmlns:a16="http://schemas.microsoft.com/office/drawing/2014/main" id="{8F7DD285-27C2-4751-872D-C57F183F673C}"/>
               </a:ext>
             </a:extLst>
           </p:cNvPr>
@@ -18275,7 +18552,7 @@
           <p:cNvPr id="17" name="AI runtime">
             <a:extLst xmlns:a="http://schemas.openxmlformats.org/drawingml/2006/main">
               <a:ext uri="{FF2B5EF4-FFF2-40B4-BE49-F238E27FC236}">
-                <a16:creationId xmlns:a16="http://schemas.microsoft.com/office/drawing/2014/main" id="{07672956-F7BF-44BA-B29D-E4E436904617}"/>
+                <a16:creationId xmlns:a16="http://schemas.microsoft.com/office/drawing/2014/main" id="{CB1120E4-48A9-4B7D-A408-087ACCA210A3}"/>
               </a:ext>
             </a:extLst>
           </p:cNvPr>
@@ -18343,7 +18620,7 @@
           <p:cNvPr id="18" name="Structured JSON Budget and fallback">
             <a:extLst xmlns:a="http://schemas.openxmlformats.org/drawingml/2006/main">
               <a:ext uri="{FF2B5EF4-FFF2-40B4-BE49-F238E27FC236}">
-                <a16:creationId xmlns:a16="http://schemas.microsoft.com/office/drawing/2014/main" id="{A21AB269-C7F6-4521-9DE3-1F926509ECB0}"/>
+                <a16:creationId xmlns:a16="http://schemas.microsoft.com/office/drawing/2014/main" id="{E67F1835-8734-4BED-AC48-856E07A6C7D5}"/>
               </a:ext>
             </a:extLst>
           </p:cNvPr>
@@ -18434,7 +18711,7 @@
           <p:cNvPr id="19" name="Optional OpenAI">
             <a:extLst xmlns:a="http://schemas.openxmlformats.org/drawingml/2006/main">
               <a:ext uri="{FF2B5EF4-FFF2-40B4-BE49-F238E27FC236}">
-                <a16:creationId xmlns:a16="http://schemas.microsoft.com/office/drawing/2014/main" id="{848C9B33-6D13-4E6B-9B10-DC577C1210CB}"/>
+                <a16:creationId xmlns:a16="http://schemas.microsoft.com/office/drawing/2014/main" id="{6EC024BA-4351-4D22-8F45-C2FF266AF55C}"/>
               </a:ext>
             </a:extLst>
           </p:cNvPr>
@@ -18466,7 +18743,7 @@
           <p:cNvPr id="20" name="Optional OpenAI">
             <a:extLst xmlns:a="http://schemas.openxmlformats.org/drawingml/2006/main">
               <a:ext uri="{FF2B5EF4-FFF2-40B4-BE49-F238E27FC236}">
-                <a16:creationId xmlns:a16="http://schemas.microsoft.com/office/drawing/2014/main" id="{A276E745-162E-4761-857F-062962D96662}"/>
+                <a16:creationId xmlns:a16="http://schemas.microsoft.com/office/drawing/2014/main" id="{62214A98-F73E-482B-8988-67DAC454C08B}"/>
               </a:ext>
             </a:extLst>
           </p:cNvPr>
@@ -18534,7 +18811,7 @@
           <p:cNvPr id="21" name="Select or explain constrained options">
             <a:extLst xmlns:a="http://schemas.openxmlformats.org/drawingml/2006/main">
               <a:ext uri="{FF2B5EF4-FFF2-40B4-BE49-F238E27FC236}">
-                <a16:creationId xmlns:a16="http://schemas.microsoft.com/office/drawing/2014/main" id="{60730D12-5545-43BD-8F9E-3EB509F66718}"/>
+                <a16:creationId xmlns:a16="http://schemas.microsoft.com/office/drawing/2014/main" id="{B4954445-005C-4DA2-93ED-439A90DF4EA3}"/>
               </a:ext>
             </a:extLst>
           </p:cNvPr>
@@ -18625,7 +18902,7 @@
           <p:cNvPr id="26" name="API to finance engines">
             <a:extLst xmlns:a="http://schemas.openxmlformats.org/drawingml/2006/main">
               <a:ext uri="{FF2B5EF4-FFF2-40B4-BE49-F238E27FC236}">
-                <a16:creationId xmlns:a16="http://schemas.microsoft.com/office/drawing/2014/main" id="{D7631231-0F63-4A63-BEF5-AC6532371D2D}"/>
+                <a16:creationId xmlns:a16="http://schemas.microsoft.com/office/drawing/2014/main" id="{1ABA486F-7F56-4A88-A574-9E1BC031CB51}"/>
               </a:ext>
             </a:extLst>
           </p:cNvPr>
@@ -18652,7 +18929,7 @@
           <p:cNvPr id="27" name="API to finance engines">
             <a:extLst xmlns:a="http://schemas.openxmlformats.org/drawingml/2006/main">
               <a:ext uri="{FF2B5EF4-FFF2-40B4-BE49-F238E27FC236}">
-                <a16:creationId xmlns:a16="http://schemas.microsoft.com/office/drawing/2014/main" id="{76C42F75-6C2C-4538-9415-7BCDDAB85BD2}"/>
+                <a16:creationId xmlns:a16="http://schemas.microsoft.com/office/drawing/2014/main" id="{2A6CAA4E-D6A2-49A1-8FC0-957A5DE1258C}"/>
               </a:ext>
             </a:extLst>
           </p:cNvPr>
@@ -18679,7 +18956,7 @@
           <p:cNvPr id="28" name="API to finance engines">
             <a:extLst xmlns:a="http://schemas.openxmlformats.org/drawingml/2006/main">
               <a:ext uri="{FF2B5EF4-FFF2-40B4-BE49-F238E27FC236}">
-                <a16:creationId xmlns:a16="http://schemas.microsoft.com/office/drawing/2014/main" id="{60F4BE38-AC7E-421C-9A21-08E4427AFDBF}"/>
+                <a16:creationId xmlns:a16="http://schemas.microsoft.com/office/drawing/2014/main" id="{CB5B1E62-38AF-456B-AC77-20D0C4359912}"/>
               </a:ext>
             </a:extLst>
           </p:cNvPr>
@@ -18707,7 +18984,7 @@
           <p:cNvPr id="29" name="Same-origin API proxy">
             <a:extLst xmlns:a="http://schemas.openxmlformats.org/drawingml/2006/main">
               <a:ext uri="{FF2B5EF4-FFF2-40B4-BE49-F238E27FC236}">
-                <a16:creationId xmlns:a16="http://schemas.microsoft.com/office/drawing/2014/main" id="{B4908935-3B7A-4FF7-AF4A-0F68A6FBE0A9}"/>
+                <a16:creationId xmlns:a16="http://schemas.microsoft.com/office/drawing/2014/main" id="{600D915B-FF52-4BD8-ACA7-2C8A00BA51B4}"/>
               </a:ext>
             </a:extLst>
           </p:cNvPr>
@@ -18775,7 +19052,7 @@
           <p:cNvPr id="30" name="Backend authorization">
             <a:extLst xmlns:a="http://schemas.openxmlformats.org/drawingml/2006/main">
               <a:ext uri="{FF2B5EF4-FFF2-40B4-BE49-F238E27FC236}">
-                <a16:creationId xmlns:a16="http://schemas.microsoft.com/office/drawing/2014/main" id="{31B28A40-6DAF-479E-9ABA-BA83E18AE328}"/>
+                <a16:creationId xmlns:a16="http://schemas.microsoft.com/office/drawing/2014/main" id="{2FBDBA31-4145-4324-A47F-C00F6AF73303}"/>
               </a:ext>
             </a:extLst>
           </p:cNvPr>
@@ -18843,7 +19120,7 @@
           <p:cNvPr id="31" name="Browser, application, database and external AI form separate">
             <a:extLst xmlns:a="http://schemas.openxmlformats.org/drawingml/2006/main">
               <a:ext uri="{FF2B5EF4-FFF2-40B4-BE49-F238E27FC236}">
-                <a16:creationId xmlns:a16="http://schemas.microsoft.com/office/drawing/2014/main" id="{79625D91-369C-405C-A82E-54E58E281CBF}"/>
+                <a16:creationId xmlns:a16="http://schemas.microsoft.com/office/drawing/2014/main" id="{61483925-3920-4B0D-8DE5-1DF055592AB1}"/>
               </a:ext>
             </a:extLst>
           </p:cNvPr>
@@ -18909,7 +19186,7 @@
     </p:spTree>
     <p:extLst>
       <p:ext uri="{BB962C8B-B14F-4D97-AF65-F5344CB8AC3E}">
-        <p14:creationId xmlns:p14="http://schemas.microsoft.com/office/powerpoint/2010/main" val="1603033466"/>
+        <p14:creationId xmlns:p14="http://schemas.microsoft.com/office/powerpoint/2010/main" val="936280788"/>
       </p:ext>
     </p:extLst>
   </p:cSld>
@@ -18940,7 +19217,7 @@
           <p:cNvPr id="22" name="">
             <a:extLst xmlns:a="http://schemas.openxmlformats.org/drawingml/2006/main">
               <a:ext uri="{FF2B5EF4-FFF2-40B4-BE49-F238E27FC236}">
-                <a16:creationId xmlns:a16="http://schemas.microsoft.com/office/drawing/2014/main" id="{5ADCB5B1-1D77-4AD8-B2C5-DF291E9534AA}"/>
+                <a16:creationId xmlns:a16="http://schemas.microsoft.com/office/drawing/2014/main" id="{2C6779AE-1C43-43DA-A744-473C70BA43F3}"/>
               </a:ext>
             </a:extLst>
           </p:cNvPr>
@@ -18972,7 +19249,7 @@
           <p:cNvPr id="21" name="">
             <a:extLst xmlns:a="http://schemas.openxmlformats.org/drawingml/2006/main">
               <a:ext uri="{FF2B5EF4-FFF2-40B4-BE49-F238E27FC236}">
-                <a16:creationId xmlns:a16="http://schemas.microsoft.com/office/drawing/2014/main" id="{76F45E76-25F7-421D-8959-BEB07BCC9608}"/>
+                <a16:creationId xmlns:a16="http://schemas.microsoft.com/office/drawing/2014/main" id="{15D1C285-15EF-47F1-9702-78AED141CE10}"/>
               </a:ext>
             </a:extLst>
           </p:cNvPr>
@@ -19004,7 +19281,7 @@
           <p:cNvPr id="20" name="">
             <a:extLst xmlns:a="http://schemas.openxmlformats.org/drawingml/2006/main">
               <a:ext uri="{FF2B5EF4-FFF2-40B4-BE49-F238E27FC236}">
-                <a16:creationId xmlns:a16="http://schemas.microsoft.com/office/drawing/2014/main" id="{6CD3535C-3846-436F-BEF0-D579716539BD}"/>
+                <a16:creationId xmlns:a16="http://schemas.microsoft.com/office/drawing/2014/main" id="{303CFE87-0A09-4F32-8C6C-E96CE740D076}"/>
               </a:ext>
             </a:extLst>
           </p:cNvPr>
@@ -19036,7 +19313,7 @@
           <p:cNvPr id="24" name="BizWizard">
             <a:extLst xmlns:a="http://schemas.openxmlformats.org/drawingml/2006/main">
               <a:ext uri="{FF2B5EF4-FFF2-40B4-BE49-F238E27FC236}">
-                <a16:creationId xmlns:a16="http://schemas.microsoft.com/office/drawing/2014/main" id="{60B33E8D-66C8-4FEB-A9D5-0945D43422AD}"/>
+                <a16:creationId xmlns:a16="http://schemas.microsoft.com/office/drawing/2014/main" id="{E7AA01FB-8F3D-4EC8-96CB-7523396B6D57}"/>
               </a:ext>
             </a:extLst>
           </p:cNvPr>
@@ -19104,7 +19381,7 @@
           <p:cNvPr id="2" name="09">
             <a:extLst xmlns:a="http://schemas.openxmlformats.org/drawingml/2006/main">
               <a:ext uri="{FF2B5EF4-FFF2-40B4-BE49-F238E27FC236}">
-                <a16:creationId xmlns:a16="http://schemas.microsoft.com/office/drawing/2014/main" id="{88136782-4A51-42FD-AC24-FA6EBAEF9B47}"/>
+                <a16:creationId xmlns:a16="http://schemas.microsoft.com/office/drawing/2014/main" id="{7A337F1A-321D-40AE-A083-5F097B6823C1}"/>
               </a:ext>
             </a:extLst>
           </p:cNvPr>
@@ -19172,7 +19449,7 @@
           <p:cNvPr id="3" name="Slide heading">
             <a:extLst xmlns:a="http://schemas.openxmlformats.org/drawingml/2006/main">
               <a:ext uri="{FF2B5EF4-FFF2-40B4-BE49-F238E27FC236}">
-                <a16:creationId xmlns:a16="http://schemas.microsoft.com/office/drawing/2014/main" id="{78560CC5-2A8E-4FB5-A55D-F5758F9D52B7}"/>
+                <a16:creationId xmlns:a16="http://schemas.microsoft.com/office/drawing/2014/main" id="{A2220CBD-EC40-4757-823E-818B6E64B71B}"/>
               </a:ext>
             </a:extLst>
           </p:cNvPr>
@@ -19240,7 +19517,7 @@
           <p:cNvPr id="4" name="AI can select and explain">
             <a:extLst xmlns:a="http://schemas.openxmlformats.org/drawingml/2006/main">
               <a:ext uri="{FF2B5EF4-FFF2-40B4-BE49-F238E27FC236}">
-                <a16:creationId xmlns:a16="http://schemas.microsoft.com/office/drawing/2014/main" id="{EA259918-6DEA-44EA-9CE2-DE57F2F9258E}"/>
+                <a16:creationId xmlns:a16="http://schemas.microsoft.com/office/drawing/2014/main" id="{8E100B8E-E342-4141-8912-07937045B482}"/>
               </a:ext>
             </a:extLst>
           </p:cNvPr>
@@ -19308,7 +19585,7 @@
           <p:cNvPr id="5" name="Product ranking, treasury choices, analysis hypotheses and e">
             <a:extLst xmlns:a="http://schemas.openxmlformats.org/drawingml/2006/main">
               <a:ext uri="{FF2B5EF4-FFF2-40B4-BE49-F238E27FC236}">
-                <a16:creationId xmlns:a16="http://schemas.microsoft.com/office/drawing/2014/main" id="{FD4EC060-88D4-4F86-86E8-0B6BF4B99161}"/>
+                <a16:creationId xmlns:a16="http://schemas.microsoft.com/office/drawing/2014/main" id="{773D8367-2FA2-44F6-92E8-4D99EEBF128C}"/>
               </a:ext>
             </a:extLst>
           </p:cNvPr>
@@ -19399,7 +19676,7 @@
           <p:cNvPr id="6" name="Code keeps the financial contract">
             <a:extLst xmlns:a="http://schemas.openxmlformats.org/drawingml/2006/main">
               <a:ext uri="{FF2B5EF4-FFF2-40B4-BE49-F238E27FC236}">
-                <a16:creationId xmlns:a16="http://schemas.microsoft.com/office/drawing/2014/main" id="{E90C0286-F703-410A-A681-D07D5DFB0021}"/>
+                <a16:creationId xmlns:a16="http://schemas.microsoft.com/office/drawing/2014/main" id="{5DF7B5A5-9B8C-4211-806F-463B961FFDA2}"/>
               </a:ext>
             </a:extLst>
           </p:cNvPr>
@@ -19467,7 +19744,7 @@
           <p:cNvPr id="7" name="Eligibility, pricing, negotiation policies, repayment math a">
             <a:extLst xmlns:a="http://schemas.openxmlformats.org/drawingml/2006/main">
               <a:ext uri="{FF2B5EF4-FFF2-40B4-BE49-F238E27FC236}">
-                <a16:creationId xmlns:a16="http://schemas.microsoft.com/office/drawing/2014/main" id="{F9369C51-D86C-4F77-8B35-7C82BF0BD70F}"/>
+                <a16:creationId xmlns:a16="http://schemas.microsoft.com/office/drawing/2014/main" id="{EB84FD6B-8A9A-4FB8-9BD2-D00AD5EDA0B7}"/>
               </a:ext>
             </a:extLst>
           </p:cNvPr>
@@ -19558,7 +19835,7 @@
           <p:cNvPr id="8" name="Scoped inputs">
             <a:extLst xmlns:a="http://schemas.openxmlformats.org/drawingml/2006/main">
               <a:ext uri="{FF2B5EF4-FFF2-40B4-BE49-F238E27FC236}">
-                <a16:creationId xmlns:a16="http://schemas.microsoft.com/office/drawing/2014/main" id="{9DD5A0DB-238E-4C08-8324-6B27C1C72AE5}"/>
+                <a16:creationId xmlns:a16="http://schemas.microsoft.com/office/drawing/2014/main" id="{8FB64A06-54EF-4C38-A0E8-3C65D38EBEB1}"/>
               </a:ext>
             </a:extLst>
           </p:cNvPr>
@@ -19590,7 +19867,7 @@
           <p:cNvPr id="9" name="Scoped inputs">
             <a:extLst xmlns:a="http://schemas.openxmlformats.org/drawingml/2006/main">
               <a:ext uri="{FF2B5EF4-FFF2-40B4-BE49-F238E27FC236}">
-                <a16:creationId xmlns:a16="http://schemas.microsoft.com/office/drawing/2014/main" id="{1CFD45F8-0278-432F-A8AD-620EE56AE33A}"/>
+                <a16:creationId xmlns:a16="http://schemas.microsoft.com/office/drawing/2014/main" id="{8822BFD8-71D6-4F2E-B158-7CE8D3BA91A7}"/>
               </a:ext>
             </a:extLst>
           </p:cNvPr>
@@ -19658,7 +19935,7 @@
           <p:cNvPr id="10" name="Only the relevant shop">
             <a:extLst xmlns:a="http://schemas.openxmlformats.org/drawingml/2006/main">
               <a:ext uri="{FF2B5EF4-FFF2-40B4-BE49-F238E27FC236}">
-                <a16:creationId xmlns:a16="http://schemas.microsoft.com/office/drawing/2014/main" id="{89041128-8408-4379-8503-1DD92A642612}"/>
+                <a16:creationId xmlns:a16="http://schemas.microsoft.com/office/drawing/2014/main" id="{A828C2DB-8993-4808-ADB4-D786D7CE2EC9}"/>
               </a:ext>
             </a:extLst>
           </p:cNvPr>
@@ -19726,7 +20003,7 @@
           <p:cNvPr id="11" name="JSON choice">
             <a:extLst xmlns:a="http://schemas.openxmlformats.org/drawingml/2006/main">
               <a:ext uri="{FF2B5EF4-FFF2-40B4-BE49-F238E27FC236}">
-                <a16:creationId xmlns:a16="http://schemas.microsoft.com/office/drawing/2014/main" id="{105C81CF-109D-4191-9A52-2D70FC6405E7}"/>
+                <a16:creationId xmlns:a16="http://schemas.microsoft.com/office/drawing/2014/main" id="{CD12A6DC-7CAC-4F53-85DA-0F73064D9ADB}"/>
               </a:ext>
             </a:extLst>
           </p:cNvPr>
@@ -19758,7 +20035,7 @@
           <p:cNvPr id="12" name="JSON choice">
             <a:extLst xmlns:a="http://schemas.openxmlformats.org/drawingml/2006/main">
               <a:ext uri="{FF2B5EF4-FFF2-40B4-BE49-F238E27FC236}">
-                <a16:creationId xmlns:a16="http://schemas.microsoft.com/office/drawing/2014/main" id="{C7CAB345-4EAD-4663-B0CA-4A7FF97084FA}"/>
+                <a16:creationId xmlns:a16="http://schemas.microsoft.com/office/drawing/2014/main" id="{B6633ECE-0283-40E9-AEF7-4C02079257A9}"/>
               </a:ext>
             </a:extLst>
           </p:cNvPr>
@@ -19826,7 +20103,7 @@
           <p:cNvPr id="13" name="Schema and allowed IDs">
             <a:extLst xmlns:a="http://schemas.openxmlformats.org/drawingml/2006/main">
               <a:ext uri="{FF2B5EF4-FFF2-40B4-BE49-F238E27FC236}">
-                <a16:creationId xmlns:a16="http://schemas.microsoft.com/office/drawing/2014/main" id="{AF854C53-B2B0-47A3-BB74-7C02ACA093F4}"/>
+                <a16:creationId xmlns:a16="http://schemas.microsoft.com/office/drawing/2014/main" id="{D68CD55F-53BC-4157-852C-819E811C61C5}"/>
               </a:ext>
             </a:extLst>
           </p:cNvPr>
@@ -19894,7 +20171,7 @@
           <p:cNvPr id="14" name="Guards">
             <a:extLst xmlns:a="http://schemas.openxmlformats.org/drawingml/2006/main">
               <a:ext uri="{FF2B5EF4-FFF2-40B4-BE49-F238E27FC236}">
-                <a16:creationId xmlns:a16="http://schemas.microsoft.com/office/drawing/2014/main" id="{6E586CD7-DB22-4E77-89F5-6F7F9AA49647}"/>
+                <a16:creationId xmlns:a16="http://schemas.microsoft.com/office/drawing/2014/main" id="{4E657461-428F-4727-B0D1-6A4571A59574}"/>
               </a:ext>
             </a:extLst>
           </p:cNvPr>
@@ -19926,7 +20203,7 @@
           <p:cNvPr id="15" name="Guards">
             <a:extLst xmlns:a="http://schemas.openxmlformats.org/drawingml/2006/main">
               <a:ext uri="{FF2B5EF4-FFF2-40B4-BE49-F238E27FC236}">
-                <a16:creationId xmlns:a16="http://schemas.microsoft.com/office/drawing/2014/main" id="{1A721B80-1A28-41DE-BA73-CD3D50F4BB1F}"/>
+                <a16:creationId xmlns:a16="http://schemas.microsoft.com/office/drawing/2014/main" id="{DC388F1D-ABC1-43AE-BF96-BCB0FB71FA5B}"/>
               </a:ext>
             </a:extLst>
           </p:cNvPr>
@@ -19994,7 +20271,7 @@
           <p:cNvPr id="16" name="Independent code checks">
             <a:extLst xmlns:a="http://schemas.openxmlformats.org/drawingml/2006/main">
               <a:ext uri="{FF2B5EF4-FFF2-40B4-BE49-F238E27FC236}">
-                <a16:creationId xmlns:a16="http://schemas.microsoft.com/office/drawing/2014/main" id="{896EE680-8138-4E4E-8D16-B38049E6E9E6}"/>
+                <a16:creationId xmlns:a16="http://schemas.microsoft.com/office/drawing/2014/main" id="{624329E3-B8BE-4D32-9F38-19A6D3D4916C}"/>
               </a:ext>
             </a:extLst>
           </p:cNvPr>
@@ -20062,7 +20339,7 @@
           <p:cNvPr id="17" name="Decision or fallback">
             <a:extLst xmlns:a="http://schemas.openxmlformats.org/drawingml/2006/main">
               <a:ext uri="{FF2B5EF4-FFF2-40B4-BE49-F238E27FC236}">
-                <a16:creationId xmlns:a16="http://schemas.microsoft.com/office/drawing/2014/main" id="{B625D0DB-A5B6-4C97-9BD8-827794729F7C}"/>
+                <a16:creationId xmlns:a16="http://schemas.microsoft.com/office/drawing/2014/main" id="{0CDBBEBE-4181-4CC0-912B-09DE8670AADD}"/>
               </a:ext>
             </a:extLst>
           </p:cNvPr>
@@ -20094,7 +20371,7 @@
           <p:cNvPr id="18" name="Decision or fallback">
             <a:extLst xmlns:a="http://schemas.openxmlformats.org/drawingml/2006/main">
               <a:ext uri="{FF2B5EF4-FFF2-40B4-BE49-F238E27FC236}">
-                <a16:creationId xmlns:a16="http://schemas.microsoft.com/office/drawing/2014/main" id="{3C3AA414-0D36-430A-9F98-7E63DE3E6D20}"/>
+                <a16:creationId xmlns:a16="http://schemas.microsoft.com/office/drawing/2014/main" id="{AABBA893-E04A-4EF5-8F97-2A305934F1CE}"/>
               </a:ext>
             </a:extLst>
           </p:cNvPr>
@@ -20162,7 +20439,7 @@
           <p:cNvPr id="19" name="Label the model used">
             <a:extLst xmlns:a="http://schemas.openxmlformats.org/drawingml/2006/main">
               <a:ext uri="{FF2B5EF4-FFF2-40B4-BE49-F238E27FC236}">
-                <a16:creationId xmlns:a16="http://schemas.microsoft.com/office/drawing/2014/main" id="{85C7D40A-9026-43F2-8540-3EBABAE3E674}"/>
+                <a16:creationId xmlns:a16="http://schemas.microsoft.com/office/drawing/2014/main" id="{DB3CB16E-29BC-4548-9849-1879A126B15F}"/>
               </a:ext>
             </a:extLst>
           </p:cNvPr>
@@ -20230,7 +20507,7 @@
           <p:cNvPr id="23" name="Missing keys, invalid responses, timeouts and budget denial ">
             <a:extLst xmlns:a="http://schemas.openxmlformats.org/drawingml/2006/main">
               <a:ext uri="{FF2B5EF4-FFF2-40B4-BE49-F238E27FC236}">
-                <a16:creationId xmlns:a16="http://schemas.microsoft.com/office/drawing/2014/main" id="{C52EC96C-A320-49E8-A695-92D1D3693ED3}"/>
+                <a16:creationId xmlns:a16="http://schemas.microsoft.com/office/drawing/2014/main" id="{818420BE-1741-4A2B-B3DF-02DE251D72A0}"/>
               </a:ext>
             </a:extLst>
           </p:cNvPr>
@@ -20296,7 +20573,7 @@
     </p:spTree>
     <p:extLst>
       <p:ext uri="{BB962C8B-B14F-4D97-AF65-F5344CB8AC3E}">
-        <p14:creationId xmlns:p14="http://schemas.microsoft.com/office/powerpoint/2010/main" val="336988885"/>
+        <p14:creationId xmlns:p14="http://schemas.microsoft.com/office/powerpoint/2010/main" val="705022496"/>
       </p:ext>
     </p:extLst>
   </p:cSld>

</xml_diff>

<commit_message>
fix: update application URL in technical documentation and presentation assets
</commit_message>
<xml_diff>
--- a/output/presentation/BizWizard-Presentation.pptx
+++ b/output/presentation/BizWizard-Presentation.pptx
@@ -2,29 +2,29 @@
 <file path=ppt/presentation.xml><?xml version="1.0" encoding="utf-8"?>
 <p:presentation xmlns:p="http://schemas.openxmlformats.org/presentationml/2006/main">
   <p:sldMasterIdLst>
-    <p:sldMasterId xmlns:r="http://schemas.openxmlformats.org/officeDocument/2006/relationships" id="2147483648" r:id="Ra25c10f712d245f2"/>
+    <p:sldMasterId xmlns:r="http://schemas.openxmlformats.org/officeDocument/2006/relationships" id="2147483648" r:id="Rbb097ea646924054"/>
   </p:sldMasterIdLst>
   <p:notesMasterIdLst>
-    <p:notesMasterId xmlns:r="http://schemas.openxmlformats.org/officeDocument/2006/relationships" r:id="R4085dabedb984ea5"/>
+    <p:notesMasterId xmlns:r="http://schemas.openxmlformats.org/officeDocument/2006/relationships" r:id="R7571a0d2204b46df"/>
   </p:notesMasterIdLst>
   <p:sldIdLst>
-    <p:sldId xmlns:r="http://schemas.openxmlformats.org/officeDocument/2006/relationships" id="256" r:id="R62a43e20343a4d28"/>
-    <p:sldId xmlns:r="http://schemas.openxmlformats.org/officeDocument/2006/relationships" id="257" r:id="Rc7ba867b1020410e"/>
-    <p:sldId xmlns:r="http://schemas.openxmlformats.org/officeDocument/2006/relationships" id="258" r:id="R465fad86d317456d"/>
-    <p:sldId xmlns:r="http://schemas.openxmlformats.org/officeDocument/2006/relationships" id="259" r:id="Rae7a679144514098"/>
-    <p:sldId xmlns:r="http://schemas.openxmlformats.org/officeDocument/2006/relationships" id="260" r:id="R0fc08fc61c524881"/>
-    <p:sldId xmlns:r="http://schemas.openxmlformats.org/officeDocument/2006/relationships" id="261" r:id="Rbdeaec37059944b5"/>
-    <p:sldId xmlns:r="http://schemas.openxmlformats.org/officeDocument/2006/relationships" id="262" r:id="R58c07be409b14243"/>
-    <p:sldId xmlns:r="http://schemas.openxmlformats.org/officeDocument/2006/relationships" id="263" r:id="R371cc253c1ba41fd"/>
-    <p:sldId xmlns:r="http://schemas.openxmlformats.org/officeDocument/2006/relationships" id="264" r:id="Re254f4452f014436"/>
-    <p:sldId xmlns:r="http://schemas.openxmlformats.org/officeDocument/2006/relationships" id="265" r:id="R4c996ae68e5e4936"/>
-    <p:sldId xmlns:r="http://schemas.openxmlformats.org/officeDocument/2006/relationships" id="266" r:id="Rfeb46513152448d8"/>
-    <p:sldId xmlns:r="http://schemas.openxmlformats.org/officeDocument/2006/relationships" id="267" r:id="Rc84fa75f9bf44663"/>
-    <p:sldId xmlns:r="http://schemas.openxmlformats.org/officeDocument/2006/relationships" id="268" r:id="Rf42e390b375e42d3"/>
-    <p:sldId xmlns:r="http://schemas.openxmlformats.org/officeDocument/2006/relationships" id="269" r:id="Rf6fff1c6457f4733"/>
-    <p:sldId xmlns:r="http://schemas.openxmlformats.org/officeDocument/2006/relationships" id="270" r:id="Rb6a502a681144683"/>
-    <p:sldId xmlns:r="http://schemas.openxmlformats.org/officeDocument/2006/relationships" id="271" r:id="Rbd69381f5f224477"/>
-    <p:sldId xmlns:r="http://schemas.openxmlformats.org/officeDocument/2006/relationships" id="272" r:id="R511185bbb1a84d06"/>
+    <p:sldId xmlns:r="http://schemas.openxmlformats.org/officeDocument/2006/relationships" id="256" r:id="R0aea4d792b7040f3"/>
+    <p:sldId xmlns:r="http://schemas.openxmlformats.org/officeDocument/2006/relationships" id="257" r:id="Rfe374a0b81164f80"/>
+    <p:sldId xmlns:r="http://schemas.openxmlformats.org/officeDocument/2006/relationships" id="258" r:id="Rae0540ce74b34fdd"/>
+    <p:sldId xmlns:r="http://schemas.openxmlformats.org/officeDocument/2006/relationships" id="259" r:id="R0fb37fa6f0864308"/>
+    <p:sldId xmlns:r="http://schemas.openxmlformats.org/officeDocument/2006/relationships" id="260" r:id="R24b072862be34003"/>
+    <p:sldId xmlns:r="http://schemas.openxmlformats.org/officeDocument/2006/relationships" id="261" r:id="R3d151a667f2541f8"/>
+    <p:sldId xmlns:r="http://schemas.openxmlformats.org/officeDocument/2006/relationships" id="262" r:id="R4c6b81ee945f4648"/>
+    <p:sldId xmlns:r="http://schemas.openxmlformats.org/officeDocument/2006/relationships" id="263" r:id="Rd9637027270541e3"/>
+    <p:sldId xmlns:r="http://schemas.openxmlformats.org/officeDocument/2006/relationships" id="264" r:id="Rcf7e51abc9804e0d"/>
+    <p:sldId xmlns:r="http://schemas.openxmlformats.org/officeDocument/2006/relationships" id="265" r:id="R149e8dcfb94b4a40"/>
+    <p:sldId xmlns:r="http://schemas.openxmlformats.org/officeDocument/2006/relationships" id="266" r:id="Racb60603caf448c9"/>
+    <p:sldId xmlns:r="http://schemas.openxmlformats.org/officeDocument/2006/relationships" id="267" r:id="Rae662a0fc7944d6d"/>
+    <p:sldId xmlns:r="http://schemas.openxmlformats.org/officeDocument/2006/relationships" id="268" r:id="Ra896ca15fec94ddd"/>
+    <p:sldId xmlns:r="http://schemas.openxmlformats.org/officeDocument/2006/relationships" id="269" r:id="Reb01093b54ff4871"/>
+    <p:sldId xmlns:r="http://schemas.openxmlformats.org/officeDocument/2006/relationships" id="270" r:id="R591904b4d72b46de"/>
+    <p:sldId xmlns:r="http://schemas.openxmlformats.org/officeDocument/2006/relationships" id="271" r:id="Rac3964d98cd6425a"/>
+    <p:sldId xmlns:r="http://schemas.openxmlformats.org/officeDocument/2006/relationships" id="272" r:id="R8071f396ba3047ec"/>
   </p:sldIdLst>
   <p:sldSz cx="15240000" cy="8572500"/>
   <p:notesSz cx="6858000" cy="9144000"/>
@@ -2680,7 +2680,7 @@
           <p:cNvPr id="3" name="Title">
             <a:extLst xmlns:a="http://schemas.openxmlformats.org/drawingml/2006/main">
               <a:ext uri="{FF2B5EF4-FFF2-40B4-BE49-F238E27FC236}">
-                <a16:creationId xmlns:a16="http://schemas.microsoft.com/office/drawing/2014/main" id="{AFE960EA-EEEA-4E3E-8DCB-55AB04FE2F73}"/>
+                <a16:creationId xmlns:a16="http://schemas.microsoft.com/office/drawing/2014/main" id="{BC7FF3E8-A832-4F70-A279-39B4EE2605DA}"/>
               </a:ext>
             </a:extLst>
           </p:cNvPr>
@@ -2837,7 +2837,7 @@
           <p:cNvPr id="2" name="Subtitle">
             <a:extLst xmlns:a="http://schemas.openxmlformats.org/drawingml/2006/main">
               <a:ext uri="{FF2B5EF4-FFF2-40B4-BE49-F238E27FC236}">
-                <a16:creationId xmlns:a16="http://schemas.microsoft.com/office/drawing/2014/main" id="{0899DD77-F569-42CB-A9C4-E28C9B010D1F}"/>
+                <a16:creationId xmlns:a16="http://schemas.microsoft.com/office/drawing/2014/main" id="{0DD0DF96-8287-47D8-9BD1-FC53DD9A79FE}"/>
               </a:ext>
             </a:extLst>
           </p:cNvPr>
@@ -3011,7 +3011,7 @@
           <p:cNvPr id="2" name="Section title">
             <a:extLst xmlns:a="http://schemas.openxmlformats.org/drawingml/2006/main">
               <a:ext uri="{FF2B5EF4-FFF2-40B4-BE49-F238E27FC236}">
-                <a16:creationId xmlns:a16="http://schemas.microsoft.com/office/drawing/2014/main" id="{A9A426C4-E5CE-4FEA-B48B-86AE45F07CA7}"/>
+                <a16:creationId xmlns:a16="http://schemas.microsoft.com/office/drawing/2014/main" id="{CB5D0468-71BD-4A41-8FA4-A6F9B4EEC725}"/>
               </a:ext>
             </a:extLst>
           </p:cNvPr>
@@ -3185,7 +3185,7 @@
           <p:cNvPr id="3" name="Title">
             <a:extLst xmlns:a="http://schemas.openxmlformats.org/drawingml/2006/main">
               <a:ext uri="{FF2B5EF4-FFF2-40B4-BE49-F238E27FC236}">
-                <a16:creationId xmlns:a16="http://schemas.microsoft.com/office/drawing/2014/main" id="{70AFF263-0B2F-4906-BF1B-81F3E2A92927}"/>
+                <a16:creationId xmlns:a16="http://schemas.microsoft.com/office/drawing/2014/main" id="{7DF4E7C8-8AD2-413E-9271-2FE2F255F95D}"/>
               </a:ext>
             </a:extLst>
           </p:cNvPr>
@@ -3342,7 +3342,7 @@
           <p:cNvPr id="2" name="Body">
             <a:extLst xmlns:a="http://schemas.openxmlformats.org/drawingml/2006/main">
               <a:ext uri="{FF2B5EF4-FFF2-40B4-BE49-F238E27FC236}">
-                <a16:creationId xmlns:a16="http://schemas.microsoft.com/office/drawing/2014/main" id="{19082B43-EBBB-4206-BA80-D2177E8ED2F7}"/>
+                <a16:creationId xmlns:a16="http://schemas.microsoft.com/office/drawing/2014/main" id="{E6B67C91-B30C-413C-A674-DCFF0CA74542}"/>
               </a:ext>
             </a:extLst>
           </p:cNvPr>
@@ -3516,7 +3516,7 @@
           <p:cNvPr id="4" name="Title">
             <a:extLst xmlns:a="http://schemas.openxmlformats.org/drawingml/2006/main">
               <a:ext uri="{FF2B5EF4-FFF2-40B4-BE49-F238E27FC236}">
-                <a16:creationId xmlns:a16="http://schemas.microsoft.com/office/drawing/2014/main" id="{067358AF-7826-4B88-8076-85C2807D693D}"/>
+                <a16:creationId xmlns:a16="http://schemas.microsoft.com/office/drawing/2014/main" id="{8235CF2D-A4B5-4B9C-8235-09DB59660A51}"/>
               </a:ext>
             </a:extLst>
           </p:cNvPr>
@@ -3673,7 +3673,7 @@
           <p:cNvPr id="2" name="Left column">
             <a:extLst xmlns:a="http://schemas.openxmlformats.org/drawingml/2006/main">
               <a:ext uri="{FF2B5EF4-FFF2-40B4-BE49-F238E27FC236}">
-                <a16:creationId xmlns:a16="http://schemas.microsoft.com/office/drawing/2014/main" id="{82AB9010-2B51-4475-87F6-C303B58F7E71}"/>
+                <a16:creationId xmlns:a16="http://schemas.microsoft.com/office/drawing/2014/main" id="{53327F0C-E7AB-4C89-9541-802584875A3C}"/>
               </a:ext>
             </a:extLst>
           </p:cNvPr>
@@ -3830,7 +3830,7 @@
           <p:cNvPr id="3" name="Right column">
             <a:extLst xmlns:a="http://schemas.openxmlformats.org/drawingml/2006/main">
               <a:ext uri="{FF2B5EF4-FFF2-40B4-BE49-F238E27FC236}">
-                <a16:creationId xmlns:a16="http://schemas.microsoft.com/office/drawing/2014/main" id="{2563AD1E-37F5-4A90-A9F7-4C6885650D6A}"/>
+                <a16:creationId xmlns:a16="http://schemas.microsoft.com/office/drawing/2014/main" id="{6E25A972-7D88-4518-84AD-1F26806039AB}"/>
               </a:ext>
             </a:extLst>
           </p:cNvPr>
@@ -4004,7 +4004,7 @@
           <p:cNvPr id="3" name="Title">
             <a:extLst xmlns:a="http://schemas.openxmlformats.org/drawingml/2006/main">
               <a:ext uri="{FF2B5EF4-FFF2-40B4-BE49-F238E27FC236}">
-                <a16:creationId xmlns:a16="http://schemas.microsoft.com/office/drawing/2014/main" id="{766C0D9C-7E16-4A79-9E30-019B774FF4DF}"/>
+                <a16:creationId xmlns:a16="http://schemas.microsoft.com/office/drawing/2014/main" id="{0D4B4A0A-9B1F-4D12-9B86-566323F879CF}"/>
               </a:ext>
             </a:extLst>
           </p:cNvPr>
@@ -4161,7 +4161,7 @@
           <p:cNvPr id="2" name="Left column">
             <a:extLst xmlns:a="http://schemas.openxmlformats.org/drawingml/2006/main">
               <a:ext uri="{FF2B5EF4-FFF2-40B4-BE49-F238E27FC236}">
-                <a16:creationId xmlns:a16="http://schemas.microsoft.com/office/drawing/2014/main" id="{18B2F8AB-C1C7-48F0-8D3F-508080330445}"/>
+                <a16:creationId xmlns:a16="http://schemas.microsoft.com/office/drawing/2014/main" id="{364D021A-3B54-494C-85A6-A6AA7A774779}"/>
               </a:ext>
             </a:extLst>
           </p:cNvPr>
@@ -4356,12 +4356,12 @@
   </p:cSld>
   <p:clrMap bg1="lt1" tx1="dk1" bg2="lt2" tx2="dk2" accent1="accent1" accent2="accent2" accent3="accent3" accent4="accent4" accent5="accent5" accent6="accent6" hlink="hlink" folHlink="folHlink"/>
   <p:sldLayoutIdLst>
-    <p:sldLayoutId xmlns:r="http://schemas.openxmlformats.org/officeDocument/2006/relationships" id="2147483649" r:id="R730f32302f634bba"/>
-    <p:sldLayoutId xmlns:r="http://schemas.openxmlformats.org/officeDocument/2006/relationships" id="2147483650" r:id="Rd8e8db1454794559"/>
-    <p:sldLayoutId xmlns:r="http://schemas.openxmlformats.org/officeDocument/2006/relationships" id="2147483651" r:id="Rd26e9f41f2a94bf0"/>
-    <p:sldLayoutId xmlns:r="http://schemas.openxmlformats.org/officeDocument/2006/relationships" id="2147483652" r:id="R90a93bcafe754ea7"/>
-    <p:sldLayoutId xmlns:r="http://schemas.openxmlformats.org/officeDocument/2006/relationships" id="2147483653" r:id="R74342ecfdf6c4017"/>
-    <p:sldLayoutId xmlns:r="http://schemas.openxmlformats.org/officeDocument/2006/relationships" id="2147483654" r:id="Rb4d0e13d260d480e"/>
+    <p:sldLayoutId xmlns:r="http://schemas.openxmlformats.org/officeDocument/2006/relationships" id="2147483649" r:id="R767171bf0c284295"/>
+    <p:sldLayoutId xmlns:r="http://schemas.openxmlformats.org/officeDocument/2006/relationships" id="2147483650" r:id="R5a15f82d01104e85"/>
+    <p:sldLayoutId xmlns:r="http://schemas.openxmlformats.org/officeDocument/2006/relationships" id="2147483651" r:id="R7bd19fe13102444c"/>
+    <p:sldLayoutId xmlns:r="http://schemas.openxmlformats.org/officeDocument/2006/relationships" id="2147483652" r:id="R3cc473f5fc7f46d3"/>
+    <p:sldLayoutId xmlns:r="http://schemas.openxmlformats.org/officeDocument/2006/relationships" id="2147483653" r:id="Rdb820a9b1a994ea8"/>
+    <p:sldLayoutId xmlns:r="http://schemas.openxmlformats.org/officeDocument/2006/relationships" id="2147483654" r:id="R13861956d42f43ae"/>
   </p:sldLayoutIdLst>
   <p:txStyles>
     <p:titleStyle>
@@ -5339,7 +5339,7 @@
           <p:cNvPr id="14" name="BizWizard">
             <a:extLst xmlns:a="http://schemas.openxmlformats.org/drawingml/2006/main">
               <a:ext uri="{FF2B5EF4-FFF2-40B4-BE49-F238E27FC236}">
-                <a16:creationId xmlns:a16="http://schemas.microsoft.com/office/drawing/2014/main" id="{AF3B5614-E8D0-4E5C-9647-4FA8E59D0562}"/>
+                <a16:creationId xmlns:a16="http://schemas.microsoft.com/office/drawing/2014/main" id="{E66B6E5C-F8DE-46B5-A6E1-A08495D80DD2}"/>
               </a:ext>
             </a:extLst>
           </p:cNvPr>
@@ -5407,7 +5407,7 @@
           <p:cNvPr id="2" name="01">
             <a:extLst xmlns:a="http://schemas.openxmlformats.org/drawingml/2006/main">
               <a:ext uri="{FF2B5EF4-FFF2-40B4-BE49-F238E27FC236}">
-                <a16:creationId xmlns:a16="http://schemas.microsoft.com/office/drawing/2014/main" id="{2C2CD185-417B-471B-8FC5-B004F3775FCA}"/>
+                <a16:creationId xmlns:a16="http://schemas.microsoft.com/office/drawing/2014/main" id="{6980A296-F396-48A9-AE3A-B5ABB5BEBC34}"/>
               </a:ext>
             </a:extLst>
           </p:cNvPr>
@@ -5475,7 +5475,7 @@
           <p:cNvPr id="3" name="BUSINESS MANAGEMENT + FINANCE">
             <a:extLst xmlns:a="http://schemas.openxmlformats.org/drawingml/2006/main">
               <a:ext uri="{FF2B5EF4-FFF2-40B4-BE49-F238E27FC236}">
-                <a16:creationId xmlns:a16="http://schemas.microsoft.com/office/drawing/2014/main" id="{FBE8C313-8E8F-4A6B-9006-015D07C634F3}"/>
+                <a16:creationId xmlns:a16="http://schemas.microsoft.com/office/drawing/2014/main" id="{7B4B5C49-3E37-4958-AEC5-5274713D978B}"/>
               </a:ext>
             </a:extLst>
           </p:cNvPr>
@@ -5543,7 +5543,7 @@
           <p:cNvPr id="4" name="BizWizard">
             <a:extLst xmlns:a="http://schemas.openxmlformats.org/drawingml/2006/main">
               <a:ext uri="{FF2B5EF4-FFF2-40B4-BE49-F238E27FC236}">
-                <a16:creationId xmlns:a16="http://schemas.microsoft.com/office/drawing/2014/main" id="{27D9CF12-303E-4D8A-822D-B3D06CB8CF9B}"/>
+                <a16:creationId xmlns:a16="http://schemas.microsoft.com/office/drawing/2014/main" id="{D4F1354A-359C-41C1-8170-9E6719EC45D4}"/>
               </a:ext>
             </a:extLst>
           </p:cNvPr>
@@ -5611,7 +5611,7 @@
           <p:cNvPr id="5" name="Business management with financial guidance">
             <a:extLst xmlns:a="http://schemas.openxmlformats.org/drawingml/2006/main">
               <a:ext uri="{FF2B5EF4-FFF2-40B4-BE49-F238E27FC236}">
-                <a16:creationId xmlns:a16="http://schemas.microsoft.com/office/drawing/2014/main" id="{706EB28E-F7EE-4FCD-9D43-C7086E4DA936}"/>
+                <a16:creationId xmlns:a16="http://schemas.microsoft.com/office/drawing/2014/main" id="{50DB75D5-8624-4F00-A459-6EF098C2DA9C}"/>
               </a:ext>
             </a:extLst>
           </p:cNvPr>
@@ -5702,7 +5702,7 @@
           <p:cNvPr id="6" name="Run the shop. Use its records to make financial decisions.">
             <a:extLst xmlns:a="http://schemas.openxmlformats.org/drawingml/2006/main">
               <a:ext uri="{FF2B5EF4-FFF2-40B4-BE49-F238E27FC236}">
-                <a16:creationId xmlns:a16="http://schemas.microsoft.com/office/drawing/2014/main" id="{7D1B1E4B-5A08-4F78-980A-0E38949F0A93}"/>
+                <a16:creationId xmlns:a16="http://schemas.microsoft.com/office/drawing/2014/main" id="{8F8A4B0A-83F9-4F2E-8DA4-EC757C860B60}"/>
               </a:ext>
             </a:extLst>
           </p:cNvPr>
@@ -5793,7 +5793,7 @@
           <p:cNvPr id="7" name="">
             <a:extLst xmlns:a="http://schemas.openxmlformats.org/drawingml/2006/main">
               <a:ext uri="{FF2B5EF4-FFF2-40B4-BE49-F238E27FC236}">
-                <a16:creationId xmlns:a16="http://schemas.microsoft.com/office/drawing/2014/main" id="{91CFCAE0-A6AB-4CFD-A61C-6E98B97933AF}"/>
+                <a16:creationId xmlns:a16="http://schemas.microsoft.com/office/drawing/2014/main" id="{5317705C-1D59-4B12-9FEB-74EC9990C00C}"/>
               </a:ext>
             </a:extLst>
           </p:cNvPr>
@@ -5803,7 +5803,7 @@
           <p:nvPr/>
         </p:nvPicPr>
         <p:blipFill>
-          <a:blip xmlns:r="http://schemas.openxmlformats.org/officeDocument/2006/relationships" xmlns:a="http://schemas.openxmlformats.org/drawingml/2006/main" r:embed="R4012556549cf4fb6"/>
+          <a:blip xmlns:r="http://schemas.openxmlformats.org/officeDocument/2006/relationships" xmlns:a="http://schemas.openxmlformats.org/drawingml/2006/main" r:embed="Rba1e57e6d3f24431"/>
           <a:stretch xmlns:a="http://schemas.openxmlformats.org/drawingml/2006/main"/>
         </p:blipFill>
         <p:spPr>
@@ -5821,7 +5821,7 @@
           <p:cNvPr id="8" name="Current product UI with illustrative demo data">
             <a:extLst xmlns:a="http://schemas.openxmlformats.org/drawingml/2006/main">
               <a:ext uri="{FF2B5EF4-FFF2-40B4-BE49-F238E27FC236}">
-                <a16:creationId xmlns:a16="http://schemas.microsoft.com/office/drawing/2014/main" id="{29924D79-E5EB-4431-B8BB-8DAA46B5CF7F}"/>
+                <a16:creationId xmlns:a16="http://schemas.microsoft.com/office/drawing/2014/main" id="{90DB635D-3FC3-4F33-BED5-5E7AD5D83A3F}"/>
               </a:ext>
             </a:extLst>
           </p:cNvPr>
@@ -5889,7 +5889,7 @@
           <p:cNvPr id="9" name="BongoForge">
             <a:extLst xmlns:a="http://schemas.openxmlformats.org/drawingml/2006/main">
               <a:ext uri="{FF2B5EF4-FFF2-40B4-BE49-F238E27FC236}">
-                <a16:creationId xmlns:a16="http://schemas.microsoft.com/office/drawing/2014/main" id="{F8852C23-5804-45B8-B35C-63870F1C376C}"/>
+                <a16:creationId xmlns:a16="http://schemas.microsoft.com/office/drawing/2014/main" id="{767050BC-EAFB-4522-9775-70A88284B0E3}"/>
               </a:ext>
             </a:extLst>
           </p:cNvPr>
@@ -5957,7 +5957,7 @@
           <p:cNvPr id="10" name="Sadman Sakib / Mahfuz Saim / Sunan Rabbi">
             <a:extLst xmlns:a="http://schemas.openxmlformats.org/drawingml/2006/main">
               <a:ext uri="{FF2B5EF4-FFF2-40B4-BE49-F238E27FC236}">
-                <a16:creationId xmlns:a16="http://schemas.microsoft.com/office/drawing/2014/main" id="{2A121490-E21C-483D-8C07-C1003CF9A9F4}"/>
+                <a16:creationId xmlns:a16="http://schemas.microsoft.com/office/drawing/2014/main" id="{BCC3CE98-D7B0-43CA-A1D3-43FE020C1C11}"/>
               </a:ext>
             </a:extLst>
           </p:cNvPr>
@@ -6025,7 +6025,7 @@
           <p:cNvPr id="11" name="Rajshahi University of Engineering &amp; Technology (RUET)">
             <a:extLst xmlns:a="http://schemas.openxmlformats.org/drawingml/2006/main">
               <a:ext uri="{FF2B5EF4-FFF2-40B4-BE49-F238E27FC236}">
-                <a16:creationId xmlns:a16="http://schemas.microsoft.com/office/drawing/2014/main" id="{DC0431A5-BEA6-421B-A734-BCFB8D6E36AA}"/>
+                <a16:creationId xmlns:a16="http://schemas.microsoft.com/office/drawing/2014/main" id="{AB8CA9FC-1A7E-452F-8A9B-C191BA1040D5}"/>
               </a:ext>
             </a:extLst>
           </p:cNvPr>
@@ -6093,7 +6093,7 @@
           <p:cNvPr id="12" name="Bangladesh">
             <a:extLst xmlns:a="http://schemas.openxmlformats.org/drawingml/2006/main">
               <a:ext uri="{FF2B5EF4-FFF2-40B4-BE49-F238E27FC236}">
-                <a16:creationId xmlns:a16="http://schemas.microsoft.com/office/drawing/2014/main" id="{74452376-3D87-45DD-ACA4-403174E541E6}"/>
+                <a16:creationId xmlns:a16="http://schemas.microsoft.com/office/drawing/2014/main" id="{0B05A0E5-DC71-49A6-97A1-709E5646CE84}"/>
               </a:ext>
             </a:extLst>
           </p:cNvPr>
@@ -6161,7 +6161,7 @@
           <p:cNvPr id="13" name="2026 FinTechathon International Track">
             <a:extLst xmlns:a="http://schemas.openxmlformats.org/drawingml/2006/main">
               <a:ext uri="{FF2B5EF4-FFF2-40B4-BE49-F238E27FC236}">
-                <a16:creationId xmlns:a16="http://schemas.microsoft.com/office/drawing/2014/main" id="{6F1537BB-9406-4E73-BB65-3B3E8A77450E}"/>
+                <a16:creationId xmlns:a16="http://schemas.microsoft.com/office/drawing/2014/main" id="{D7D896DC-90F6-487D-AA5F-CDB2BAA27A48}"/>
               </a:ext>
             </a:extLst>
           </p:cNvPr>
@@ -6227,7 +6227,7 @@
     </p:spTree>
     <p:extLst>
       <p:ext uri="{BB962C8B-B14F-4D97-AF65-F5344CB8AC3E}">
-        <p14:creationId xmlns:p14="http://schemas.microsoft.com/office/powerpoint/2010/main" val="1114334479"/>
+        <p14:creationId xmlns:p14="http://schemas.microsoft.com/office/powerpoint/2010/main" val="837336080"/>
       </p:ext>
     </p:extLst>
   </p:cSld>
@@ -6258,7 +6258,7 @@
           <p:cNvPr id="11" name="BizWizard">
             <a:extLst xmlns:a="http://schemas.openxmlformats.org/drawingml/2006/main">
               <a:ext uri="{FF2B5EF4-FFF2-40B4-BE49-F238E27FC236}">
-                <a16:creationId xmlns:a16="http://schemas.microsoft.com/office/drawing/2014/main" id="{4AFE9CCD-AE3D-4329-9555-88F65401EA5D}"/>
+                <a16:creationId xmlns:a16="http://schemas.microsoft.com/office/drawing/2014/main" id="{501BB924-2392-45AB-83B4-52A301E6C256}"/>
               </a:ext>
             </a:extLst>
           </p:cNvPr>
@@ -6326,7 +6326,7 @@
           <p:cNvPr id="2" name="10">
             <a:extLst xmlns:a="http://schemas.openxmlformats.org/drawingml/2006/main">
               <a:ext uri="{FF2B5EF4-FFF2-40B4-BE49-F238E27FC236}">
-                <a16:creationId xmlns:a16="http://schemas.microsoft.com/office/drawing/2014/main" id="{27BCC953-02FF-4C6F-A3B6-1DF3E7A51D48}"/>
+                <a16:creationId xmlns:a16="http://schemas.microsoft.com/office/drawing/2014/main" id="{75BC543B-6B34-4749-B702-3DBCB1B2E2E6}"/>
               </a:ext>
             </a:extLst>
           </p:cNvPr>
@@ -6394,7 +6394,7 @@
           <p:cNvPr id="3" name="Slide heading">
             <a:extLst xmlns:a="http://schemas.openxmlformats.org/drawingml/2006/main">
               <a:ext uri="{FF2B5EF4-FFF2-40B4-BE49-F238E27FC236}">
-                <a16:creationId xmlns:a16="http://schemas.microsoft.com/office/drawing/2014/main" id="{6A7AD30E-79AD-48E7-B471-C0E35A337D59}"/>
+                <a16:creationId xmlns:a16="http://schemas.microsoft.com/office/drawing/2014/main" id="{068E6C8C-74E0-4EF8-8B84-83C7D225CB8B}"/>
               </a:ext>
             </a:extLst>
           </p:cNvPr>
@@ -6462,7 +6462,7 @@
           <p:cNvPr id="4" name="">
             <a:extLst xmlns:a="http://schemas.openxmlformats.org/drawingml/2006/main">
               <a:ext uri="{FF2B5EF4-FFF2-40B4-BE49-F238E27FC236}">
-                <a16:creationId xmlns:a16="http://schemas.microsoft.com/office/drawing/2014/main" id="{B0DEA77B-ADF3-420D-B93B-2DE63B8227A1}"/>
+                <a16:creationId xmlns:a16="http://schemas.microsoft.com/office/drawing/2014/main" id="{1797155D-6960-46A1-88E3-C87512493F74}"/>
               </a:ext>
             </a:extLst>
           </p:cNvPr>
@@ -6472,7 +6472,7 @@
           <p:nvPr/>
         </p:nvPicPr>
         <p:blipFill>
-          <a:blip xmlns:r="http://schemas.openxmlformats.org/officeDocument/2006/relationships" xmlns:a="http://schemas.openxmlformats.org/drawingml/2006/main" r:embed="R5968ba2cab8b40e0"/>
+          <a:blip xmlns:r="http://schemas.openxmlformats.org/officeDocument/2006/relationships" xmlns:a="http://schemas.openxmlformats.org/drawingml/2006/main" r:embed="Ra517d19766d04da9"/>
           <a:stretch xmlns:a="http://schemas.openxmlformats.org/drawingml/2006/main"/>
         </p:blipFill>
         <p:spPr>
@@ -6490,7 +6490,7 @@
           <p:cNvPr id="5" name="Candidate explanation">
             <a:extLst xmlns:a="http://schemas.openxmlformats.org/drawingml/2006/main">
               <a:ext uri="{FF2B5EF4-FFF2-40B4-BE49-F238E27FC236}">
-                <a16:creationId xmlns:a16="http://schemas.microsoft.com/office/drawing/2014/main" id="{35E89570-D296-4800-9B47-E70F5BC9EEF6}"/>
+                <a16:creationId xmlns:a16="http://schemas.microsoft.com/office/drawing/2014/main" id="{D7B1EE00-587B-4D96-B1B4-7A18B80D837A}"/>
               </a:ext>
             </a:extLst>
           </p:cNvPr>
@@ -6558,7 +6558,7 @@
           <p:cNvPr id="6" name="Check the contribution to the observed gap">
             <a:extLst xmlns:a="http://schemas.openxmlformats.org/drawingml/2006/main">
               <a:ext uri="{FF2B5EF4-FFF2-40B4-BE49-F238E27FC236}">
-                <a16:creationId xmlns:a16="http://schemas.microsoft.com/office/drawing/2014/main" id="{90BC8AD3-4A05-440D-83B9-C6B153D05D16}"/>
+                <a16:creationId xmlns:a16="http://schemas.microsoft.com/office/drawing/2014/main" id="{7A6D91CA-67FE-49A3-8C50-32CF18F32498}"/>
               </a:ext>
             </a:extLst>
           </p:cNvPr>
@@ -6649,7 +6649,7 @@
           <p:cNvPr id="7" name="Residual gap ≤10%">
             <a:extLst xmlns:a="http://schemas.openxmlformats.org/drawingml/2006/main">
               <a:ext uri="{FF2B5EF4-FFF2-40B4-BE49-F238E27FC236}">
-                <a16:creationId xmlns:a16="http://schemas.microsoft.com/office/drawing/2014/main" id="{2796EE99-CEB3-4C5F-B354-891007D966DB}"/>
+                <a16:creationId xmlns:a16="http://schemas.microsoft.com/office/drawing/2014/main" id="{EFEAC813-C0FC-4F5F-8620-1F159F698D93}"/>
               </a:ext>
             </a:extLst>
           </p:cNvPr>
@@ -6717,7 +6717,7 @@
           <p:cNvPr id="8" name="Accounting attribution supports the “verified” label.">
             <a:extLst xmlns:a="http://schemas.openxmlformats.org/drawingml/2006/main">
               <a:ext uri="{FF2B5EF4-FFF2-40B4-BE49-F238E27FC236}">
-                <a16:creationId xmlns:a16="http://schemas.microsoft.com/office/drawing/2014/main" id="{E8E66093-E9DE-45A1-9FF0-B4F37E370FDD}"/>
+                <a16:creationId xmlns:a16="http://schemas.microsoft.com/office/drawing/2014/main" id="{B1CA8CC0-1B60-4988-B12C-A23D72C16E77}"/>
               </a:ext>
             </a:extLst>
           </p:cNvPr>
@@ -6808,7 +6808,7 @@
           <p:cNvPr id="9" name="Scenarios explore changes before the owner commits.">
             <a:extLst xmlns:a="http://schemas.openxmlformats.org/drawingml/2006/main">
               <a:ext uri="{FF2B5EF4-FFF2-40B4-BE49-F238E27FC236}">
-                <a16:creationId xmlns:a16="http://schemas.microsoft.com/office/drawing/2014/main" id="{4540A3C8-6CCA-44FD-A685-9D2F08526F34}"/>
+                <a16:creationId xmlns:a16="http://schemas.microsoft.com/office/drawing/2014/main" id="{45E69C4D-96C6-476B-94A0-15E426F850D3}"/>
               </a:ext>
             </a:extLst>
           </p:cNvPr>
@@ -6899,7 +6899,7 @@
           <p:cNvPr id="10" name="Live app with seeded demo records. Saved insights may predat">
             <a:extLst xmlns:a="http://schemas.openxmlformats.org/drawingml/2006/main">
               <a:ext uri="{FF2B5EF4-FFF2-40B4-BE49-F238E27FC236}">
-                <a16:creationId xmlns:a16="http://schemas.microsoft.com/office/drawing/2014/main" id="{89C9E8AB-8FD7-4F27-B113-27DA43847D06}"/>
+                <a16:creationId xmlns:a16="http://schemas.microsoft.com/office/drawing/2014/main" id="{2E73E27B-C538-4DFF-AA90-C14AF221C36C}"/>
               </a:ext>
             </a:extLst>
           </p:cNvPr>
@@ -6965,7 +6965,7 @@
     </p:spTree>
     <p:extLst>
       <p:ext uri="{BB962C8B-B14F-4D97-AF65-F5344CB8AC3E}">
-        <p14:creationId xmlns:p14="http://schemas.microsoft.com/office/powerpoint/2010/main" val="231916024"/>
+        <p14:creationId xmlns:p14="http://schemas.microsoft.com/office/powerpoint/2010/main" val="1544506346"/>
       </p:ext>
     </p:extLst>
   </p:cSld>
@@ -6996,7 +6996,7 @@
           <p:cNvPr id="14" name="BizWizard">
             <a:extLst xmlns:a="http://schemas.openxmlformats.org/drawingml/2006/main">
               <a:ext uri="{FF2B5EF4-FFF2-40B4-BE49-F238E27FC236}">
-                <a16:creationId xmlns:a16="http://schemas.microsoft.com/office/drawing/2014/main" id="{443518DC-0481-4E39-84FD-9B76D593A676}"/>
+                <a16:creationId xmlns:a16="http://schemas.microsoft.com/office/drawing/2014/main" id="{8C23EC8E-AFD0-47CD-A867-5E255A389C95}"/>
               </a:ext>
             </a:extLst>
           </p:cNvPr>
@@ -7064,7 +7064,7 @@
           <p:cNvPr id="2" name="11">
             <a:extLst xmlns:a="http://schemas.openxmlformats.org/drawingml/2006/main">
               <a:ext uri="{FF2B5EF4-FFF2-40B4-BE49-F238E27FC236}">
-                <a16:creationId xmlns:a16="http://schemas.microsoft.com/office/drawing/2014/main" id="{1D0EA5ED-F2A0-44EA-883F-C11D586B5CCF}"/>
+                <a16:creationId xmlns:a16="http://schemas.microsoft.com/office/drawing/2014/main" id="{78B5CA85-21D5-46BE-8D6F-783417620F76}"/>
               </a:ext>
             </a:extLst>
           </p:cNvPr>
@@ -7132,7 +7132,7 @@
           <p:cNvPr id="3" name="Slide heading">
             <a:extLst xmlns:a="http://schemas.openxmlformats.org/drawingml/2006/main">
               <a:ext uri="{FF2B5EF4-FFF2-40B4-BE49-F238E27FC236}">
-                <a16:creationId xmlns:a16="http://schemas.microsoft.com/office/drawing/2014/main" id="{B4455D53-3815-47A5-97D5-5F314D42CA06}"/>
+                <a16:creationId xmlns:a16="http://schemas.microsoft.com/office/drawing/2014/main" id="{B26AEF03-766D-4A22-A6AF-EF0F6E4251AC}"/>
               </a:ext>
             </a:extLst>
           </p:cNvPr>
@@ -7200,7 +7200,7 @@
           <p:cNvPr id="4" name="">
             <a:extLst xmlns:a="http://schemas.openxmlformats.org/drawingml/2006/main">
               <a:ext uri="{FF2B5EF4-FFF2-40B4-BE49-F238E27FC236}">
-                <a16:creationId xmlns:a16="http://schemas.microsoft.com/office/drawing/2014/main" id="{DC2A3875-3DE1-4F73-B76E-A92D027DFEB8}"/>
+                <a16:creationId xmlns:a16="http://schemas.microsoft.com/office/drawing/2014/main" id="{C23CB8DD-2162-4E51-A415-B36204C3495A}"/>
               </a:ext>
             </a:extLst>
           </p:cNvPr>
@@ -7479,7 +7479,7 @@
           <p:cNvPr id="5" name="Unusual changes">
             <a:extLst xmlns:a="http://schemas.openxmlformats.org/drawingml/2006/main">
               <a:ext uri="{FF2B5EF4-FFF2-40B4-BE49-F238E27FC236}">
-                <a16:creationId xmlns:a16="http://schemas.microsoft.com/office/drawing/2014/main" id="{1F3456E8-E34A-4604-982E-96C62E7C9A9E}"/>
+                <a16:creationId xmlns:a16="http://schemas.microsoft.com/office/drawing/2014/main" id="{EE3A8094-3534-446F-BDFC-8B3B097ED539}"/>
               </a:ext>
             </a:extLst>
           </p:cNvPr>
@@ -7547,7 +7547,7 @@
           <p:cNvPr id="6" name="Weekday-adjusted robust z-score: |z| &gt;3.5. AI ranks the supp">
             <a:extLst xmlns:a="http://schemas.openxmlformats.org/drawingml/2006/main">
               <a:ext uri="{FF2B5EF4-FFF2-40B4-BE49-F238E27FC236}">
-                <a16:creationId xmlns:a16="http://schemas.microsoft.com/office/drawing/2014/main" id="{09C00813-F64A-473C-AE01-4B30881CCA97}"/>
+                <a16:creationId xmlns:a16="http://schemas.microsoft.com/office/drawing/2014/main" id="{33319881-AF8B-4204-88E9-EFEA4650C9C0}"/>
               </a:ext>
             </a:extLst>
           </p:cNvPr>
@@ -7638,7 +7638,7 @@
           <p:cNvPr id="7" name="Verification threshold">
             <a:extLst xmlns:a="http://schemas.openxmlformats.org/drawingml/2006/main">
               <a:ext uri="{FF2B5EF4-FFF2-40B4-BE49-F238E27FC236}">
-                <a16:creationId xmlns:a16="http://schemas.microsoft.com/office/drawing/2014/main" id="{C493B429-59C1-47A7-BEB4-9E27F3FD5031}"/>
+                <a16:creationId xmlns:a16="http://schemas.microsoft.com/office/drawing/2014/main" id="{FE95E2BB-84CB-4714-886D-5EC70F3F5EDE}"/>
               </a:ext>
             </a:extLst>
           </p:cNvPr>
@@ -7706,7 +7706,7 @@
           <p:cNvPr id="8" name="Residual gap ≤10%. Keep refuted explanations in the record.">
             <a:extLst xmlns:a="http://schemas.openxmlformats.org/drawingml/2006/main">
               <a:ext uri="{FF2B5EF4-FFF2-40B4-BE49-F238E27FC236}">
-                <a16:creationId xmlns:a16="http://schemas.microsoft.com/office/drawing/2014/main" id="{64BF1DD8-3F8B-44E0-8141-DCFD569DC516}"/>
+                <a16:creationId xmlns:a16="http://schemas.microsoft.com/office/drawing/2014/main" id="{87B09FEC-3034-4B50-87A4-7236BF0BB18B}"/>
               </a:ext>
             </a:extLst>
           </p:cNvPr>
@@ -7797,7 +7797,7 @@
           <p:cNvPr id="9" name="Stock and customer risk">
             <a:extLst xmlns:a="http://schemas.openxmlformats.org/drawingml/2006/main">
               <a:ext uri="{FF2B5EF4-FFF2-40B4-BE49-F238E27FC236}">
-                <a16:creationId xmlns:a16="http://schemas.microsoft.com/office/drawing/2014/main" id="{527870B4-1753-48BC-B0E1-F40A52C3DEE5}"/>
+                <a16:creationId xmlns:a16="http://schemas.microsoft.com/office/drawing/2014/main" id="{DA8DD4BB-69A3-4754-AF46-AC7488956CBC}"/>
               </a:ext>
             </a:extLst>
           </p:cNvPr>
@@ -7865,7 +7865,7 @@
           <p:cNvPr id="10" name="Dead stock: &gt;45 days without sale and &gt;5% of stock value. To">
             <a:extLst xmlns:a="http://schemas.openxmlformats.org/drawingml/2006/main">
               <a:ext uri="{FF2B5EF4-FFF2-40B4-BE49-F238E27FC236}">
-                <a16:creationId xmlns:a16="http://schemas.microsoft.com/office/drawing/2014/main" id="{61D10B7C-CF99-473D-B822-BDE653C2A45B}"/>
+                <a16:creationId xmlns:a16="http://schemas.microsoft.com/office/drawing/2014/main" id="{4D6B005D-48E8-4E30-800C-D727749F8D0C}"/>
               </a:ext>
             </a:extLst>
           </p:cNvPr>
@@ -7956,7 +7956,7 @@
           <p:cNvPr id="11" name="Capital decisions">
             <a:extLst xmlns:a="http://schemas.openxmlformats.org/drawingml/2006/main">
               <a:ext uri="{FF2B5EF4-FFF2-40B4-BE49-F238E27FC236}">
-                <a16:creationId xmlns:a16="http://schemas.microsoft.com/office/drawing/2014/main" id="{0DF6A706-E325-4238-B1EF-C45CD901A70E}"/>
+                <a16:creationId xmlns:a16="http://schemas.microsoft.com/office/drawing/2014/main" id="{C0B469B7-D85F-409B-B1D7-FC760D30FAE1}"/>
               </a:ext>
             </a:extLst>
           </p:cNvPr>
@@ -8024,7 +8024,7 @@
           <p:cNvPr id="12" name="Freeze a baseline, then observe 30 days. Before/after result">
             <a:extLst xmlns:a="http://schemas.openxmlformats.org/drawingml/2006/main">
               <a:ext uri="{FF2B5EF4-FFF2-40B4-BE49-F238E27FC236}">
-                <a16:creationId xmlns:a16="http://schemas.microsoft.com/office/drawing/2014/main" id="{FD6A623B-663D-4771-BAB3-42EA465E717A}"/>
+                <a16:creationId xmlns:a16="http://schemas.microsoft.com/office/drawing/2014/main" id="{98013904-F4B1-4F2D-A8BD-282947CC206E}"/>
               </a:ext>
             </a:extLst>
           </p:cNvPr>
@@ -8115,7 +8115,7 @@
           <p:cNvPr id="13" name="Missing lot costs use a 70% sales-value estimate. Forecast a">
             <a:extLst xmlns:a="http://schemas.openxmlformats.org/drawingml/2006/main">
               <a:ext uri="{FF2B5EF4-FFF2-40B4-BE49-F238E27FC236}">
-                <a16:creationId xmlns:a16="http://schemas.microsoft.com/office/drawing/2014/main" id="{A7095A1C-40B8-4D35-A59F-1F61584DECD1}"/>
+                <a16:creationId xmlns:a16="http://schemas.microsoft.com/office/drawing/2014/main" id="{9AD2ED10-0BC7-49EC-8C8E-A650D23459B0}"/>
               </a:ext>
             </a:extLst>
           </p:cNvPr>
@@ -8181,7 +8181,7 @@
     </p:spTree>
     <p:extLst>
       <p:ext uri="{BB962C8B-B14F-4D97-AF65-F5344CB8AC3E}">
-        <p14:creationId xmlns:p14="http://schemas.microsoft.com/office/powerpoint/2010/main" val="382524029"/>
+        <p14:creationId xmlns:p14="http://schemas.microsoft.com/office/powerpoint/2010/main" val="1555099656"/>
       </p:ext>
     </p:extLst>
   </p:cSld>
@@ -8212,7 +8212,7 @@
           <p:cNvPr id="25" name="">
             <a:extLst xmlns:a="http://schemas.openxmlformats.org/drawingml/2006/main">
               <a:ext uri="{FF2B5EF4-FFF2-40B4-BE49-F238E27FC236}">
-                <a16:creationId xmlns:a16="http://schemas.microsoft.com/office/drawing/2014/main" id="{5D014759-43BD-4906-9FDE-EFE79544A57B}"/>
+                <a16:creationId xmlns:a16="http://schemas.microsoft.com/office/drawing/2014/main" id="{0BA35E64-5086-4423-8C6E-73AFC6F7B288}"/>
               </a:ext>
             </a:extLst>
           </p:cNvPr>
@@ -8244,7 +8244,7 @@
           <p:cNvPr id="24" name="">
             <a:extLst xmlns:a="http://schemas.openxmlformats.org/drawingml/2006/main">
               <a:ext uri="{FF2B5EF4-FFF2-40B4-BE49-F238E27FC236}">
-                <a16:creationId xmlns:a16="http://schemas.microsoft.com/office/drawing/2014/main" id="{C54348CF-BCB1-4C0C-AEFB-5F05FE9F3DDC}"/>
+                <a16:creationId xmlns:a16="http://schemas.microsoft.com/office/drawing/2014/main" id="{0987EFF8-BCB8-4F14-A80A-81F74DD2C95D}"/>
               </a:ext>
             </a:extLst>
           </p:cNvPr>
@@ -8276,7 +8276,7 @@
           <p:cNvPr id="23" name="">
             <a:extLst xmlns:a="http://schemas.openxmlformats.org/drawingml/2006/main">
               <a:ext uri="{FF2B5EF4-FFF2-40B4-BE49-F238E27FC236}">
-                <a16:creationId xmlns:a16="http://schemas.microsoft.com/office/drawing/2014/main" id="{C6F4CA4D-BC38-45D5-8D42-B3B98570DCC5}"/>
+                <a16:creationId xmlns:a16="http://schemas.microsoft.com/office/drawing/2014/main" id="{28E2A2D8-F6F1-48B8-9AE0-7DAF146B27D9}"/>
               </a:ext>
             </a:extLst>
           </p:cNvPr>
@@ -8308,7 +8308,7 @@
           <p:cNvPr id="22" name="">
             <a:extLst xmlns:a="http://schemas.openxmlformats.org/drawingml/2006/main">
               <a:ext uri="{FF2B5EF4-FFF2-40B4-BE49-F238E27FC236}">
-                <a16:creationId xmlns:a16="http://schemas.microsoft.com/office/drawing/2014/main" id="{0512AA65-51FE-4F37-BF98-887E92F428AD}"/>
+                <a16:creationId xmlns:a16="http://schemas.microsoft.com/office/drawing/2014/main" id="{8A14C55C-9CC4-43AC-86D1-8F2F72C0700A}"/>
               </a:ext>
             </a:extLst>
           </p:cNvPr>
@@ -8340,7 +8340,7 @@
           <p:cNvPr id="32" name="BizWizard">
             <a:extLst xmlns:a="http://schemas.openxmlformats.org/drawingml/2006/main">
               <a:ext uri="{FF2B5EF4-FFF2-40B4-BE49-F238E27FC236}">
-                <a16:creationId xmlns:a16="http://schemas.microsoft.com/office/drawing/2014/main" id="{45FB56BE-A33B-4597-BC86-B49A81D01EB9}"/>
+                <a16:creationId xmlns:a16="http://schemas.microsoft.com/office/drawing/2014/main" id="{CF8EADAE-2A55-43D1-AF15-167072B04C80}"/>
               </a:ext>
             </a:extLst>
           </p:cNvPr>
@@ -8408,7 +8408,7 @@
           <p:cNvPr id="2" name="12">
             <a:extLst xmlns:a="http://schemas.openxmlformats.org/drawingml/2006/main">
               <a:ext uri="{FF2B5EF4-FFF2-40B4-BE49-F238E27FC236}">
-                <a16:creationId xmlns:a16="http://schemas.microsoft.com/office/drawing/2014/main" id="{BE15B737-2036-4BFE-9E71-12AA5C75D663}"/>
+                <a16:creationId xmlns:a16="http://schemas.microsoft.com/office/drawing/2014/main" id="{49A95910-40B1-4B6F-A0C9-B53311BC99C6}"/>
               </a:ext>
             </a:extLst>
           </p:cNvPr>
@@ -8476,7 +8476,7 @@
           <p:cNvPr id="3" name="Slide heading">
             <a:extLst xmlns:a="http://schemas.openxmlformats.org/drawingml/2006/main">
               <a:ext uri="{FF2B5EF4-FFF2-40B4-BE49-F238E27FC236}">
-                <a16:creationId xmlns:a16="http://schemas.microsoft.com/office/drawing/2014/main" id="{DAE51919-BC45-44FE-B391-1C5E67012108}"/>
+                <a16:creationId xmlns:a16="http://schemas.microsoft.com/office/drawing/2014/main" id="{29C5245D-891F-44F4-A5F8-1FC18160DF25}"/>
               </a:ext>
             </a:extLst>
           </p:cNvPr>
@@ -8544,7 +8544,7 @@
           <p:cNvPr id="4" name="Next.js frontend">
             <a:extLst xmlns:a="http://schemas.openxmlformats.org/drawingml/2006/main">
               <a:ext uri="{FF2B5EF4-FFF2-40B4-BE49-F238E27FC236}">
-                <a16:creationId xmlns:a16="http://schemas.microsoft.com/office/drawing/2014/main" id="{F9DFDE47-B6D9-42EC-8705-FFE2F0E2EE60}"/>
+                <a16:creationId xmlns:a16="http://schemas.microsoft.com/office/drawing/2014/main" id="{D1AACF04-4402-4103-BE9B-2F18B29CF2A9}"/>
               </a:ext>
             </a:extLst>
           </p:cNvPr>
@@ -8576,7 +8576,7 @@
           <p:cNvPr id="5" name="Next.js frontend">
             <a:extLst xmlns:a="http://schemas.openxmlformats.org/drawingml/2006/main">
               <a:ext uri="{FF2B5EF4-FFF2-40B4-BE49-F238E27FC236}">
-                <a16:creationId xmlns:a16="http://schemas.microsoft.com/office/drawing/2014/main" id="{A26582FB-0BD7-4E16-ABDF-8C2923480C3C}"/>
+                <a16:creationId xmlns:a16="http://schemas.microsoft.com/office/drawing/2014/main" id="{3603FC14-6485-409E-BE0D-A56ECF76261E}"/>
               </a:ext>
             </a:extLst>
           </p:cNvPr>
@@ -8644,7 +8644,7 @@
           <p:cNvPr id="6" name="React / Tailwind Vercel deployment">
             <a:extLst xmlns:a="http://schemas.openxmlformats.org/drawingml/2006/main">
               <a:ext uri="{FF2B5EF4-FFF2-40B4-BE49-F238E27FC236}">
-                <a16:creationId xmlns:a16="http://schemas.microsoft.com/office/drawing/2014/main" id="{E806C23A-44E3-4EC9-B91E-A46A1D913D86}"/>
+                <a16:creationId xmlns:a16="http://schemas.microsoft.com/office/drawing/2014/main" id="{7B0C3A87-8593-466C-A21A-29AB9D678A72}"/>
               </a:ext>
             </a:extLst>
           </p:cNvPr>
@@ -8735,7 +8735,7 @@
           <p:cNvPr id="7" name="Express API">
             <a:extLst xmlns:a="http://schemas.openxmlformats.org/drawingml/2006/main">
               <a:ext uri="{FF2B5EF4-FFF2-40B4-BE49-F238E27FC236}">
-                <a16:creationId xmlns:a16="http://schemas.microsoft.com/office/drawing/2014/main" id="{5941202D-12F0-443D-AEC5-E19D41F55BF9}"/>
+                <a16:creationId xmlns:a16="http://schemas.microsoft.com/office/drawing/2014/main" id="{2B101E9C-8E09-40E0-A93C-F3D0A5015920}"/>
               </a:ext>
             </a:extLst>
           </p:cNvPr>
@@ -8767,7 +8767,7 @@
           <p:cNvPr id="8" name="Express API">
             <a:extLst xmlns:a="http://schemas.openxmlformats.org/drawingml/2006/main">
               <a:ext uri="{FF2B5EF4-FFF2-40B4-BE49-F238E27FC236}">
-                <a16:creationId xmlns:a16="http://schemas.microsoft.com/office/drawing/2014/main" id="{190B2B10-BAFF-4F99-873E-335E0144E059}"/>
+                <a16:creationId xmlns:a16="http://schemas.microsoft.com/office/drawing/2014/main" id="{F131C5B4-BB9F-4831-B331-6F370894F7A7}"/>
               </a:ext>
             </a:extLst>
           </p:cNvPr>
@@ -8835,7 +8835,7 @@
           <p:cNvPr id="9" name="JWT, roles and scope Request validation">
             <a:extLst xmlns:a="http://schemas.openxmlformats.org/drawingml/2006/main">
               <a:ext uri="{FF2B5EF4-FFF2-40B4-BE49-F238E27FC236}">
-                <a16:creationId xmlns:a16="http://schemas.microsoft.com/office/drawing/2014/main" id="{3111ADDF-CF0E-4853-A707-D97D56E3D035}"/>
+                <a16:creationId xmlns:a16="http://schemas.microsoft.com/office/drawing/2014/main" id="{CCBFB370-54E9-4BA1-A0E9-53D4626D94D5}"/>
               </a:ext>
             </a:extLst>
           </p:cNvPr>
@@ -8926,7 +8926,7 @@
           <p:cNvPr id="10" name="PostgreSQL">
             <a:extLst xmlns:a="http://schemas.openxmlformats.org/drawingml/2006/main">
               <a:ext uri="{FF2B5EF4-FFF2-40B4-BE49-F238E27FC236}">
-                <a16:creationId xmlns:a16="http://schemas.microsoft.com/office/drawing/2014/main" id="{28DE3453-4B3C-4357-B737-3BAC060717AC}"/>
+                <a16:creationId xmlns:a16="http://schemas.microsoft.com/office/drawing/2014/main" id="{4E834A73-9D80-4AD3-A9EE-4DFA8D0C4F46}"/>
               </a:ext>
             </a:extLst>
           </p:cNvPr>
@@ -8958,7 +8958,7 @@
           <p:cNvPr id="11" name="PostgreSQL">
             <a:extLst xmlns:a="http://schemas.openxmlformats.org/drawingml/2006/main">
               <a:ext uri="{FF2B5EF4-FFF2-40B4-BE49-F238E27FC236}">
-                <a16:creationId xmlns:a16="http://schemas.microsoft.com/office/drawing/2014/main" id="{128EE941-6A3F-44AB-944A-5EF91F3F78D9}"/>
+                <a16:creationId xmlns:a16="http://schemas.microsoft.com/office/drawing/2014/main" id="{3463B502-4809-4913-A503-E9988391893C}"/>
               </a:ext>
             </a:extLst>
           </p:cNvPr>
@@ -9026,7 +9026,7 @@
           <p:cNvPr id="12" name="Prisma migrations Scoped business records">
             <a:extLst xmlns:a="http://schemas.openxmlformats.org/drawingml/2006/main">
               <a:ext uri="{FF2B5EF4-FFF2-40B4-BE49-F238E27FC236}">
-                <a16:creationId xmlns:a16="http://schemas.microsoft.com/office/drawing/2014/main" id="{27CCAA46-D9BF-4984-B699-BE183505E481}"/>
+                <a16:creationId xmlns:a16="http://schemas.microsoft.com/office/drawing/2014/main" id="{2594A76A-C601-406A-9C59-D73B149BF9F9}"/>
               </a:ext>
             </a:extLst>
           </p:cNvPr>
@@ -9117,7 +9117,7 @@
           <p:cNvPr id="13" name="Finance engines">
             <a:extLst xmlns:a="http://schemas.openxmlformats.org/drawingml/2006/main">
               <a:ext uri="{FF2B5EF4-FFF2-40B4-BE49-F238E27FC236}">
-                <a16:creationId xmlns:a16="http://schemas.microsoft.com/office/drawing/2014/main" id="{225601EE-41FF-44B7-9A44-08F24CB99751}"/>
+                <a16:creationId xmlns:a16="http://schemas.microsoft.com/office/drawing/2014/main" id="{47A28759-E02C-4A4C-900D-0AD5593B2E0D}"/>
               </a:ext>
             </a:extLst>
           </p:cNvPr>
@@ -9149,7 +9149,7 @@
           <p:cNvPr id="14" name="Finance engines">
             <a:extLst xmlns:a="http://schemas.openxmlformats.org/drawingml/2006/main">
               <a:ext uri="{FF2B5EF4-FFF2-40B4-BE49-F238E27FC236}">
-                <a16:creationId xmlns:a16="http://schemas.microsoft.com/office/drawing/2014/main" id="{F492E826-8B0F-4060-A14F-426DFD8D1C2B}"/>
+                <a16:creationId xmlns:a16="http://schemas.microsoft.com/office/drawing/2014/main" id="{2AE861B2-872C-4E49-9CEE-D040F19A9B95}"/>
               </a:ext>
             </a:extLst>
           </p:cNvPr>
@@ -9217,7 +9217,7 @@
           <p:cNvPr id="15" name="Calculations, forecasts and financial guards">
             <a:extLst xmlns:a="http://schemas.openxmlformats.org/drawingml/2006/main">
               <a:ext uri="{FF2B5EF4-FFF2-40B4-BE49-F238E27FC236}">
-                <a16:creationId xmlns:a16="http://schemas.microsoft.com/office/drawing/2014/main" id="{456FF11C-0C97-4C0D-94E6-E864D11487D5}"/>
+                <a16:creationId xmlns:a16="http://schemas.microsoft.com/office/drawing/2014/main" id="{ED3AE4E2-EAF6-4116-8438-5F95C3E6EC39}"/>
               </a:ext>
             </a:extLst>
           </p:cNvPr>
@@ -9308,7 +9308,7 @@
           <p:cNvPr id="16" name="AI runtime">
             <a:extLst xmlns:a="http://schemas.openxmlformats.org/drawingml/2006/main">
               <a:ext uri="{FF2B5EF4-FFF2-40B4-BE49-F238E27FC236}">
-                <a16:creationId xmlns:a16="http://schemas.microsoft.com/office/drawing/2014/main" id="{C3EBCA97-5331-4F49-9DF8-8F34301B8DF2}"/>
+                <a16:creationId xmlns:a16="http://schemas.microsoft.com/office/drawing/2014/main" id="{2F4B43C3-9A7E-4D65-A592-03E933ED0710}"/>
               </a:ext>
             </a:extLst>
           </p:cNvPr>
@@ -9340,7 +9340,7 @@
           <p:cNvPr id="17" name="AI runtime">
             <a:extLst xmlns:a="http://schemas.openxmlformats.org/drawingml/2006/main">
               <a:ext uri="{FF2B5EF4-FFF2-40B4-BE49-F238E27FC236}">
-                <a16:creationId xmlns:a16="http://schemas.microsoft.com/office/drawing/2014/main" id="{E7EBC240-624F-4C96-8991-4E879F5A4E3F}"/>
+                <a16:creationId xmlns:a16="http://schemas.microsoft.com/office/drawing/2014/main" id="{B312787F-3B83-4FCE-BAEF-29322DCAA5C8}"/>
               </a:ext>
             </a:extLst>
           </p:cNvPr>
@@ -9408,7 +9408,7 @@
           <p:cNvPr id="18" name="Structured JSON Budget and fallback">
             <a:extLst xmlns:a="http://schemas.openxmlformats.org/drawingml/2006/main">
               <a:ext uri="{FF2B5EF4-FFF2-40B4-BE49-F238E27FC236}">
-                <a16:creationId xmlns:a16="http://schemas.microsoft.com/office/drawing/2014/main" id="{0F243C4B-6D66-444C-9C90-BB0FED53048B}"/>
+                <a16:creationId xmlns:a16="http://schemas.microsoft.com/office/drawing/2014/main" id="{C1FC21CA-4A04-4898-B300-C9AA3B1C787A}"/>
               </a:ext>
             </a:extLst>
           </p:cNvPr>
@@ -9499,7 +9499,7 @@
           <p:cNvPr id="19" name="Optional OpenAI">
             <a:extLst xmlns:a="http://schemas.openxmlformats.org/drawingml/2006/main">
               <a:ext uri="{FF2B5EF4-FFF2-40B4-BE49-F238E27FC236}">
-                <a16:creationId xmlns:a16="http://schemas.microsoft.com/office/drawing/2014/main" id="{58E87EFC-633A-4476-96A6-8C238B34121E}"/>
+                <a16:creationId xmlns:a16="http://schemas.microsoft.com/office/drawing/2014/main" id="{31A12962-1528-4AF9-A172-82CA41497187}"/>
               </a:ext>
             </a:extLst>
           </p:cNvPr>
@@ -9531,7 +9531,7 @@
           <p:cNvPr id="20" name="Optional OpenAI">
             <a:extLst xmlns:a="http://schemas.openxmlformats.org/drawingml/2006/main">
               <a:ext uri="{FF2B5EF4-FFF2-40B4-BE49-F238E27FC236}">
-                <a16:creationId xmlns:a16="http://schemas.microsoft.com/office/drawing/2014/main" id="{6791381A-6273-4029-BB28-111B4156D161}"/>
+                <a16:creationId xmlns:a16="http://schemas.microsoft.com/office/drawing/2014/main" id="{7E790D05-0179-4FEE-8603-A4EC5BD202E8}"/>
               </a:ext>
             </a:extLst>
           </p:cNvPr>
@@ -9599,7 +9599,7 @@
           <p:cNvPr id="21" name="Select or explain constrained options">
             <a:extLst xmlns:a="http://schemas.openxmlformats.org/drawingml/2006/main">
               <a:ext uri="{FF2B5EF4-FFF2-40B4-BE49-F238E27FC236}">
-                <a16:creationId xmlns:a16="http://schemas.microsoft.com/office/drawing/2014/main" id="{09683DF3-54CC-4F0F-B448-446AD009E78C}"/>
+                <a16:creationId xmlns:a16="http://schemas.microsoft.com/office/drawing/2014/main" id="{33A5F19B-3BA3-4D7A-92DE-A771C661E2D5}"/>
               </a:ext>
             </a:extLst>
           </p:cNvPr>
@@ -9690,7 +9690,7 @@
           <p:cNvPr id="26" name="API to finance engines">
             <a:extLst xmlns:a="http://schemas.openxmlformats.org/drawingml/2006/main">
               <a:ext uri="{FF2B5EF4-FFF2-40B4-BE49-F238E27FC236}">
-                <a16:creationId xmlns:a16="http://schemas.microsoft.com/office/drawing/2014/main" id="{6114B6BD-4602-4167-AB82-9E62294A3363}"/>
+                <a16:creationId xmlns:a16="http://schemas.microsoft.com/office/drawing/2014/main" id="{A441A80F-F9DC-45FA-89DD-251769B9C37A}"/>
               </a:ext>
             </a:extLst>
           </p:cNvPr>
@@ -9717,7 +9717,7 @@
           <p:cNvPr id="27" name="API to finance engines">
             <a:extLst xmlns:a="http://schemas.openxmlformats.org/drawingml/2006/main">
               <a:ext uri="{FF2B5EF4-FFF2-40B4-BE49-F238E27FC236}">
-                <a16:creationId xmlns:a16="http://schemas.microsoft.com/office/drawing/2014/main" id="{D44BFB8E-BA22-43C4-A072-BC7B4F1F5B14}"/>
+                <a16:creationId xmlns:a16="http://schemas.microsoft.com/office/drawing/2014/main" id="{35B764CB-76DD-483F-9A24-BB073F4795B2}"/>
               </a:ext>
             </a:extLst>
           </p:cNvPr>
@@ -9744,7 +9744,7 @@
           <p:cNvPr id="28" name="API to finance engines">
             <a:extLst xmlns:a="http://schemas.openxmlformats.org/drawingml/2006/main">
               <a:ext uri="{FF2B5EF4-FFF2-40B4-BE49-F238E27FC236}">
-                <a16:creationId xmlns:a16="http://schemas.microsoft.com/office/drawing/2014/main" id="{C1BE415F-E533-46B7-A5D2-0A8B04E475F3}"/>
+                <a16:creationId xmlns:a16="http://schemas.microsoft.com/office/drawing/2014/main" id="{3532560F-D5D1-4345-A3A4-33AD4121BF3C}"/>
               </a:ext>
             </a:extLst>
           </p:cNvPr>
@@ -9772,7 +9772,7 @@
           <p:cNvPr id="29" name="Same-origin API proxy">
             <a:extLst xmlns:a="http://schemas.openxmlformats.org/drawingml/2006/main">
               <a:ext uri="{FF2B5EF4-FFF2-40B4-BE49-F238E27FC236}">
-                <a16:creationId xmlns:a16="http://schemas.microsoft.com/office/drawing/2014/main" id="{37C68F8C-864E-403F-A77D-30039B345CDC}"/>
+                <a16:creationId xmlns:a16="http://schemas.microsoft.com/office/drawing/2014/main" id="{CEBD5865-426E-4F16-8B12-7122A07C88F2}"/>
               </a:ext>
             </a:extLst>
           </p:cNvPr>
@@ -9840,7 +9840,7 @@
           <p:cNvPr id="30" name="Backend authorization">
             <a:extLst xmlns:a="http://schemas.openxmlformats.org/drawingml/2006/main">
               <a:ext uri="{FF2B5EF4-FFF2-40B4-BE49-F238E27FC236}">
-                <a16:creationId xmlns:a16="http://schemas.microsoft.com/office/drawing/2014/main" id="{6B57F9ED-2184-4DDF-A066-4C44645666C5}"/>
+                <a16:creationId xmlns:a16="http://schemas.microsoft.com/office/drawing/2014/main" id="{C5669C85-5EF5-49BE-8CA6-103FD5ABD408}"/>
               </a:ext>
             </a:extLst>
           </p:cNvPr>
@@ -9908,7 +9908,7 @@
           <p:cNvPr id="31" name="Browser, application, database and external AI form separate">
             <a:extLst xmlns:a="http://schemas.openxmlformats.org/drawingml/2006/main">
               <a:ext uri="{FF2B5EF4-FFF2-40B4-BE49-F238E27FC236}">
-                <a16:creationId xmlns:a16="http://schemas.microsoft.com/office/drawing/2014/main" id="{545C16E5-AADC-4028-B44D-533C9158869F}"/>
+                <a16:creationId xmlns:a16="http://schemas.microsoft.com/office/drawing/2014/main" id="{F7D3BB10-0D63-45EB-AE24-CDECE66AB012}"/>
               </a:ext>
             </a:extLst>
           </p:cNvPr>
@@ -9974,7 +9974,7 @@
     </p:spTree>
     <p:extLst>
       <p:ext uri="{BB962C8B-B14F-4D97-AF65-F5344CB8AC3E}">
-        <p14:creationId xmlns:p14="http://schemas.microsoft.com/office/powerpoint/2010/main" val="1941209040"/>
+        <p14:creationId xmlns:p14="http://schemas.microsoft.com/office/powerpoint/2010/main" val="1265883287"/>
       </p:ext>
     </p:extLst>
   </p:cSld>
@@ -10005,7 +10005,7 @@
           <p:cNvPr id="23" name="">
             <a:extLst xmlns:a="http://schemas.openxmlformats.org/drawingml/2006/main">
               <a:ext uri="{FF2B5EF4-FFF2-40B4-BE49-F238E27FC236}">
-                <a16:creationId xmlns:a16="http://schemas.microsoft.com/office/drawing/2014/main" id="{B515C253-E98C-4A89-A0C5-0A050987546F}"/>
+                <a16:creationId xmlns:a16="http://schemas.microsoft.com/office/drawing/2014/main" id="{FC789819-5493-42AB-8F56-409C5D09BB72}"/>
               </a:ext>
             </a:extLst>
           </p:cNvPr>
@@ -10037,7 +10037,7 @@
           <p:cNvPr id="22" name="">
             <a:extLst xmlns:a="http://schemas.openxmlformats.org/drawingml/2006/main">
               <a:ext uri="{FF2B5EF4-FFF2-40B4-BE49-F238E27FC236}">
-                <a16:creationId xmlns:a16="http://schemas.microsoft.com/office/drawing/2014/main" id="{6334D03D-CA7A-4880-B59A-936959743966}"/>
+                <a16:creationId xmlns:a16="http://schemas.microsoft.com/office/drawing/2014/main" id="{2A046543-EC81-4F23-B80E-092B07E0EB07}"/>
               </a:ext>
             </a:extLst>
           </p:cNvPr>
@@ -10069,7 +10069,7 @@
           <p:cNvPr id="21" name="">
             <a:extLst xmlns:a="http://schemas.openxmlformats.org/drawingml/2006/main">
               <a:ext uri="{FF2B5EF4-FFF2-40B4-BE49-F238E27FC236}">
-                <a16:creationId xmlns:a16="http://schemas.microsoft.com/office/drawing/2014/main" id="{FDD32FEC-E2BD-4C44-AE7F-1FBF85BE417C}"/>
+                <a16:creationId xmlns:a16="http://schemas.microsoft.com/office/drawing/2014/main" id="{C6C52A2F-DB53-4CFC-9928-C6DBB3232E92}"/>
               </a:ext>
             </a:extLst>
           </p:cNvPr>
@@ -10101,7 +10101,7 @@
           <p:cNvPr id="25" name="BizWizard">
             <a:extLst xmlns:a="http://schemas.openxmlformats.org/drawingml/2006/main">
               <a:ext uri="{FF2B5EF4-FFF2-40B4-BE49-F238E27FC236}">
-                <a16:creationId xmlns:a16="http://schemas.microsoft.com/office/drawing/2014/main" id="{D1BCDBB4-4F99-4E7C-89A9-884D88344B87}"/>
+                <a16:creationId xmlns:a16="http://schemas.microsoft.com/office/drawing/2014/main" id="{D9BC18DC-216C-4316-8673-32D2A7D431B2}"/>
               </a:ext>
             </a:extLst>
           </p:cNvPr>
@@ -10169,7 +10169,7 @@
           <p:cNvPr id="2" name="13">
             <a:extLst xmlns:a="http://schemas.openxmlformats.org/drawingml/2006/main">
               <a:ext uri="{FF2B5EF4-FFF2-40B4-BE49-F238E27FC236}">
-                <a16:creationId xmlns:a16="http://schemas.microsoft.com/office/drawing/2014/main" id="{3DCD4E99-6B2E-480E-BD36-5EB6778D3CB9}"/>
+                <a16:creationId xmlns:a16="http://schemas.microsoft.com/office/drawing/2014/main" id="{BE0D0066-717C-4E78-B2C6-E4BCB2D3E552}"/>
               </a:ext>
             </a:extLst>
           </p:cNvPr>
@@ -10237,7 +10237,7 @@
           <p:cNvPr id="3" name="Slide heading">
             <a:extLst xmlns:a="http://schemas.openxmlformats.org/drawingml/2006/main">
               <a:ext uri="{FF2B5EF4-FFF2-40B4-BE49-F238E27FC236}">
-                <a16:creationId xmlns:a16="http://schemas.microsoft.com/office/drawing/2014/main" id="{A162A200-AA38-49E8-B919-82F9E1B210B9}"/>
+                <a16:creationId xmlns:a16="http://schemas.microsoft.com/office/drawing/2014/main" id="{EAF7F4A0-D526-49B4-9F2F-44DB2F10BE5F}"/>
               </a:ext>
             </a:extLst>
           </p:cNvPr>
@@ -10305,7 +10305,7 @@
           <p:cNvPr id="4" name="Four agent roles">
             <a:extLst xmlns:a="http://schemas.openxmlformats.org/drawingml/2006/main">
               <a:ext uri="{FF2B5EF4-FFF2-40B4-BE49-F238E27FC236}">
-                <a16:creationId xmlns:a16="http://schemas.microsoft.com/office/drawing/2014/main" id="{5ECE6E62-A13D-4996-B9F1-D8B018C9DFC2}"/>
+                <a16:creationId xmlns:a16="http://schemas.microsoft.com/office/drawing/2014/main" id="{F49AF88E-9455-43B5-8C9E-56966248888E}"/>
               </a:ext>
             </a:extLst>
           </p:cNvPr>
@@ -10373,7 +10373,7 @@
           <p:cNvPr id="5" name="Lender, borrower, treasurer and analyst. Optional AI support">
             <a:extLst xmlns:a="http://schemas.openxmlformats.org/drawingml/2006/main">
               <a:ext uri="{FF2B5EF4-FFF2-40B4-BE49-F238E27FC236}">
-                <a16:creationId xmlns:a16="http://schemas.microsoft.com/office/drawing/2014/main" id="{E42CEA88-B93C-4E3E-B604-9264367A91F9}"/>
+                <a16:creationId xmlns:a16="http://schemas.microsoft.com/office/drawing/2014/main" id="{3EEDB4F5-E115-42CC-8680-9CDF590030A4}"/>
               </a:ext>
             </a:extLst>
           </p:cNvPr>
@@ -10487,7 +10487,7 @@
           <p:cNvPr id="6" name="Code keeps the financial contract">
             <a:extLst xmlns:a="http://schemas.openxmlformats.org/drawingml/2006/main">
               <a:ext uri="{FF2B5EF4-FFF2-40B4-BE49-F238E27FC236}">
-                <a16:creationId xmlns:a16="http://schemas.microsoft.com/office/drawing/2014/main" id="{2C0697D4-ED56-4F4E-9D9B-14F573F7827A}"/>
+                <a16:creationId xmlns:a16="http://schemas.microsoft.com/office/drawing/2014/main" id="{7B8E8388-4657-4A9E-9681-1C0B97341152}"/>
               </a:ext>
             </a:extLst>
           </p:cNvPr>
@@ -10555,7 +10555,7 @@
           <p:cNvPr id="7" name="Eligibility, pricing, negotiation policies, repayment math a">
             <a:extLst xmlns:a="http://schemas.openxmlformats.org/drawingml/2006/main">
               <a:ext uri="{FF2B5EF4-FFF2-40B4-BE49-F238E27FC236}">
-                <a16:creationId xmlns:a16="http://schemas.microsoft.com/office/drawing/2014/main" id="{5404CA5A-F035-49B8-BBEE-5847D95D6C2D}"/>
+                <a16:creationId xmlns:a16="http://schemas.microsoft.com/office/drawing/2014/main" id="{595F60EB-9DF0-4DDA-90B1-58DF1FA22F48}"/>
               </a:ext>
             </a:extLst>
           </p:cNvPr>
@@ -10646,7 +10646,7 @@
           <p:cNvPr id="8" name="$2 / tenant / month default budget 6s fast / 12s reasoning d">
             <a:extLst xmlns:a="http://schemas.openxmlformats.org/drawingml/2006/main">
               <a:ext uri="{FF2B5EF4-FFF2-40B4-BE49-F238E27FC236}">
-                <a16:creationId xmlns:a16="http://schemas.microsoft.com/office/drawing/2014/main" id="{19E8012A-BA7B-4544-AA87-7909FC9B0788}"/>
+                <a16:creationId xmlns:a16="http://schemas.microsoft.com/office/drawing/2014/main" id="{DD26CABE-61C7-4541-A0F4-FAFFD10629F7}"/>
               </a:ext>
             </a:extLst>
           </p:cNvPr>
@@ -10714,7 +10714,7 @@
           <p:cNvPr id="9" name="Scoped inputs">
             <a:extLst xmlns:a="http://schemas.openxmlformats.org/drawingml/2006/main">
               <a:ext uri="{FF2B5EF4-FFF2-40B4-BE49-F238E27FC236}">
-                <a16:creationId xmlns:a16="http://schemas.microsoft.com/office/drawing/2014/main" id="{B8CB4BFD-54D5-401A-BD98-268BB50F5395}"/>
+                <a16:creationId xmlns:a16="http://schemas.microsoft.com/office/drawing/2014/main" id="{BEB26500-D1EB-4547-B2DA-9487FDDEAB40}"/>
               </a:ext>
             </a:extLst>
           </p:cNvPr>
@@ -10746,7 +10746,7 @@
           <p:cNvPr id="10" name="Scoped inputs">
             <a:extLst xmlns:a="http://schemas.openxmlformats.org/drawingml/2006/main">
               <a:ext uri="{FF2B5EF4-FFF2-40B4-BE49-F238E27FC236}">
-                <a16:creationId xmlns:a16="http://schemas.microsoft.com/office/drawing/2014/main" id="{98CADBC5-C100-4BD2-AEB1-27E0F8CB62D8}"/>
+                <a16:creationId xmlns:a16="http://schemas.microsoft.com/office/drawing/2014/main" id="{C22944CA-0893-4F42-80B0-49C107381A89}"/>
               </a:ext>
             </a:extLst>
           </p:cNvPr>
@@ -10814,7 +10814,7 @@
           <p:cNvPr id="11" name="Only the relevant shop">
             <a:extLst xmlns:a="http://schemas.openxmlformats.org/drawingml/2006/main">
               <a:ext uri="{FF2B5EF4-FFF2-40B4-BE49-F238E27FC236}">
-                <a16:creationId xmlns:a16="http://schemas.microsoft.com/office/drawing/2014/main" id="{EBAD5BB2-DC69-4913-875E-631E18E19EBF}"/>
+                <a16:creationId xmlns:a16="http://schemas.microsoft.com/office/drawing/2014/main" id="{97E8BE7F-CEBC-4776-8524-65EBDF34664B}"/>
               </a:ext>
             </a:extLst>
           </p:cNvPr>
@@ -10882,7 +10882,7 @@
           <p:cNvPr id="12" name="JSON choice">
             <a:extLst xmlns:a="http://schemas.openxmlformats.org/drawingml/2006/main">
               <a:ext uri="{FF2B5EF4-FFF2-40B4-BE49-F238E27FC236}">
-                <a16:creationId xmlns:a16="http://schemas.microsoft.com/office/drawing/2014/main" id="{2B5022AC-0C4A-4677-B699-203C785AA98E}"/>
+                <a16:creationId xmlns:a16="http://schemas.microsoft.com/office/drawing/2014/main" id="{563478AF-4A33-476E-85D1-5856AB92038A}"/>
               </a:ext>
             </a:extLst>
           </p:cNvPr>
@@ -10914,7 +10914,7 @@
           <p:cNvPr id="13" name="JSON choice">
             <a:extLst xmlns:a="http://schemas.openxmlformats.org/drawingml/2006/main">
               <a:ext uri="{FF2B5EF4-FFF2-40B4-BE49-F238E27FC236}">
-                <a16:creationId xmlns:a16="http://schemas.microsoft.com/office/drawing/2014/main" id="{8CEBEBD9-E8F8-430D-A875-2FCC1948B79F}"/>
+                <a16:creationId xmlns:a16="http://schemas.microsoft.com/office/drawing/2014/main" id="{7A95F1DB-1E65-4F8A-8DD8-0DCB9C59AF56}"/>
               </a:ext>
             </a:extLst>
           </p:cNvPr>
@@ -10982,7 +10982,7 @@
           <p:cNvPr id="14" name="Schema and allowed IDs">
             <a:extLst xmlns:a="http://schemas.openxmlformats.org/drawingml/2006/main">
               <a:ext uri="{FF2B5EF4-FFF2-40B4-BE49-F238E27FC236}">
-                <a16:creationId xmlns:a16="http://schemas.microsoft.com/office/drawing/2014/main" id="{C487FDB8-EA61-4C7E-A310-477E972A649C}"/>
+                <a16:creationId xmlns:a16="http://schemas.microsoft.com/office/drawing/2014/main" id="{C687EA35-F718-44B3-9AF7-14339649C8F6}"/>
               </a:ext>
             </a:extLst>
           </p:cNvPr>
@@ -11050,7 +11050,7 @@
           <p:cNvPr id="15" name="Guards">
             <a:extLst xmlns:a="http://schemas.openxmlformats.org/drawingml/2006/main">
               <a:ext uri="{FF2B5EF4-FFF2-40B4-BE49-F238E27FC236}">
-                <a16:creationId xmlns:a16="http://schemas.microsoft.com/office/drawing/2014/main" id="{ABD56C40-8F60-454A-B95D-E1E2723700FC}"/>
+                <a16:creationId xmlns:a16="http://schemas.microsoft.com/office/drawing/2014/main" id="{1A780366-5B12-479E-A225-34A88DEF3150}"/>
               </a:ext>
             </a:extLst>
           </p:cNvPr>
@@ -11082,7 +11082,7 @@
           <p:cNvPr id="16" name="Guards">
             <a:extLst xmlns:a="http://schemas.openxmlformats.org/drawingml/2006/main">
               <a:ext uri="{FF2B5EF4-FFF2-40B4-BE49-F238E27FC236}">
-                <a16:creationId xmlns:a16="http://schemas.microsoft.com/office/drawing/2014/main" id="{156F8165-DE90-4CF2-8FCA-24701DFE16BF}"/>
+                <a16:creationId xmlns:a16="http://schemas.microsoft.com/office/drawing/2014/main" id="{0DA7FE6E-9E28-4CF9-BEEB-087F910DE7CE}"/>
               </a:ext>
             </a:extLst>
           </p:cNvPr>
@@ -11150,7 +11150,7 @@
           <p:cNvPr id="17" name="Independent code checks">
             <a:extLst xmlns:a="http://schemas.openxmlformats.org/drawingml/2006/main">
               <a:ext uri="{FF2B5EF4-FFF2-40B4-BE49-F238E27FC236}">
-                <a16:creationId xmlns:a16="http://schemas.microsoft.com/office/drawing/2014/main" id="{ACCA8DC9-56DC-4233-8A6A-488A14079D87}"/>
+                <a16:creationId xmlns:a16="http://schemas.microsoft.com/office/drawing/2014/main" id="{D433F1EA-C6D1-4E00-8FC1-D7FE894C7982}"/>
               </a:ext>
             </a:extLst>
           </p:cNvPr>
@@ -11218,7 +11218,7 @@
           <p:cNvPr id="18" name="Decision or fallback">
             <a:extLst xmlns:a="http://schemas.openxmlformats.org/drawingml/2006/main">
               <a:ext uri="{FF2B5EF4-FFF2-40B4-BE49-F238E27FC236}">
-                <a16:creationId xmlns:a16="http://schemas.microsoft.com/office/drawing/2014/main" id="{165FE842-56B0-4667-823B-D4756D58BB19}"/>
+                <a16:creationId xmlns:a16="http://schemas.microsoft.com/office/drawing/2014/main" id="{FE82A3AC-947B-4355-91A4-3DA935074145}"/>
               </a:ext>
             </a:extLst>
           </p:cNvPr>
@@ -11250,7 +11250,7 @@
           <p:cNvPr id="19" name="Decision or fallback">
             <a:extLst xmlns:a="http://schemas.openxmlformats.org/drawingml/2006/main">
               <a:ext uri="{FF2B5EF4-FFF2-40B4-BE49-F238E27FC236}">
-                <a16:creationId xmlns:a16="http://schemas.microsoft.com/office/drawing/2014/main" id="{EC9E1F40-B0A4-43C2-A5B3-C9C37E968B08}"/>
+                <a16:creationId xmlns:a16="http://schemas.microsoft.com/office/drawing/2014/main" id="{91A3FD8B-0A56-4F7E-8B35-18C78F0BBF30}"/>
               </a:ext>
             </a:extLst>
           </p:cNvPr>
@@ -11318,7 +11318,7 @@
           <p:cNvPr id="20" name="Label the model used">
             <a:extLst xmlns:a="http://schemas.openxmlformats.org/drawingml/2006/main">
               <a:ext uri="{FF2B5EF4-FFF2-40B4-BE49-F238E27FC236}">
-                <a16:creationId xmlns:a16="http://schemas.microsoft.com/office/drawing/2014/main" id="{7C0B538B-AC73-488A-AD8F-5BA601EE3CF7}"/>
+                <a16:creationId xmlns:a16="http://schemas.microsoft.com/office/drawing/2014/main" id="{E4AFACDC-9B6F-438B-A16C-D4419654FB0C}"/>
               </a:ext>
             </a:extLst>
           </p:cNvPr>
@@ -11386,7 +11386,7 @@
           <p:cNvPr id="24" name="No key: zero provider calls. A fallback after an invalid res">
             <a:extLst xmlns:a="http://schemas.openxmlformats.org/drawingml/2006/main">
               <a:ext uri="{FF2B5EF4-FFF2-40B4-BE49-F238E27FC236}">
-                <a16:creationId xmlns:a16="http://schemas.microsoft.com/office/drawing/2014/main" id="{D7D5E6A5-51ED-4676-9A6A-F892B69BAF6D}"/>
+                <a16:creationId xmlns:a16="http://schemas.microsoft.com/office/drawing/2014/main" id="{856D58C6-C9C0-4F00-9EC9-E249552A56A2}"/>
               </a:ext>
             </a:extLst>
           </p:cNvPr>
@@ -11452,7 +11452,7 @@
     </p:spTree>
     <p:extLst>
       <p:ext uri="{BB962C8B-B14F-4D97-AF65-F5344CB8AC3E}">
-        <p14:creationId xmlns:p14="http://schemas.microsoft.com/office/powerpoint/2010/main" val="614430339"/>
+        <p14:creationId xmlns:p14="http://schemas.microsoft.com/office/powerpoint/2010/main" val="920178241"/>
       </p:ext>
     </p:extLst>
   </p:cSld>
@@ -11483,7 +11483,7 @@
           <p:cNvPr id="9" name="BizWizard">
             <a:extLst xmlns:a="http://schemas.openxmlformats.org/drawingml/2006/main">
               <a:ext uri="{FF2B5EF4-FFF2-40B4-BE49-F238E27FC236}">
-                <a16:creationId xmlns:a16="http://schemas.microsoft.com/office/drawing/2014/main" id="{8C040512-FA0B-48D3-A1F3-3B2D05FE63AA}"/>
+                <a16:creationId xmlns:a16="http://schemas.microsoft.com/office/drawing/2014/main" id="{02229335-2DD4-45C4-A825-0BE56EC78795}"/>
               </a:ext>
             </a:extLst>
           </p:cNvPr>
@@ -11551,7 +11551,7 @@
           <p:cNvPr id="2" name="14">
             <a:extLst xmlns:a="http://schemas.openxmlformats.org/drawingml/2006/main">
               <a:ext uri="{FF2B5EF4-FFF2-40B4-BE49-F238E27FC236}">
-                <a16:creationId xmlns:a16="http://schemas.microsoft.com/office/drawing/2014/main" id="{51F19052-325F-4BAC-8159-B045A388E138}"/>
+                <a16:creationId xmlns:a16="http://schemas.microsoft.com/office/drawing/2014/main" id="{E3FA33EE-732B-4698-AFD8-0F7980F8E310}"/>
               </a:ext>
             </a:extLst>
           </p:cNvPr>
@@ -11619,7 +11619,7 @@
           <p:cNvPr id="3" name="Slide heading">
             <a:extLst xmlns:a="http://schemas.openxmlformats.org/drawingml/2006/main">
               <a:ext uri="{FF2B5EF4-FFF2-40B4-BE49-F238E27FC236}">
-                <a16:creationId xmlns:a16="http://schemas.microsoft.com/office/drawing/2014/main" id="{D74E76B3-EB74-45D2-9B4C-6651FBD6E492}"/>
+                <a16:creationId xmlns:a16="http://schemas.microsoft.com/office/drawing/2014/main" id="{2D094608-1874-40F7-A92D-4FAE39A6ACD0}"/>
               </a:ext>
             </a:extLst>
           </p:cNvPr>
@@ -11687,7 +11687,7 @@
           <p:cNvPr id="4" name="Versioned mandates and recorded choices keep decisions inspe">
             <a:extLst xmlns:a="http://schemas.openxmlformats.org/drawingml/2006/main">
               <a:ext uri="{FF2B5EF4-FFF2-40B4-BE49-F238E27FC236}">
-                <a16:creationId xmlns:a16="http://schemas.microsoft.com/office/drawing/2014/main" id="{0E2FF6DD-400D-4B2E-AD79-E776B41ED504}"/>
+                <a16:creationId xmlns:a16="http://schemas.microsoft.com/office/drawing/2014/main" id="{9ED28B8A-7BB9-42D6-88A4-9B9F4CF5F12A}"/>
               </a:ext>
             </a:extLst>
           </p:cNvPr>
@@ -11755,7 +11755,7 @@
           <p:cNvPr id="5" name="Saved live policy run: eight paired paths on one frozen shop">
             <a:extLst xmlns:a="http://schemas.openxmlformats.org/drawingml/2006/main">
               <a:ext uri="{FF2B5EF4-FFF2-40B4-BE49-F238E27FC236}">
-                <a16:creationId xmlns:a16="http://schemas.microsoft.com/office/drawing/2014/main" id="{7D3FC5DC-F734-410D-9DC7-9310C92FC3F6}"/>
+                <a16:creationId xmlns:a16="http://schemas.microsoft.com/office/drawing/2014/main" id="{8D5A0D23-0C66-443F-9148-734DE354F81C}"/>
               </a:ext>
             </a:extLst>
           </p:cNvPr>
@@ -11823,7 +11823,7 @@
           <p:cNvPr id="6" name="">
             <a:extLst xmlns:a="http://schemas.openxmlformats.org/drawingml/2006/main">
               <a:ext uri="{FF2B5EF4-FFF2-40B4-BE49-F238E27FC236}">
-                <a16:creationId xmlns:a16="http://schemas.microsoft.com/office/drawing/2014/main" id="{65F56754-EBFC-4A85-8189-43D0E9081D88}"/>
+                <a16:creationId xmlns:a16="http://schemas.microsoft.com/office/drawing/2014/main" id="{3F012284-55BD-4A31-A453-1F69C65D63AE}"/>
               </a:ext>
             </a:extLst>
           </p:cNvPr>
@@ -12637,7 +12637,7 @@
           <p:cNvPr id="7" name="Same inputs and outcome draws. Offline replay matched the sa">
             <a:extLst xmlns:a="http://schemas.openxmlformats.org/drawingml/2006/main">
               <a:ext uri="{FF2B5EF4-FFF2-40B4-BE49-F238E27FC236}">
-                <a16:creationId xmlns:a16="http://schemas.microsoft.com/office/drawing/2014/main" id="{895A4F8F-112A-48EB-B415-38DBFF395A4C}"/>
+                <a16:creationId xmlns:a16="http://schemas.microsoft.com/office/drawing/2014/main" id="{B1CD9ED4-1AFA-46BD-A77F-29787A9BB0D1}"/>
               </a:ext>
             </a:extLst>
           </p:cNvPr>
@@ -12705,7 +12705,7 @@
           <p:cNvPr id="8" name="Loan roles use full terms. Cash and margin use 30 days. Thes">
             <a:extLst xmlns:a="http://schemas.openxmlformats.org/drawingml/2006/main">
               <a:ext uri="{FF2B5EF4-FFF2-40B4-BE49-F238E27FC236}">
-                <a16:creationId xmlns:a16="http://schemas.microsoft.com/office/drawing/2014/main" id="{8F42E2C1-1FCF-46A5-9656-79020681C7BA}"/>
+                <a16:creationId xmlns:a16="http://schemas.microsoft.com/office/drawing/2014/main" id="{FDA6EBA0-B328-46E3-8C2A-04A7032BA20E}"/>
               </a:ext>
             </a:extLst>
           </p:cNvPr>
@@ -12771,7 +12771,7 @@
     </p:spTree>
     <p:extLst>
       <p:ext uri="{BB962C8B-B14F-4D97-AF65-F5344CB8AC3E}">
-        <p14:creationId xmlns:p14="http://schemas.microsoft.com/office/powerpoint/2010/main" val="896440260"/>
+        <p14:creationId xmlns:p14="http://schemas.microsoft.com/office/powerpoint/2010/main" val="658521269"/>
       </p:ext>
     </p:extLst>
   </p:cSld>
@@ -12802,7 +12802,7 @@
           <p:cNvPr id="11" name="BizWizard">
             <a:extLst xmlns:a="http://schemas.openxmlformats.org/drawingml/2006/main">
               <a:ext uri="{FF2B5EF4-FFF2-40B4-BE49-F238E27FC236}">
-                <a16:creationId xmlns:a16="http://schemas.microsoft.com/office/drawing/2014/main" id="{7B0FDC69-746B-4218-98D5-AA91C885A1E1}"/>
+                <a16:creationId xmlns:a16="http://schemas.microsoft.com/office/drawing/2014/main" id="{0DFC9F01-D3EB-4681-8FB5-20BDF1307AA3}"/>
               </a:ext>
             </a:extLst>
           </p:cNvPr>
@@ -12870,7 +12870,7 @@
           <p:cNvPr id="2" name="15">
             <a:extLst xmlns:a="http://schemas.openxmlformats.org/drawingml/2006/main">
               <a:ext uri="{FF2B5EF4-FFF2-40B4-BE49-F238E27FC236}">
-                <a16:creationId xmlns:a16="http://schemas.microsoft.com/office/drawing/2014/main" id="{F9198643-5303-4F52-9219-01A451662C2F}"/>
+                <a16:creationId xmlns:a16="http://schemas.microsoft.com/office/drawing/2014/main" id="{A74B08A6-D6F0-4CB8-AE71-D36843AC72AB}"/>
               </a:ext>
             </a:extLst>
           </p:cNvPr>
@@ -12938,7 +12938,7 @@
           <p:cNvPr id="3" name="Slide heading">
             <a:extLst xmlns:a="http://schemas.openxmlformats.org/drawingml/2006/main">
               <a:ext uri="{FF2B5EF4-FFF2-40B4-BE49-F238E27FC236}">
-                <a16:creationId xmlns:a16="http://schemas.microsoft.com/office/drawing/2014/main" id="{83E9D63B-65A3-4BF7-821B-D60DDC3003CF}"/>
+                <a16:creationId xmlns:a16="http://schemas.microsoft.com/office/drawing/2014/main" id="{9B30348B-F572-4F25-ACE4-6AE267CA0533}"/>
               </a:ext>
             </a:extLst>
           </p:cNvPr>
@@ -13006,7 +13006,7 @@
           <p:cNvPr id="4" name="">
             <a:extLst xmlns:a="http://schemas.openxmlformats.org/drawingml/2006/main">
               <a:ext uri="{FF2B5EF4-FFF2-40B4-BE49-F238E27FC236}">
-                <a16:creationId xmlns:a16="http://schemas.microsoft.com/office/drawing/2014/main" id="{3DD467A7-2D1A-4FF6-9E8E-A8BBE582D292}"/>
+                <a16:creationId xmlns:a16="http://schemas.microsoft.com/office/drawing/2014/main" id="{A8416919-9B7A-478F-8826-F9361C7CFC28}"/>
               </a:ext>
             </a:extLst>
           </p:cNvPr>
@@ -13633,7 +13633,7 @@
           <p:cNvPr id="5" name="Backend checks">
             <a:extLst xmlns:a="http://schemas.openxmlformats.org/drawingml/2006/main">
               <a:ext uri="{FF2B5EF4-FFF2-40B4-BE49-F238E27FC236}">
-                <a16:creationId xmlns:a16="http://schemas.microsoft.com/office/drawing/2014/main" id="{25CF9C8B-4B36-418F-B361-398FF3DB3B06}"/>
+                <a16:creationId xmlns:a16="http://schemas.microsoft.com/office/drawing/2014/main" id="{5C4955EC-91B6-476A-9837-E1BFAC49F63D}"/>
               </a:ext>
             </a:extLst>
           </p:cNvPr>
@@ -13701,7 +13701,7 @@
           <p:cNvPr id="6" name="Token, role, tenant membership and employee shop assignment.">
             <a:extLst xmlns:a="http://schemas.openxmlformats.org/drawingml/2006/main">
               <a:ext uri="{FF2B5EF4-FFF2-40B4-BE49-F238E27FC236}">
-                <a16:creationId xmlns:a16="http://schemas.microsoft.com/office/drawing/2014/main" id="{CDDB9685-7736-48D5-8338-A4CAFD0B8AD2}"/>
+                <a16:creationId xmlns:a16="http://schemas.microsoft.com/office/drawing/2014/main" id="{A2091B71-4AFC-47FD-AD96-CD037816B687}"/>
               </a:ext>
             </a:extLst>
           </p:cNvPr>
@@ -13792,7 +13792,7 @@
           <p:cNvPr id="7" name="Financial safeguards">
             <a:extLst xmlns:a="http://schemas.openxmlformats.org/drawingml/2006/main">
               <a:ext uri="{FF2B5EF4-FFF2-40B4-BE49-F238E27FC236}">
-                <a16:creationId xmlns:a16="http://schemas.microsoft.com/office/drawing/2014/main" id="{C13BED71-7CFA-47E0-81F3-CB53EB1BD2B9}"/>
+                <a16:creationId xmlns:a16="http://schemas.microsoft.com/office/drawing/2014/main" id="{2D9FEE7F-2ADC-422C-89E5-FA3E702DFEC3}"/>
               </a:ext>
             </a:extLst>
           </p:cNvPr>
@@ -13860,7 +13860,7 @@
           <p:cNvPr id="8" name="Scoped references, allowed IDs and transactional state chang">
             <a:extLst xmlns:a="http://schemas.openxmlformats.org/drawingml/2006/main">
               <a:ext uri="{FF2B5EF4-FFF2-40B4-BE49-F238E27FC236}">
-                <a16:creationId xmlns:a16="http://schemas.microsoft.com/office/drawing/2014/main" id="{17672B7D-5E57-4971-A008-CA0614CE51E6}"/>
+                <a16:creationId xmlns:a16="http://schemas.microsoft.com/office/drawing/2014/main" id="{F2CABD24-2043-4A8A-9F7B-AF5FB6CD7C04}"/>
               </a:ext>
             </a:extLst>
           </p:cNvPr>
@@ -13951,7 +13951,7 @@
           <p:cNvPr id="9" name="Remaining risks">
             <a:extLst xmlns:a="http://schemas.openxmlformats.org/drawingml/2006/main">
               <a:ext uri="{FF2B5EF4-FFF2-40B4-BE49-F238E27FC236}">
-                <a16:creationId xmlns:a16="http://schemas.microsoft.com/office/drawing/2014/main" id="{6CE3D6B5-3585-4EB8-977D-6516A2F1B703}"/>
+                <a16:creationId xmlns:a16="http://schemas.microsoft.com/office/drawing/2014/main" id="{58108974-C0C3-4520-BD92-6AA8F2A5FCEA}"/>
               </a:ext>
             </a:extLst>
           </p:cNvPr>
@@ -14019,7 +14019,7 @@
           <p:cNvPr id="10" name="Browser token storage, incomplete redaction, audit gaps and ">
             <a:extLst xmlns:a="http://schemas.openxmlformats.org/drawingml/2006/main">
               <a:ext uri="{FF2B5EF4-FFF2-40B4-BE49-F238E27FC236}">
-                <a16:creationId xmlns:a16="http://schemas.microsoft.com/office/drawing/2014/main" id="{0D5B0BDA-FF13-4A01-A48A-31AB6D90AC94}"/>
+                <a16:creationId xmlns:a16="http://schemas.microsoft.com/office/drawing/2014/main" id="{20587FFA-94E6-4271-84CB-3726B362F504}"/>
               </a:ext>
             </a:extLst>
           </p:cNvPr>
@@ -14085,7 +14085,7 @@
     </p:spTree>
     <p:extLst>
       <p:ext uri="{BB962C8B-B14F-4D97-AF65-F5344CB8AC3E}">
-        <p14:creationId xmlns:p14="http://schemas.microsoft.com/office/powerpoint/2010/main" val="723493749"/>
+        <p14:creationId xmlns:p14="http://schemas.microsoft.com/office/powerpoint/2010/main" val="1106667680"/>
       </p:ext>
     </p:extLst>
   </p:cSld>
@@ -14116,7 +14116,7 @@
           <p:cNvPr id="13" name="BizWizard">
             <a:extLst xmlns:a="http://schemas.openxmlformats.org/drawingml/2006/main">
               <a:ext uri="{FF2B5EF4-FFF2-40B4-BE49-F238E27FC236}">
-                <a16:creationId xmlns:a16="http://schemas.microsoft.com/office/drawing/2014/main" id="{B1E2ABB9-18C1-4830-84C4-7E0616DC4B98}"/>
+                <a16:creationId xmlns:a16="http://schemas.microsoft.com/office/drawing/2014/main" id="{9E6BAA25-75E5-42D1-9453-B812F3CFDD04}"/>
               </a:ext>
             </a:extLst>
           </p:cNvPr>
@@ -14184,7 +14184,7 @@
           <p:cNvPr id="2" name="16">
             <a:extLst xmlns:a="http://schemas.openxmlformats.org/drawingml/2006/main">
               <a:ext uri="{FF2B5EF4-FFF2-40B4-BE49-F238E27FC236}">
-                <a16:creationId xmlns:a16="http://schemas.microsoft.com/office/drawing/2014/main" id="{5FD279A4-DC14-4DD9-A775-879918757BE1}"/>
+                <a16:creationId xmlns:a16="http://schemas.microsoft.com/office/drawing/2014/main" id="{A3D5E16F-1730-49F2-A9CC-6395CD7E6BEF}"/>
               </a:ext>
             </a:extLst>
           </p:cNvPr>
@@ -14252,7 +14252,7 @@
           <p:cNvPr id="3" name="Slide heading">
             <a:extLst xmlns:a="http://schemas.openxmlformats.org/drawingml/2006/main">
               <a:ext uri="{FF2B5EF4-FFF2-40B4-BE49-F238E27FC236}">
-                <a16:creationId xmlns:a16="http://schemas.microsoft.com/office/drawing/2014/main" id="{7EF749D2-DC31-455E-853B-296564F45BB6}"/>
+                <a16:creationId xmlns:a16="http://schemas.microsoft.com/office/drawing/2014/main" id="{F54BBA9D-86FE-4B01-8285-790F1AE06B09}"/>
               </a:ext>
             </a:extLst>
           </p:cNvPr>
@@ -14320,7 +14320,7 @@
           <p:cNvPr id="4" name="Live AI versus pinned rules">
             <a:extLst xmlns:a="http://schemas.openxmlformats.org/drawingml/2006/main">
               <a:ext uri="{FF2B5EF4-FFF2-40B4-BE49-F238E27FC236}">
-                <a16:creationId xmlns:a16="http://schemas.microsoft.com/office/drawing/2014/main" id="{BFA30149-D913-4F95-A84F-294D25A9938A}"/>
+                <a16:creationId xmlns:a16="http://schemas.microsoft.com/office/drawing/2014/main" id="{8784532C-5CB7-4CF9-9AC9-A976A4B47452}"/>
               </a:ext>
             </a:extLst>
           </p:cNvPr>
@@ -14388,7 +14388,7 @@
           <p:cNvPr id="5" name="Three synthetic risk cases across four roles">
             <a:extLst xmlns:a="http://schemas.openxmlformats.org/drawingml/2006/main">
               <a:ext uri="{FF2B5EF4-FFF2-40B4-BE49-F238E27FC236}">
-                <a16:creationId xmlns:a16="http://schemas.microsoft.com/office/drawing/2014/main" id="{4D049267-01D1-426A-A65C-49050310E35E}"/>
+                <a16:creationId xmlns:a16="http://schemas.microsoft.com/office/drawing/2014/main" id="{1972910A-FD67-4423-A792-3DBA6659E32D}"/>
               </a:ext>
             </a:extLst>
           </p:cNvPr>
@@ -14456,7 +14456,7 @@
           <p:cNvPr id="6" name="Chart">
             <a:extLst xmlns:a="http://schemas.openxmlformats.org/drawingml/2006/main">
               <a:ext uri="{FF2B5EF4-FFF2-40B4-BE49-F238E27FC236}">
-                <a16:creationId xmlns:a16="http://schemas.microsoft.com/office/drawing/2014/main" id="{149EF843-049B-4145-B34C-3B34392A152C}"/>
+                <a16:creationId xmlns:a16="http://schemas.microsoft.com/office/drawing/2014/main" id="{E67D0232-71D1-4071-BA27-8FF2FED2D6C4}"/>
               </a:ext>
             </a:extLst>
           </p:cNvPr>
@@ -14469,7 +14469,7 @@
         </p:xfrm>
         <a:graphic xmlns:a="http://schemas.openxmlformats.org/drawingml/2006/main">
           <a:graphicData uri="http://schemas.openxmlformats.org/drawingml/2006/chart">
-            <c:chart xmlns:r="http://schemas.openxmlformats.org/officeDocument/2006/relationships" xmlns:c="http://schemas.openxmlformats.org/drawingml/2006/chart" r:id="R761d12b571c64bdc"/>
+            <c:chart xmlns:r="http://schemas.openxmlformats.org/officeDocument/2006/relationships" xmlns:c="http://schemas.openxmlformats.org/drawingml/2006/chart" r:id="Ra2d90aaa3eac45a8"/>
           </a:graphicData>
         </a:graphic>
       </p:graphicFrame>
@@ -14478,7 +14478,7 @@
           <p:cNvPr id="7" name="Section rule">
             <a:extLst xmlns:a="http://schemas.openxmlformats.org/drawingml/2006/main">
               <a:ext uri="{FF2B5EF4-FFF2-40B4-BE49-F238E27FC236}">
-                <a16:creationId xmlns:a16="http://schemas.microsoft.com/office/drawing/2014/main" id="{A0D20EDC-52C9-44DE-9C5C-E840F6029A4F}"/>
+                <a16:creationId xmlns:a16="http://schemas.microsoft.com/office/drawing/2014/main" id="{CFAF3D8A-F4AD-4B8E-92BE-FA54B34107D2}"/>
               </a:ext>
             </a:extLst>
           </p:cNvPr>
@@ -14508,7 +14508,7 @@
           <p:cNvPr id="8" name="11">
             <a:extLst xmlns:a="http://schemas.openxmlformats.org/drawingml/2006/main">
               <a:ext uri="{FF2B5EF4-FFF2-40B4-BE49-F238E27FC236}">
-                <a16:creationId xmlns:a16="http://schemas.microsoft.com/office/drawing/2014/main" id="{721956AB-C1C6-425B-9997-5C492D638DDB}"/>
+                <a16:creationId xmlns:a16="http://schemas.microsoft.com/office/drawing/2014/main" id="{739C4785-43A7-4AB6-B8CF-B0D7CDA5F7DD}"/>
               </a:ext>
             </a:extLst>
           </p:cNvPr>
@@ -14576,7 +14576,7 @@
           <p:cNvPr id="9" name="integration tests passed">
             <a:extLst xmlns:a="http://schemas.openxmlformats.org/drawingml/2006/main">
               <a:ext uri="{FF2B5EF4-FFF2-40B4-BE49-F238E27FC236}">
-                <a16:creationId xmlns:a16="http://schemas.microsoft.com/office/drawing/2014/main" id="{7F732011-A6F4-4B48-866D-93247F35D4CE}"/>
+                <a16:creationId xmlns:a16="http://schemas.microsoft.com/office/drawing/2014/main" id="{A204728E-B438-4D6E-842A-09FA4BF421C4}"/>
               </a:ext>
             </a:extLst>
           </p:cNvPr>
@@ -14644,7 +14644,7 @@
           <p:cNvPr id="10" name="5 suites Zero failed or skipped Migrations applied">
             <a:extLst xmlns:a="http://schemas.openxmlformats.org/drawingml/2006/main">
               <a:ext uri="{FF2B5EF4-FFF2-40B4-BE49-F238E27FC236}">
-                <a16:creationId xmlns:a16="http://schemas.microsoft.com/office/drawing/2014/main" id="{3B3C8156-AD84-4F72-A7CC-AC4AA1D7DD3C}"/>
+                <a16:creationId xmlns:a16="http://schemas.microsoft.com/office/drawing/2014/main" id="{17E08440-B7C6-4C13-BEC6-350217C18B0C}"/>
               </a:ext>
             </a:extLst>
           </p:cNvPr>
@@ -14758,7 +14758,7 @@
           <p:cNvPr id="11" name="Cash integrity, permissions, concurrency and isolation">
             <a:extLst xmlns:a="http://schemas.openxmlformats.org/drawingml/2006/main">
               <a:ext uri="{FF2B5EF4-FFF2-40B4-BE49-F238E27FC236}">
-                <a16:creationId xmlns:a16="http://schemas.microsoft.com/office/drawing/2014/main" id="{D88CAB60-1F94-472E-B5A1-86E5AAA8952D}"/>
+                <a16:creationId xmlns:a16="http://schemas.microsoft.com/office/drawing/2014/main" id="{036C87A3-69A5-4925-9E62-DD5C6059F033}"/>
               </a:ext>
             </a:extLst>
           </p:cNvPr>
@@ -14849,7 +14849,7 @@
           <p:cNvPr id="12" name="4 AI wins, 5 rules wins, 3 ties. Synthetic outcomes do not e">
             <a:extLst xmlns:a="http://schemas.openxmlformats.org/drawingml/2006/main">
               <a:ext uri="{FF2B5EF4-FFF2-40B4-BE49-F238E27FC236}">
-                <a16:creationId xmlns:a16="http://schemas.microsoft.com/office/drawing/2014/main" id="{C600C30E-20E1-4A01-BDDC-03BB11CC6F15}"/>
+                <a16:creationId xmlns:a16="http://schemas.microsoft.com/office/drawing/2014/main" id="{B81895C2-CB08-46CC-AE39-A784F560EB08}"/>
               </a:ext>
             </a:extLst>
           </p:cNvPr>
@@ -14915,7 +14915,7 @@
     </p:spTree>
     <p:extLst>
       <p:ext uri="{BB962C8B-B14F-4D97-AF65-F5344CB8AC3E}">
-        <p14:creationId xmlns:p14="http://schemas.microsoft.com/office/powerpoint/2010/main" val="1243745733"/>
+        <p14:creationId xmlns:p14="http://schemas.microsoft.com/office/powerpoint/2010/main" val="1800241153"/>
       </p:ext>
     </p:extLst>
   </p:cSld>
@@ -14946,7 +14946,7 @@
           <p:cNvPr id="8" name="BizWizard">
             <a:extLst xmlns:a="http://schemas.openxmlformats.org/drawingml/2006/main">
               <a:ext uri="{FF2B5EF4-FFF2-40B4-BE49-F238E27FC236}">
-                <a16:creationId xmlns:a16="http://schemas.microsoft.com/office/drawing/2014/main" id="{AB65B51D-353D-4608-BA27-8BFE4746EC62}"/>
+                <a16:creationId xmlns:a16="http://schemas.microsoft.com/office/drawing/2014/main" id="{88869C24-46B2-4D21-83C4-CB244C282084}"/>
               </a:ext>
             </a:extLst>
           </p:cNvPr>
@@ -15014,7 +15014,7 @@
           <p:cNvPr id="2" name="17">
             <a:extLst xmlns:a="http://schemas.openxmlformats.org/drawingml/2006/main">
               <a:ext uri="{FF2B5EF4-FFF2-40B4-BE49-F238E27FC236}">
-                <a16:creationId xmlns:a16="http://schemas.microsoft.com/office/drawing/2014/main" id="{06C3DC6E-A6CC-4389-A4DF-B65741C6BF33}"/>
+                <a16:creationId xmlns:a16="http://schemas.microsoft.com/office/drawing/2014/main" id="{ACF491EA-A06D-414B-82A0-8956D3585ED4}"/>
               </a:ext>
             </a:extLst>
           </p:cNvPr>
@@ -15082,7 +15082,7 @@
           <p:cNvPr id="3" name="Slide heading">
             <a:extLst xmlns:a="http://schemas.openxmlformats.org/drawingml/2006/main">
               <a:ext uri="{FF2B5EF4-FFF2-40B4-BE49-F238E27FC236}">
-                <a16:creationId xmlns:a16="http://schemas.microsoft.com/office/drawing/2014/main" id="{6110F731-4171-4305-A437-BACA041D6693}"/>
+                <a16:creationId xmlns:a16="http://schemas.microsoft.com/office/drawing/2014/main" id="{EFA63BFF-DFB9-4DE4-ABC5-3CE2C0782C65}"/>
               </a:ext>
             </a:extLst>
           </p:cNvPr>
@@ -15150,7 +15150,7 @@
           <p:cNvPr id="4" name="Daily operations and financial decisions, connected in one s">
             <a:extLst xmlns:a="http://schemas.openxmlformats.org/drawingml/2006/main">
               <a:ext uri="{FF2B5EF4-FFF2-40B4-BE49-F238E27FC236}">
-                <a16:creationId xmlns:a16="http://schemas.microsoft.com/office/drawing/2014/main" id="{29B404F3-4398-4885-BAE4-C2B21A58103A}"/>
+                <a16:creationId xmlns:a16="http://schemas.microsoft.com/office/drawing/2014/main" id="{805D5AA3-19C2-4217-8E9A-1CCE707DB730}"/>
               </a:ext>
             </a:extLst>
           </p:cNvPr>
@@ -15241,7 +15241,7 @@
           <p:cNvPr id="5" name="Manage the business, then use its records to review financin">
             <a:extLst xmlns:a="http://schemas.openxmlformats.org/drawingml/2006/main">
               <a:ext uri="{FF2B5EF4-FFF2-40B4-BE49-F238E27FC236}">
-                <a16:creationId xmlns:a16="http://schemas.microsoft.com/office/drawing/2014/main" id="{30D65BD1-901F-4770-9AA0-392F35977DDF}"/>
+                <a16:creationId xmlns:a16="http://schemas.microsoft.com/office/drawing/2014/main" id="{D20A1882-9627-406B-97DD-9FC4F4F2A3A1}"/>
               </a:ext>
             </a:extLst>
           </p:cNvPr>
@@ -15332,7 +15332,7 @@
           <p:cNvPr id="6" name="bizwizard-lake.vercel.app">
             <a:extLst xmlns:a="http://schemas.openxmlformats.org/drawingml/2006/main">
               <a:ext uri="{FF2B5EF4-FFF2-40B4-BE49-F238E27FC236}">
-                <a16:creationId xmlns:a16="http://schemas.microsoft.com/office/drawing/2014/main" id="{05887F5F-C793-4F39-8DC5-E9FECF0C6511}"/>
+                <a16:creationId xmlns:a16="http://schemas.microsoft.com/office/drawing/2014/main" id="{8A842367-068C-443D-B663-06DD17C893D8}"/>
               </a:ext>
             </a:extLst>
           </p:cNvPr>
@@ -15389,7 +15389,7 @@
                 <a:latin typeface="Arial"/>
                 <a:ea typeface="Arial"/>
                 <a:cs typeface="Arial"/>
-                <a:hlinkClick xmlns:r="http://schemas.openxmlformats.org/officeDocument/2006/relationships" r:id="R101ca42fc96f423b"/>
+                <a:hlinkClick xmlns:r="http://schemas.openxmlformats.org/officeDocument/2006/relationships" r:id="Refa6e2abe7cf4697"/>
               </a:rPr>
               <a:t>bizwizard-lake.vercel.app</a:t>
             </a:r>
@@ -15401,7 +15401,7 @@
           <p:cNvPr id="7" name="Working sandbox. No external lender contact or bank transfer">
             <a:extLst xmlns:a="http://schemas.openxmlformats.org/drawingml/2006/main">
               <a:ext uri="{FF2B5EF4-FFF2-40B4-BE49-F238E27FC236}">
-                <a16:creationId xmlns:a16="http://schemas.microsoft.com/office/drawing/2014/main" id="{683CB7D7-BB40-4C28-92D2-50886C286298}"/>
+                <a16:creationId xmlns:a16="http://schemas.microsoft.com/office/drawing/2014/main" id="{0F5D6540-5A8B-4EB6-8C2E-764DA4388604}"/>
               </a:ext>
             </a:extLst>
           </p:cNvPr>
@@ -15467,7 +15467,7 @@
     </p:spTree>
     <p:extLst>
       <p:ext uri="{BB962C8B-B14F-4D97-AF65-F5344CB8AC3E}">
-        <p14:creationId xmlns:p14="http://schemas.microsoft.com/office/powerpoint/2010/main" val="376876870"/>
+        <p14:creationId xmlns:p14="http://schemas.microsoft.com/office/powerpoint/2010/main" val="1185454520"/>
       </p:ext>
     </p:extLst>
   </p:cSld>
@@ -15498,7 +15498,7 @@
           <p:cNvPr id="15" name="">
             <a:extLst xmlns:a="http://schemas.openxmlformats.org/drawingml/2006/main">
               <a:ext uri="{FF2B5EF4-FFF2-40B4-BE49-F238E27FC236}">
-                <a16:creationId xmlns:a16="http://schemas.microsoft.com/office/drawing/2014/main" id="{11878BCE-E420-4B7E-8338-65F031610B25}"/>
+                <a16:creationId xmlns:a16="http://schemas.microsoft.com/office/drawing/2014/main" id="{FA9047C3-D047-4C88-9DBA-80432A5C8677}"/>
               </a:ext>
             </a:extLst>
           </p:cNvPr>
@@ -15530,7 +15530,7 @@
           <p:cNvPr id="14" name="">
             <a:extLst xmlns:a="http://schemas.openxmlformats.org/drawingml/2006/main">
               <a:ext uri="{FF2B5EF4-FFF2-40B4-BE49-F238E27FC236}">
-                <a16:creationId xmlns:a16="http://schemas.microsoft.com/office/drawing/2014/main" id="{F6795FB9-F704-41F3-AACF-F5283858122F}"/>
+                <a16:creationId xmlns:a16="http://schemas.microsoft.com/office/drawing/2014/main" id="{52F3C881-B0AD-4991-A697-8137CDB01616}"/>
               </a:ext>
             </a:extLst>
           </p:cNvPr>
@@ -15562,7 +15562,7 @@
           <p:cNvPr id="21" name="BizWizard">
             <a:extLst xmlns:a="http://schemas.openxmlformats.org/drawingml/2006/main">
               <a:ext uri="{FF2B5EF4-FFF2-40B4-BE49-F238E27FC236}">
-                <a16:creationId xmlns:a16="http://schemas.microsoft.com/office/drawing/2014/main" id="{854BEC73-0D2F-4FAE-A337-F6F28614A686}"/>
+                <a16:creationId xmlns:a16="http://schemas.microsoft.com/office/drawing/2014/main" id="{BAF563F5-1B78-4A71-983B-24705F681D89}"/>
               </a:ext>
             </a:extLst>
           </p:cNvPr>
@@ -15630,7 +15630,7 @@
           <p:cNvPr id="2" name="02">
             <a:extLst xmlns:a="http://schemas.openxmlformats.org/drawingml/2006/main">
               <a:ext uri="{FF2B5EF4-FFF2-40B4-BE49-F238E27FC236}">
-                <a16:creationId xmlns:a16="http://schemas.microsoft.com/office/drawing/2014/main" id="{2606CE89-F215-47F7-85FD-1DD5FD722535}"/>
+                <a16:creationId xmlns:a16="http://schemas.microsoft.com/office/drawing/2014/main" id="{1A15D2DA-B796-4A2D-906C-50F126BAE840}"/>
               </a:ext>
             </a:extLst>
           </p:cNvPr>
@@ -15698,7 +15698,7 @@
           <p:cNvPr id="3" name="Slide heading">
             <a:extLst xmlns:a="http://schemas.openxmlformats.org/drawingml/2006/main">
               <a:ext uri="{FF2B5EF4-FFF2-40B4-BE49-F238E27FC236}">
-                <a16:creationId xmlns:a16="http://schemas.microsoft.com/office/drawing/2014/main" id="{4B3F2401-DDC1-49F5-AFC0-09C174889EB2}"/>
+                <a16:creationId xmlns:a16="http://schemas.microsoft.com/office/drawing/2014/main" id="{7ED26A0D-50FA-40DB-BA9D-990EC2BAC870}"/>
               </a:ext>
             </a:extLst>
           </p:cNvPr>
@@ -15766,7 +15766,7 @@
           <p:cNvPr id="4" name="An illustrative owner scenario">
             <a:extLst xmlns:a="http://schemas.openxmlformats.org/drawingml/2006/main">
               <a:ext uri="{FF2B5EF4-FFF2-40B4-BE49-F238E27FC236}">
-                <a16:creationId xmlns:a16="http://schemas.microsoft.com/office/drawing/2014/main" id="{6F5D45E0-F713-416B-9D49-1944EF69C5E3}"/>
+                <a16:creationId xmlns:a16="http://schemas.microsoft.com/office/drawing/2014/main" id="{FDEDB4EC-675B-45C3-A661-D0A882EA6C4C}"/>
               </a:ext>
             </a:extLst>
           </p:cNvPr>
@@ -15834,7 +15834,7 @@
           <p:cNvPr id="5" name="Stock on the shelf">
             <a:extLst xmlns:a="http://schemas.openxmlformats.org/drawingml/2006/main">
               <a:ext uri="{FF2B5EF4-FFF2-40B4-BE49-F238E27FC236}">
-                <a16:creationId xmlns:a16="http://schemas.microsoft.com/office/drawing/2014/main" id="{E4A957C9-C9CF-48C6-A341-7527152AC712}"/>
+                <a16:creationId xmlns:a16="http://schemas.microsoft.com/office/drawing/2014/main" id="{06C8F4E4-278A-4D1B-88CD-EF5F8431C464}"/>
               </a:ext>
             </a:extLst>
           </p:cNvPr>
@@ -15866,7 +15866,7 @@
           <p:cNvPr id="6" name="Stock on the shelf">
             <a:extLst xmlns:a="http://schemas.openxmlformats.org/drawingml/2006/main">
               <a:ext uri="{FF2B5EF4-FFF2-40B4-BE49-F238E27FC236}">
-                <a16:creationId xmlns:a16="http://schemas.microsoft.com/office/drawing/2014/main" id="{ED29C7D7-5869-4EE6-9312-9E71EE29D3AA}"/>
+                <a16:creationId xmlns:a16="http://schemas.microsoft.com/office/drawing/2014/main" id="{76878557-E6C7-46FA-B398-AACEC39B412A}"/>
               </a:ext>
             </a:extLst>
           </p:cNvPr>
@@ -15934,7 +15934,7 @@
           <p:cNvPr id="7" name="Cash has already paid for inventory">
             <a:extLst xmlns:a="http://schemas.openxmlformats.org/drawingml/2006/main">
               <a:ext uri="{FF2B5EF4-FFF2-40B4-BE49-F238E27FC236}">
-                <a16:creationId xmlns:a16="http://schemas.microsoft.com/office/drawing/2014/main" id="{26DE0CAA-21D5-4C24-9D4B-736AD4E89EEE}"/>
+                <a16:creationId xmlns:a16="http://schemas.microsoft.com/office/drawing/2014/main" id="{3EBEA331-A234-4D32-8FA2-CE9768B3CFB1}"/>
               </a:ext>
             </a:extLst>
           </p:cNvPr>
@@ -16025,7 +16025,7 @@
           <p:cNvPr id="8" name="Sales on credit">
             <a:extLst xmlns:a="http://schemas.openxmlformats.org/drawingml/2006/main">
               <a:ext uri="{FF2B5EF4-FFF2-40B4-BE49-F238E27FC236}">
-                <a16:creationId xmlns:a16="http://schemas.microsoft.com/office/drawing/2014/main" id="{A94762A2-038C-4296-A1CB-5A5AC418F9D2}"/>
+                <a16:creationId xmlns:a16="http://schemas.microsoft.com/office/drawing/2014/main" id="{60849453-1E6D-4BBA-90A2-5C53B4706077}"/>
               </a:ext>
             </a:extLst>
           </p:cNvPr>
@@ -16057,7 +16057,7 @@
           <p:cNvPr id="9" name="Sales on credit">
             <a:extLst xmlns:a="http://schemas.openxmlformats.org/drawingml/2006/main">
               <a:ext uri="{FF2B5EF4-FFF2-40B4-BE49-F238E27FC236}">
-                <a16:creationId xmlns:a16="http://schemas.microsoft.com/office/drawing/2014/main" id="{216A4712-2886-411E-9C28-CC98428CC0C4}"/>
+                <a16:creationId xmlns:a16="http://schemas.microsoft.com/office/drawing/2014/main" id="{ECAE05B0-39E9-41DF-8E71-32E798C182B6}"/>
               </a:ext>
             </a:extLst>
           </p:cNvPr>
@@ -16125,7 +16125,7 @@
           <p:cNvPr id="10" name="Customers still owe the shop">
             <a:extLst xmlns:a="http://schemas.openxmlformats.org/drawingml/2006/main">
               <a:ext uri="{FF2B5EF4-FFF2-40B4-BE49-F238E27FC236}">
-                <a16:creationId xmlns:a16="http://schemas.microsoft.com/office/drawing/2014/main" id="{9CCAA661-EF4E-4C9C-9043-C0CCADA3363F}"/>
+                <a16:creationId xmlns:a16="http://schemas.microsoft.com/office/drawing/2014/main" id="{1758DE7F-326D-4A40-AD32-6C35294FADDE}"/>
               </a:ext>
             </a:extLst>
           </p:cNvPr>
@@ -16216,7 +16216,7 @@
           <p:cNvPr id="11" name="Bills approaching">
             <a:extLst xmlns:a="http://schemas.openxmlformats.org/drawingml/2006/main">
               <a:ext uri="{FF2B5EF4-FFF2-40B4-BE49-F238E27FC236}">
-                <a16:creationId xmlns:a16="http://schemas.microsoft.com/office/drawing/2014/main" id="{397970B1-9184-4599-8239-EB8A2AECC420}"/>
+                <a16:creationId xmlns:a16="http://schemas.microsoft.com/office/drawing/2014/main" id="{3C52BD32-EA3D-4904-8FE7-FB9E90D4FD2E}"/>
               </a:ext>
             </a:extLst>
           </p:cNvPr>
@@ -16248,7 +16248,7 @@
           <p:cNvPr id="12" name="Bills approaching">
             <a:extLst xmlns:a="http://schemas.openxmlformats.org/drawingml/2006/main">
               <a:ext uri="{FF2B5EF4-FFF2-40B4-BE49-F238E27FC236}">
-                <a16:creationId xmlns:a16="http://schemas.microsoft.com/office/drawing/2014/main" id="{6EF2E204-8C28-49D5-A84F-A3677FBBA84C}"/>
+                <a16:creationId xmlns:a16="http://schemas.microsoft.com/office/drawing/2014/main" id="{7A81B2FB-3981-4438-9668-05DC97EC5A0B}"/>
               </a:ext>
             </a:extLst>
           </p:cNvPr>
@@ -16316,7 +16316,7 @@
           <p:cNvPr id="13" name="Rent and suppliers need payment">
             <a:extLst xmlns:a="http://schemas.openxmlformats.org/drawingml/2006/main">
               <a:ext uri="{FF2B5EF4-FFF2-40B4-BE49-F238E27FC236}">
-                <a16:creationId xmlns:a16="http://schemas.microsoft.com/office/drawing/2014/main" id="{D23EEBF3-5669-45DB-9A8F-73BE16DEE057}"/>
+                <a16:creationId xmlns:a16="http://schemas.microsoft.com/office/drawing/2014/main" id="{2BE00214-FE24-4970-A0F9-B3F7D357B59B}"/>
               </a:ext>
             </a:extLst>
           </p:cNvPr>
@@ -16407,7 +16407,7 @@
           <p:cNvPr id="16" name="The owner’s question">
             <a:extLst xmlns:a="http://schemas.openxmlformats.org/drawingml/2006/main">
               <a:ext uri="{FF2B5EF4-FFF2-40B4-BE49-F238E27FC236}">
-                <a16:creationId xmlns:a16="http://schemas.microsoft.com/office/drawing/2014/main" id="{B885EF89-A382-4B1E-A96D-DE4778303570}"/>
+                <a16:creationId xmlns:a16="http://schemas.microsoft.com/office/drawing/2014/main" id="{2E4D5D60-236D-4E0E-B025-A5B77D787557}"/>
               </a:ext>
             </a:extLst>
           </p:cNvPr>
@@ -16475,7 +16475,7 @@
           <p:cNvPr id="17" name="“Can I pay and restock?”">
             <a:extLst xmlns:a="http://schemas.openxmlformats.org/drawingml/2006/main">
               <a:ext uri="{FF2B5EF4-FFF2-40B4-BE49-F238E27FC236}">
-                <a16:creationId xmlns:a16="http://schemas.microsoft.com/office/drawing/2014/main" id="{2ADB2FFD-A35E-4805-B203-237C641B8AF2}"/>
+                <a16:creationId xmlns:a16="http://schemas.microsoft.com/office/drawing/2014/main" id="{9934E415-AE19-4BB9-8A3A-88EB6315620B}"/>
               </a:ext>
             </a:extLst>
           </p:cNvPr>
@@ -16566,7 +16566,7 @@
           <p:cNvPr id="18" name="Section rule">
             <a:extLst xmlns:a="http://schemas.openxmlformats.org/drawingml/2006/main">
               <a:ext uri="{FF2B5EF4-FFF2-40B4-BE49-F238E27FC236}">
-                <a16:creationId xmlns:a16="http://schemas.microsoft.com/office/drawing/2014/main" id="{FF527961-7BE0-4218-A0E6-C7AC39EBB415}"/>
+                <a16:creationId xmlns:a16="http://schemas.microsoft.com/office/drawing/2014/main" id="{333C2492-4D5B-4544-916E-119291D133DF}"/>
               </a:ext>
             </a:extLst>
           </p:cNvPr>
@@ -16596,7 +16596,7 @@
           <p:cNvPr id="19" name="Sales, stock and cash answer different questions.">
             <a:extLst xmlns:a="http://schemas.openxmlformats.org/drawingml/2006/main">
               <a:ext uri="{FF2B5EF4-FFF2-40B4-BE49-F238E27FC236}">
-                <a16:creationId xmlns:a16="http://schemas.microsoft.com/office/drawing/2014/main" id="{6D96D044-48C2-4B63-9196-E49CBA169DC9}"/>
+                <a16:creationId xmlns:a16="http://schemas.microsoft.com/office/drawing/2014/main" id="{ACE01497-91FA-4518-A643-427F833119F1}"/>
               </a:ext>
             </a:extLst>
           </p:cNvPr>
@@ -16664,7 +16664,7 @@
           <p:cNvPr id="20" name="The decision needs payment timing, financing terms and produ">
             <a:extLst xmlns:a="http://schemas.openxmlformats.org/drawingml/2006/main">
               <a:ext uri="{FF2B5EF4-FFF2-40B4-BE49-F238E27FC236}">
-                <a16:creationId xmlns:a16="http://schemas.microsoft.com/office/drawing/2014/main" id="{03DBED36-C39F-477E-BEA7-C1EA869C428F}"/>
+                <a16:creationId xmlns:a16="http://schemas.microsoft.com/office/drawing/2014/main" id="{B7B0141E-621C-44A9-92E9-9CF433C055C3}"/>
               </a:ext>
             </a:extLst>
           </p:cNvPr>
@@ -16730,7 +16730,7 @@
     </p:spTree>
     <p:extLst>
       <p:ext uri="{BB962C8B-B14F-4D97-AF65-F5344CB8AC3E}">
-        <p14:creationId xmlns:p14="http://schemas.microsoft.com/office/powerpoint/2010/main" val="509984155"/>
+        <p14:creationId xmlns:p14="http://schemas.microsoft.com/office/powerpoint/2010/main" val="486013551"/>
       </p:ext>
     </p:extLst>
   </p:cSld>
@@ -16761,7 +16761,7 @@
           <p:cNvPr id="13" name="BizWizard">
             <a:extLst xmlns:a="http://schemas.openxmlformats.org/drawingml/2006/main">
               <a:ext uri="{FF2B5EF4-FFF2-40B4-BE49-F238E27FC236}">
-                <a16:creationId xmlns:a16="http://schemas.microsoft.com/office/drawing/2014/main" id="{9A02DD0F-B5EA-4659-BA7A-1D7933C97F15}"/>
+                <a16:creationId xmlns:a16="http://schemas.microsoft.com/office/drawing/2014/main" id="{07B78669-C009-4E2C-BC6A-B5C25EC0016F}"/>
               </a:ext>
             </a:extLst>
           </p:cNvPr>
@@ -16829,7 +16829,7 @@
           <p:cNvPr id="2" name="03">
             <a:extLst xmlns:a="http://schemas.openxmlformats.org/drawingml/2006/main">
               <a:ext uri="{FF2B5EF4-FFF2-40B4-BE49-F238E27FC236}">
-                <a16:creationId xmlns:a16="http://schemas.microsoft.com/office/drawing/2014/main" id="{CEB1A901-294D-4C1C-9DB0-945D76937E75}"/>
+                <a16:creationId xmlns:a16="http://schemas.microsoft.com/office/drawing/2014/main" id="{F1A6DC53-2D07-44CF-9CA1-B055F90B5A12}"/>
               </a:ext>
             </a:extLst>
           </p:cNvPr>
@@ -16897,7 +16897,7 @@
           <p:cNvPr id="3" name="Slide heading">
             <a:extLst xmlns:a="http://schemas.openxmlformats.org/drawingml/2006/main">
               <a:ext uri="{FF2B5EF4-FFF2-40B4-BE49-F238E27FC236}">
-                <a16:creationId xmlns:a16="http://schemas.microsoft.com/office/drawing/2014/main" id="{8CAEEC71-57B1-465E-9610-04A647E4A052}"/>
+                <a16:creationId xmlns:a16="http://schemas.microsoft.com/office/drawing/2014/main" id="{66275F73-F1E6-42FD-9545-0F4566252808}"/>
               </a:ext>
             </a:extLst>
           </p:cNvPr>
@@ -16965,7 +16965,7 @@
           <p:cNvPr id="4" name="Which financing fits?">
             <a:extLst xmlns:a="http://schemas.openxmlformats.org/drawingml/2006/main">
               <a:ext uri="{FF2B5EF4-FFF2-40B4-BE49-F238E27FC236}">
-                <a16:creationId xmlns:a16="http://schemas.microsoft.com/office/drawing/2014/main" id="{D742F713-8D65-465C-848F-7A146FE98DF8}"/>
+                <a16:creationId xmlns:a16="http://schemas.microsoft.com/office/drawing/2014/main" id="{45DBBC21-A3B8-418C-AE9C-930FF4D808E9}"/>
               </a:ext>
             </a:extLst>
           </p:cNvPr>
@@ -17033,7 +17033,7 @@
           <p:cNvPr id="5" name="Compare eligibility, cost and repayment capacity.">
             <a:extLst xmlns:a="http://schemas.openxmlformats.org/drawingml/2006/main">
               <a:ext uri="{FF2B5EF4-FFF2-40B4-BE49-F238E27FC236}">
-                <a16:creationId xmlns:a16="http://schemas.microsoft.com/office/drawing/2014/main" id="{D5643860-713F-4B9D-ABC6-8D9DC3E77B0A}"/>
+                <a16:creationId xmlns:a16="http://schemas.microsoft.com/office/drawing/2014/main" id="{DF372F56-A349-4D0A-BF44-0F97AF3533A0}"/>
               </a:ext>
             </a:extLst>
           </p:cNvPr>
@@ -17124,7 +17124,7 @@
           <p:cNvPr id="6" name="Will cash run short?">
             <a:extLst xmlns:a="http://schemas.openxmlformats.org/drawingml/2006/main">
               <a:ext uri="{FF2B5EF4-FFF2-40B4-BE49-F238E27FC236}">
-                <a16:creationId xmlns:a16="http://schemas.microsoft.com/office/drawing/2014/main" id="{130F6575-B9CD-405A-9409-340B5796F16F}"/>
+                <a16:creationId xmlns:a16="http://schemas.microsoft.com/office/drawing/2014/main" id="{789F9795-37B8-4F38-8AFF-2A4DA4855C84}"/>
               </a:ext>
             </a:extLst>
           </p:cNvPr>
@@ -17192,7 +17192,7 @@
           <p:cNvPr id="7" name="Project dated balances and review alerts.">
             <a:extLst xmlns:a="http://schemas.openxmlformats.org/drawingml/2006/main">
               <a:ext uri="{FF2B5EF4-FFF2-40B4-BE49-F238E27FC236}">
-                <a16:creationId xmlns:a16="http://schemas.microsoft.com/office/drawing/2014/main" id="{A0E503CD-54C5-45E6-B32D-F3AC227596C0}"/>
+                <a16:creationId xmlns:a16="http://schemas.microsoft.com/office/drawing/2014/main" id="{4A21D7D3-4C34-409A-ACF9-AF322941FD80}"/>
               </a:ext>
             </a:extLst>
           </p:cNvPr>
@@ -17283,7 +17283,7 @@
           <p:cNvPr id="8" name="Where is cash tied up?">
             <a:extLst xmlns:a="http://schemas.openxmlformats.org/drawingml/2006/main">
               <a:ext uri="{FF2B5EF4-FFF2-40B4-BE49-F238E27FC236}">
-                <a16:creationId xmlns:a16="http://schemas.microsoft.com/office/drawing/2014/main" id="{845247DB-BC0A-4CA7-874B-72BE8E6E6877}"/>
+                <a16:creationId xmlns:a16="http://schemas.microsoft.com/office/drawing/2014/main" id="{6E2D1891-3A0E-42C3-A720-59DDAF605C86}"/>
               </a:ext>
             </a:extLst>
           </p:cNvPr>
@@ -17351,7 +17351,7 @@
           <p:cNvPr id="9" name="Inspect product margins and working capital.">
             <a:extLst xmlns:a="http://schemas.openxmlformats.org/drawingml/2006/main">
               <a:ext uri="{FF2B5EF4-FFF2-40B4-BE49-F238E27FC236}">
-                <a16:creationId xmlns:a16="http://schemas.microsoft.com/office/drawing/2014/main" id="{DE548B43-C003-4B3E-A81F-F0572EBA9857}"/>
+                <a16:creationId xmlns:a16="http://schemas.microsoft.com/office/drawing/2014/main" id="{3EEDF249-2BA0-4FCD-AF26-CCFE194C15D1}"/>
               </a:ext>
             </a:extLst>
           </p:cNvPr>
@@ -17442,7 +17442,7 @@
           <p:cNvPr id="10" name="">
             <a:extLst xmlns:a="http://schemas.openxmlformats.org/drawingml/2006/main">
               <a:ext uri="{FF2B5EF4-FFF2-40B4-BE49-F238E27FC236}">
-                <a16:creationId xmlns:a16="http://schemas.microsoft.com/office/drawing/2014/main" id="{D0156553-1683-4D9E-A4DA-3C0E760C9097}"/>
+                <a16:creationId xmlns:a16="http://schemas.microsoft.com/office/drawing/2014/main" id="{5CAADB76-131D-4705-B15D-3D5190F3F983}"/>
               </a:ext>
             </a:extLst>
           </p:cNvPr>
@@ -17452,7 +17452,7 @@
           <p:nvPr/>
         </p:nvPicPr>
         <p:blipFill>
-          <a:blip xmlns:r="http://schemas.openxmlformats.org/officeDocument/2006/relationships" xmlns:a="http://schemas.openxmlformats.org/drawingml/2006/main" r:embed="R118175cc64274f8d"/>
+          <a:blip xmlns:r="http://schemas.openxmlformats.org/officeDocument/2006/relationships" xmlns:a="http://schemas.openxmlformats.org/drawingml/2006/main" r:embed="R4a4e5cc4d9b2403d"/>
           <a:stretch xmlns:a="http://schemas.openxmlformats.org/drawingml/2006/main"/>
         </p:blipFill>
         <p:spPr>
@@ -17470,7 +17470,7 @@
           <p:cNvPr id="11" name="">
             <a:extLst xmlns:a="http://schemas.openxmlformats.org/drawingml/2006/main">
               <a:ext uri="{FF2B5EF4-FFF2-40B4-BE49-F238E27FC236}">
-                <a16:creationId xmlns:a16="http://schemas.microsoft.com/office/drawing/2014/main" id="{3C5E2A19-CDD8-4E75-AD12-F35BB3B60852}"/>
+                <a16:creationId xmlns:a16="http://schemas.microsoft.com/office/drawing/2014/main" id="{9E117CA5-81F1-4D7E-8BBF-DE99A5D48ECB}"/>
               </a:ext>
             </a:extLst>
           </p:cNvPr>
@@ -17480,7 +17480,7 @@
           <p:nvPr/>
         </p:nvPicPr>
         <p:blipFill>
-          <a:blip xmlns:r="http://schemas.openxmlformats.org/officeDocument/2006/relationships" xmlns:a="http://schemas.openxmlformats.org/drawingml/2006/main" r:embed="Rf2d718889f924e14"/>
+          <a:blip xmlns:r="http://schemas.openxmlformats.org/officeDocument/2006/relationships" xmlns:a="http://schemas.openxmlformats.org/drawingml/2006/main" r:embed="R4a0413ef7cb24a2a"/>
           <a:stretch xmlns:a="http://schemas.openxmlformats.org/drawingml/2006/main"/>
         </p:blipFill>
         <p:spPr>
@@ -17498,7 +17498,7 @@
           <p:cNvPr id="12" name="Inventory: live app with seeded demo records. Mobile view: i">
             <a:extLst xmlns:a="http://schemas.openxmlformats.org/drawingml/2006/main">
               <a:ext uri="{FF2B5EF4-FFF2-40B4-BE49-F238E27FC236}">
-                <a16:creationId xmlns:a16="http://schemas.microsoft.com/office/drawing/2014/main" id="{F3B89CEF-6231-4BB8-8EE4-81982C5AD3B7}"/>
+                <a16:creationId xmlns:a16="http://schemas.microsoft.com/office/drawing/2014/main" id="{D9825728-6B8E-4953-AD73-4A1871FF5F01}"/>
               </a:ext>
             </a:extLst>
           </p:cNvPr>
@@ -17564,7 +17564,7 @@
     </p:spTree>
     <p:extLst>
       <p:ext uri="{BB962C8B-B14F-4D97-AF65-F5344CB8AC3E}">
-        <p14:creationId xmlns:p14="http://schemas.microsoft.com/office/powerpoint/2010/main" val="746944480"/>
+        <p14:creationId xmlns:p14="http://schemas.microsoft.com/office/powerpoint/2010/main" val="1865403523"/>
       </p:ext>
     </p:extLst>
   </p:cSld>
@@ -17595,7 +17595,7 @@
           <p:cNvPr id="22" name="">
             <a:extLst xmlns:a="http://schemas.openxmlformats.org/drawingml/2006/main">
               <a:ext uri="{FF2B5EF4-FFF2-40B4-BE49-F238E27FC236}">
-                <a16:creationId xmlns:a16="http://schemas.microsoft.com/office/drawing/2014/main" id="{5E1F9F13-B296-4C18-9E5D-8818B4F7D520}"/>
+                <a16:creationId xmlns:a16="http://schemas.microsoft.com/office/drawing/2014/main" id="{D7A99B3A-EDB5-47DA-B32B-3C7CD85B1986}"/>
               </a:ext>
             </a:extLst>
           </p:cNvPr>
@@ -17627,7 +17627,7 @@
           <p:cNvPr id="21" name="">
             <a:extLst xmlns:a="http://schemas.openxmlformats.org/drawingml/2006/main">
               <a:ext uri="{FF2B5EF4-FFF2-40B4-BE49-F238E27FC236}">
-                <a16:creationId xmlns:a16="http://schemas.microsoft.com/office/drawing/2014/main" id="{84D48A8A-FB27-419B-98CF-C9E175E0F61E}"/>
+                <a16:creationId xmlns:a16="http://schemas.microsoft.com/office/drawing/2014/main" id="{10C49E9C-228C-4BC9-A06E-CAFF3D88FE4D}"/>
               </a:ext>
             </a:extLst>
           </p:cNvPr>
@@ -17659,7 +17659,7 @@
           <p:cNvPr id="20" name="">
             <a:extLst xmlns:a="http://schemas.openxmlformats.org/drawingml/2006/main">
               <a:ext uri="{FF2B5EF4-FFF2-40B4-BE49-F238E27FC236}">
-                <a16:creationId xmlns:a16="http://schemas.microsoft.com/office/drawing/2014/main" id="{F860A62F-09CA-41A8-8F45-DF88068C303B}"/>
+                <a16:creationId xmlns:a16="http://schemas.microsoft.com/office/drawing/2014/main" id="{7B760002-F957-46D1-9801-976333C8B8A9}"/>
               </a:ext>
             </a:extLst>
           </p:cNvPr>
@@ -17691,7 +17691,7 @@
           <p:cNvPr id="19" name="">
             <a:extLst xmlns:a="http://schemas.openxmlformats.org/drawingml/2006/main">
               <a:ext uri="{FF2B5EF4-FFF2-40B4-BE49-F238E27FC236}">
-                <a16:creationId xmlns:a16="http://schemas.microsoft.com/office/drawing/2014/main" id="{6425FD97-3D46-4D59-9834-C53C30BD3A26}"/>
+                <a16:creationId xmlns:a16="http://schemas.microsoft.com/office/drawing/2014/main" id="{3BB0EA43-8EAB-4D87-B8CA-63AACDB98182}"/>
               </a:ext>
             </a:extLst>
           </p:cNvPr>
@@ -17723,7 +17723,7 @@
           <p:cNvPr id="26" name="BizWizard">
             <a:extLst xmlns:a="http://schemas.openxmlformats.org/drawingml/2006/main">
               <a:ext uri="{FF2B5EF4-FFF2-40B4-BE49-F238E27FC236}">
-                <a16:creationId xmlns:a16="http://schemas.microsoft.com/office/drawing/2014/main" id="{9B0C3638-17B3-46A5-850F-EB9AA856DD8D}"/>
+                <a16:creationId xmlns:a16="http://schemas.microsoft.com/office/drawing/2014/main" id="{0E2EA047-AC4B-4F74-85A8-B68093EC382F}"/>
               </a:ext>
             </a:extLst>
           </p:cNvPr>
@@ -17791,7 +17791,7 @@
           <p:cNvPr id="2" name="04">
             <a:extLst xmlns:a="http://schemas.openxmlformats.org/drawingml/2006/main">
               <a:ext uri="{FF2B5EF4-FFF2-40B4-BE49-F238E27FC236}">
-                <a16:creationId xmlns:a16="http://schemas.microsoft.com/office/drawing/2014/main" id="{3001AC91-52DC-4375-B7AB-236BAE3748C2}"/>
+                <a16:creationId xmlns:a16="http://schemas.microsoft.com/office/drawing/2014/main" id="{7A0BFA8B-BD8F-4366-98B7-DCE777A20D26}"/>
               </a:ext>
             </a:extLst>
           </p:cNvPr>
@@ -17859,7 +17859,7 @@
           <p:cNvPr id="3" name="Slide heading">
             <a:extLst xmlns:a="http://schemas.openxmlformats.org/drawingml/2006/main">
               <a:ext uri="{FF2B5EF4-FFF2-40B4-BE49-F238E27FC236}">
-                <a16:creationId xmlns:a16="http://schemas.microsoft.com/office/drawing/2014/main" id="{11F20F56-597F-40F0-BEAD-1D3F2566FC04}"/>
+                <a16:creationId xmlns:a16="http://schemas.microsoft.com/office/drawing/2014/main" id="{61D43327-DDEE-4D95-80F8-A970ACBC00E7}"/>
               </a:ext>
             </a:extLst>
           </p:cNvPr>
@@ -17927,7 +17927,7 @@
           <p:cNvPr id="4" name="Shop records">
             <a:extLst xmlns:a="http://schemas.openxmlformats.org/drawingml/2006/main">
               <a:ext uri="{FF2B5EF4-FFF2-40B4-BE49-F238E27FC236}">
-                <a16:creationId xmlns:a16="http://schemas.microsoft.com/office/drawing/2014/main" id="{A6CC16AA-F371-4317-AA5F-DD6576BE313F}"/>
+                <a16:creationId xmlns:a16="http://schemas.microsoft.com/office/drawing/2014/main" id="{5D8A5807-3957-4854-BC32-312E6F8872EF}"/>
               </a:ext>
             </a:extLst>
           </p:cNvPr>
@@ -17959,7 +17959,7 @@
           <p:cNvPr id="5" name="Shop records">
             <a:extLst xmlns:a="http://schemas.openxmlformats.org/drawingml/2006/main">
               <a:ext uri="{FF2B5EF4-FFF2-40B4-BE49-F238E27FC236}">
-                <a16:creationId xmlns:a16="http://schemas.microsoft.com/office/drawing/2014/main" id="{142846CD-6FE2-49BD-8B65-0ECBDCCCF819}"/>
+                <a16:creationId xmlns:a16="http://schemas.microsoft.com/office/drawing/2014/main" id="{86DCB8BF-3C43-49E2-8EE9-1D93942434DE}"/>
               </a:ext>
             </a:extLst>
           </p:cNvPr>
@@ -18027,7 +18027,7 @@
           <p:cNvPr id="6" name="Sales, debt, stock and expenses">
             <a:extLst xmlns:a="http://schemas.openxmlformats.org/drawingml/2006/main">
               <a:ext uri="{FF2B5EF4-FFF2-40B4-BE49-F238E27FC236}">
-                <a16:creationId xmlns:a16="http://schemas.microsoft.com/office/drawing/2014/main" id="{4E019CAA-1935-4ADC-B2BE-323D1492F8A1}"/>
+                <a16:creationId xmlns:a16="http://schemas.microsoft.com/office/drawing/2014/main" id="{30309393-619F-48A4-AF27-BD7908938BC2}"/>
               </a:ext>
             </a:extLst>
           </p:cNvPr>
@@ -18118,7 +18118,7 @@
           <p:cNvPr id="7" name="Finance engines">
             <a:extLst xmlns:a="http://schemas.openxmlformats.org/drawingml/2006/main">
               <a:ext uri="{FF2B5EF4-FFF2-40B4-BE49-F238E27FC236}">
-                <a16:creationId xmlns:a16="http://schemas.microsoft.com/office/drawing/2014/main" id="{FC163D1D-B9DB-4E37-B873-4A894A95B338}"/>
+                <a16:creationId xmlns:a16="http://schemas.microsoft.com/office/drawing/2014/main" id="{6F7D0C05-2336-428E-A9A7-E601D6FF99AB}"/>
               </a:ext>
             </a:extLst>
           </p:cNvPr>
@@ -18150,7 +18150,7 @@
           <p:cNvPr id="8" name="Finance engines">
             <a:extLst xmlns:a="http://schemas.openxmlformats.org/drawingml/2006/main">
               <a:ext uri="{FF2B5EF4-FFF2-40B4-BE49-F238E27FC236}">
-                <a16:creationId xmlns:a16="http://schemas.microsoft.com/office/drawing/2014/main" id="{6D33B64C-F7E9-463D-B3F5-36AD2928BEAC}"/>
+                <a16:creationId xmlns:a16="http://schemas.microsoft.com/office/drawing/2014/main" id="{F5C40469-BA33-4BE3-98A0-735390378A75}"/>
               </a:ext>
             </a:extLst>
           </p:cNvPr>
@@ -18218,7 +18218,7 @@
           <p:cNvPr id="9" name="Cash forecast, metrics and eligibility">
             <a:extLst xmlns:a="http://schemas.openxmlformats.org/drawingml/2006/main">
               <a:ext uri="{FF2B5EF4-FFF2-40B4-BE49-F238E27FC236}">
-                <a16:creationId xmlns:a16="http://schemas.microsoft.com/office/drawing/2014/main" id="{DB2E2D44-B674-42C2-BC79-B1B7F422A018}"/>
+                <a16:creationId xmlns:a16="http://schemas.microsoft.com/office/drawing/2014/main" id="{128817BB-D772-4390-BD47-98021528C1D6}"/>
               </a:ext>
             </a:extLst>
           </p:cNvPr>
@@ -18309,7 +18309,7 @@
           <p:cNvPr id="10" name="AI choice">
             <a:extLst xmlns:a="http://schemas.openxmlformats.org/drawingml/2006/main">
               <a:ext uri="{FF2B5EF4-FFF2-40B4-BE49-F238E27FC236}">
-                <a16:creationId xmlns:a16="http://schemas.microsoft.com/office/drawing/2014/main" id="{FDBEC303-8B69-4122-9FB5-56694512903E}"/>
+                <a16:creationId xmlns:a16="http://schemas.microsoft.com/office/drawing/2014/main" id="{9C0D0FD8-86F2-4335-84AF-8D63BB548FA4}"/>
               </a:ext>
             </a:extLst>
           </p:cNvPr>
@@ -18341,7 +18341,7 @@
           <p:cNvPr id="11" name="AI choice">
             <a:extLst xmlns:a="http://schemas.openxmlformats.org/drawingml/2006/main">
               <a:ext uri="{FF2B5EF4-FFF2-40B4-BE49-F238E27FC236}">
-                <a16:creationId xmlns:a16="http://schemas.microsoft.com/office/drawing/2014/main" id="{E2C15964-C578-4137-BF1E-53DCAF62DA17}"/>
+                <a16:creationId xmlns:a16="http://schemas.microsoft.com/office/drawing/2014/main" id="{C0D18FA1-7C89-4674-A63C-DB8FBA15DB34}"/>
               </a:ext>
             </a:extLst>
           </p:cNvPr>
@@ -18409,7 +18409,7 @@
           <p:cNvPr id="12" name="Select or explain allowed options">
             <a:extLst xmlns:a="http://schemas.openxmlformats.org/drawingml/2006/main">
               <a:ext uri="{FF2B5EF4-FFF2-40B4-BE49-F238E27FC236}">
-                <a16:creationId xmlns:a16="http://schemas.microsoft.com/office/drawing/2014/main" id="{DAFA0CCE-4021-481C-9344-35FDC3C122F7}"/>
+                <a16:creationId xmlns:a16="http://schemas.microsoft.com/office/drawing/2014/main" id="{FC5ACC98-F5D3-40E6-AA51-A48B54B81A3C}"/>
               </a:ext>
             </a:extLst>
           </p:cNvPr>
@@ -18500,7 +18500,7 @@
           <p:cNvPr id="13" name="Owner review">
             <a:extLst xmlns:a="http://schemas.openxmlformats.org/drawingml/2006/main">
               <a:ext uri="{FF2B5EF4-FFF2-40B4-BE49-F238E27FC236}">
-                <a16:creationId xmlns:a16="http://schemas.microsoft.com/office/drawing/2014/main" id="{783EEBA4-CA0A-4C3E-B4C0-5EFEFB8EAF2B}"/>
+                <a16:creationId xmlns:a16="http://schemas.microsoft.com/office/drawing/2014/main" id="{2BA28185-A52F-4954-90CA-151C5A401208}"/>
               </a:ext>
             </a:extLst>
           </p:cNvPr>
@@ -18532,7 +18532,7 @@
           <p:cNvPr id="14" name="Owner review">
             <a:extLst xmlns:a="http://schemas.openxmlformats.org/drawingml/2006/main">
               <a:ext uri="{FF2B5EF4-FFF2-40B4-BE49-F238E27FC236}">
-                <a16:creationId xmlns:a16="http://schemas.microsoft.com/office/drawing/2014/main" id="{B2108D5E-1735-4318-8E0A-981033BBD58E}"/>
+                <a16:creationId xmlns:a16="http://schemas.microsoft.com/office/drawing/2014/main" id="{2F823D40-57F5-4319-9AE5-EF2B587936CF}"/>
               </a:ext>
             </a:extLst>
           </p:cNvPr>
@@ -18600,7 +18600,7 @@
           <p:cNvPr id="15" name="Approve or reject a proposed plan">
             <a:extLst xmlns:a="http://schemas.openxmlformats.org/drawingml/2006/main">
               <a:ext uri="{FF2B5EF4-FFF2-40B4-BE49-F238E27FC236}">
-                <a16:creationId xmlns:a16="http://schemas.microsoft.com/office/drawing/2014/main" id="{479962EB-9DDD-4551-9FF4-7AEF78322E5D}"/>
+                <a16:creationId xmlns:a16="http://schemas.microsoft.com/office/drawing/2014/main" id="{04ABB6E3-4A4C-46AD-8501-947579C345AA}"/>
               </a:ext>
             </a:extLst>
           </p:cNvPr>
@@ -18691,7 +18691,7 @@
           <p:cNvPr id="16" name="Outcome record">
             <a:extLst xmlns:a="http://schemas.openxmlformats.org/drawingml/2006/main">
               <a:ext uri="{FF2B5EF4-FFF2-40B4-BE49-F238E27FC236}">
-                <a16:creationId xmlns:a16="http://schemas.microsoft.com/office/drawing/2014/main" id="{59EB10EB-1B3C-4465-A01A-5F29C98B584A}"/>
+                <a16:creationId xmlns:a16="http://schemas.microsoft.com/office/drawing/2014/main" id="{868FA46C-86A6-41DB-8ACA-595BDD53B551}"/>
               </a:ext>
             </a:extLst>
           </p:cNvPr>
@@ -18723,7 +18723,7 @@
           <p:cNvPr id="17" name="Outcome record">
             <a:extLst xmlns:a="http://schemas.openxmlformats.org/drawingml/2006/main">
               <a:ext uri="{FF2B5EF4-FFF2-40B4-BE49-F238E27FC236}">
-                <a16:creationId xmlns:a16="http://schemas.microsoft.com/office/drawing/2014/main" id="{7996C894-BC2C-4B1F-9398-1A3D0164D06D}"/>
+                <a16:creationId xmlns:a16="http://schemas.microsoft.com/office/drawing/2014/main" id="{85FE2FC6-0C5E-4677-B2CD-D4EFEE602A7F}"/>
               </a:ext>
             </a:extLst>
           </p:cNvPr>
@@ -18791,7 +18791,7 @@
           <p:cNvPr id="18" name="Link recorded events and inspect results">
             <a:extLst xmlns:a="http://schemas.openxmlformats.org/drawingml/2006/main">
               <a:ext uri="{FF2B5EF4-FFF2-40B4-BE49-F238E27FC236}">
-                <a16:creationId xmlns:a16="http://schemas.microsoft.com/office/drawing/2014/main" id="{1662C8E3-37B4-447E-B0B7-AE1C059C895B}"/>
+                <a16:creationId xmlns:a16="http://schemas.microsoft.com/office/drawing/2014/main" id="{9DC9D248-5826-4129-9986-F5A74505E4CB}"/>
               </a:ext>
             </a:extLst>
           </p:cNvPr>
@@ -18882,7 +18882,7 @@
           <p:cNvPr id="23" name="Example: overdue customer payment">
             <a:extLst xmlns:a="http://schemas.openxmlformats.org/drawingml/2006/main">
               <a:ext uri="{FF2B5EF4-FFF2-40B4-BE49-F238E27FC236}">
-                <a16:creationId xmlns:a16="http://schemas.microsoft.com/office/drawing/2014/main" id="{A424EDF9-59F9-4FEA-ABB5-38D7EFB75F05}"/>
+                <a16:creationId xmlns:a16="http://schemas.microsoft.com/office/drawing/2014/main" id="{36535344-998D-4590-B424-DDEFE2499956}"/>
               </a:ext>
             </a:extLst>
           </p:cNvPr>
@@ -18950,7 +18950,7 @@
           <p:cNvPr id="24" name="A cash alert leads to a proposed collection plan. The owner ">
             <a:extLst xmlns:a="http://schemas.openxmlformats.org/drawingml/2006/main">
               <a:ext uri="{FF2B5EF4-FFF2-40B4-BE49-F238E27FC236}">
-                <a16:creationId xmlns:a16="http://schemas.microsoft.com/office/drawing/2014/main" id="{91FC3A35-8AD4-4257-9226-C99425793721}"/>
+                <a16:creationId xmlns:a16="http://schemas.microsoft.com/office/drawing/2014/main" id="{E2884FDD-E931-4084-BC81-34AB41DDA419}"/>
               </a:ext>
             </a:extLst>
           </p:cNvPr>
@@ -19041,7 +19041,7 @@
           <p:cNvPr id="25" name="Approval records a decision. The application does not execut">
             <a:extLst xmlns:a="http://schemas.openxmlformats.org/drawingml/2006/main">
               <a:ext uri="{FF2B5EF4-FFF2-40B4-BE49-F238E27FC236}">
-                <a16:creationId xmlns:a16="http://schemas.microsoft.com/office/drawing/2014/main" id="{6C574D95-7678-44F0-929D-525BD4905494}"/>
+                <a16:creationId xmlns:a16="http://schemas.microsoft.com/office/drawing/2014/main" id="{6C397B8A-64A5-45D2-95BB-75119349A348}"/>
               </a:ext>
             </a:extLst>
           </p:cNvPr>
@@ -19107,7 +19107,7 @@
     </p:spTree>
     <p:extLst>
       <p:ext uri="{BB962C8B-B14F-4D97-AF65-F5344CB8AC3E}">
-        <p14:creationId xmlns:p14="http://schemas.microsoft.com/office/powerpoint/2010/main" val="927724810"/>
+        <p14:creationId xmlns:p14="http://schemas.microsoft.com/office/powerpoint/2010/main" val="1604485464"/>
       </p:ext>
     </p:extLst>
   </p:cSld>
@@ -19138,7 +19138,7 @@
           <p:cNvPr id="8" name="BizWizard">
             <a:extLst xmlns:a="http://schemas.openxmlformats.org/drawingml/2006/main">
               <a:ext uri="{FF2B5EF4-FFF2-40B4-BE49-F238E27FC236}">
-                <a16:creationId xmlns:a16="http://schemas.microsoft.com/office/drawing/2014/main" id="{A530DB94-3D9A-4F16-AFE5-73775C093C76}"/>
+                <a16:creationId xmlns:a16="http://schemas.microsoft.com/office/drawing/2014/main" id="{0FD4C24C-A751-4813-AFAE-B19F0AC96743}"/>
               </a:ext>
             </a:extLst>
           </p:cNvPr>
@@ -19206,7 +19206,7 @@
           <p:cNvPr id="2" name="05">
             <a:extLst xmlns:a="http://schemas.openxmlformats.org/drawingml/2006/main">
               <a:ext uri="{FF2B5EF4-FFF2-40B4-BE49-F238E27FC236}">
-                <a16:creationId xmlns:a16="http://schemas.microsoft.com/office/drawing/2014/main" id="{4430FAEB-4D72-40BB-B49F-DF4BBF7B5A9E}"/>
+                <a16:creationId xmlns:a16="http://schemas.microsoft.com/office/drawing/2014/main" id="{CB73E549-9D55-47DC-869B-3592958DDA2F}"/>
               </a:ext>
             </a:extLst>
           </p:cNvPr>
@@ -19274,7 +19274,7 @@
           <p:cNvPr id="3" name="Slide heading">
             <a:extLst xmlns:a="http://schemas.openxmlformats.org/drawingml/2006/main">
               <a:ext uri="{FF2B5EF4-FFF2-40B4-BE49-F238E27FC236}">
-                <a16:creationId xmlns:a16="http://schemas.microsoft.com/office/drawing/2014/main" id="{FF353AD0-2028-472B-96F5-33410E4D4EA1}"/>
+                <a16:creationId xmlns:a16="http://schemas.microsoft.com/office/drawing/2014/main" id="{0AE6BB33-1D84-4135-809F-0483F1D4F2B8}"/>
               </a:ext>
             </a:extLst>
           </p:cNvPr>
@@ -19342,7 +19342,7 @@
           <p:cNvPr id="4" name="The finance copilot reads the platform’s saved business reco">
             <a:extLst xmlns:a="http://schemas.openxmlformats.org/drawingml/2006/main">
               <a:ext uri="{FF2B5EF4-FFF2-40B4-BE49-F238E27FC236}">
-                <a16:creationId xmlns:a16="http://schemas.microsoft.com/office/drawing/2014/main" id="{A0600AFE-7F94-4C21-807C-7E82EE2F75E3}"/>
+                <a16:creationId xmlns:a16="http://schemas.microsoft.com/office/drawing/2014/main" id="{E977987C-7E23-4600-AC6C-B8EFD207C1A6}"/>
               </a:ext>
             </a:extLst>
           </p:cNvPr>
@@ -19410,7 +19410,7 @@
           <p:cNvPr id="5" name="">
             <a:extLst xmlns:a="http://schemas.openxmlformats.org/drawingml/2006/main">
               <a:ext uri="{FF2B5EF4-FFF2-40B4-BE49-F238E27FC236}">
-                <a16:creationId xmlns:a16="http://schemas.microsoft.com/office/drawing/2014/main" id="{ADDFD258-86A8-45E0-AAB2-0646EBCC0396}"/>
+                <a16:creationId xmlns:a16="http://schemas.microsoft.com/office/drawing/2014/main" id="{A63FDAEE-89B4-4185-AE77-D2DE54A3D57A}"/>
               </a:ext>
             </a:extLst>
           </p:cNvPr>
@@ -20153,7 +20153,7 @@
           <p:cNvPr id="6" name="A credit sale reduces stock and records money owed. A later ">
             <a:extLst xmlns:a="http://schemas.openxmlformats.org/drawingml/2006/main">
               <a:ext uri="{FF2B5EF4-FFF2-40B4-BE49-F238E27FC236}">
-                <a16:creationId xmlns:a16="http://schemas.microsoft.com/office/drawing/2014/main" id="{F15DD704-1CDC-4331-A6E1-C222E284E5B1}"/>
+                <a16:creationId xmlns:a16="http://schemas.microsoft.com/office/drawing/2014/main" id="{90785B2B-D05B-4BFE-9082-A49E2D9DAC86}"/>
               </a:ext>
             </a:extLst>
           </p:cNvPr>
@@ -20244,7 +20244,7 @@
           <p:cNvPr id="7" name="Implemented application workflows. Presentation screenshots ">
             <a:extLst xmlns:a="http://schemas.openxmlformats.org/drawingml/2006/main">
               <a:ext uri="{FF2B5EF4-FFF2-40B4-BE49-F238E27FC236}">
-                <a16:creationId xmlns:a16="http://schemas.microsoft.com/office/drawing/2014/main" id="{1C459E67-6968-42B3-BEF1-0F6DE7356635}"/>
+                <a16:creationId xmlns:a16="http://schemas.microsoft.com/office/drawing/2014/main" id="{8F7CAFFA-6EBB-4E88-A01B-4D7B1579CFF1}"/>
               </a:ext>
             </a:extLst>
           </p:cNvPr>
@@ -20310,7 +20310,7 @@
     </p:spTree>
     <p:extLst>
       <p:ext uri="{BB962C8B-B14F-4D97-AF65-F5344CB8AC3E}">
-        <p14:creationId xmlns:p14="http://schemas.microsoft.com/office/powerpoint/2010/main" val="1640052467"/>
+        <p14:creationId xmlns:p14="http://schemas.microsoft.com/office/powerpoint/2010/main" val="1118909667"/>
       </p:ext>
     </p:extLst>
   </p:cSld>
@@ -20341,7 +20341,7 @@
           <p:cNvPr id="13" name="BizWizard">
             <a:extLst xmlns:a="http://schemas.openxmlformats.org/drawingml/2006/main">
               <a:ext uri="{FF2B5EF4-FFF2-40B4-BE49-F238E27FC236}">
-                <a16:creationId xmlns:a16="http://schemas.microsoft.com/office/drawing/2014/main" id="{0473E413-9222-479E-9437-8D04641C04BD}"/>
+                <a16:creationId xmlns:a16="http://schemas.microsoft.com/office/drawing/2014/main" id="{78F1002D-F621-4B95-90E7-BC7BC09E5A98}"/>
               </a:ext>
             </a:extLst>
           </p:cNvPr>
@@ -20409,7 +20409,7 @@
           <p:cNvPr id="2" name="06">
             <a:extLst xmlns:a="http://schemas.openxmlformats.org/drawingml/2006/main">
               <a:ext uri="{FF2B5EF4-FFF2-40B4-BE49-F238E27FC236}">
-                <a16:creationId xmlns:a16="http://schemas.microsoft.com/office/drawing/2014/main" id="{D5EBD4DB-A7B1-454A-AC39-8BA128B4B4A5}"/>
+                <a16:creationId xmlns:a16="http://schemas.microsoft.com/office/drawing/2014/main" id="{BC71FE50-4478-4F5F-8FF0-F07F4991FC6F}"/>
               </a:ext>
             </a:extLst>
           </p:cNvPr>
@@ -20477,7 +20477,7 @@
           <p:cNvPr id="3" name="Slide heading">
             <a:extLst xmlns:a="http://schemas.openxmlformats.org/drawingml/2006/main">
               <a:ext uri="{FF2B5EF4-FFF2-40B4-BE49-F238E27FC236}">
-                <a16:creationId xmlns:a16="http://schemas.microsoft.com/office/drawing/2014/main" id="{1464054B-71F1-4F9A-BE72-ECEC72C0DFE7}"/>
+                <a16:creationId xmlns:a16="http://schemas.microsoft.com/office/drawing/2014/main" id="{C0B829EB-D3CB-4AE3-90B9-A200BEEAAE2D}"/>
               </a:ext>
             </a:extLst>
           </p:cNvPr>
@@ -20545,7 +20545,7 @@
           <p:cNvPr id="4" name="1 Check eligibility">
             <a:extLst xmlns:a="http://schemas.openxmlformats.org/drawingml/2006/main">
               <a:ext uri="{FF2B5EF4-FFF2-40B4-BE49-F238E27FC236}">
-                <a16:creationId xmlns:a16="http://schemas.microsoft.com/office/drawing/2014/main" id="{E4449B83-9C8D-4D2B-B265-94B1A0F37069}"/>
+                <a16:creationId xmlns:a16="http://schemas.microsoft.com/office/drawing/2014/main" id="{90D9695C-92EA-4EF0-A989-5CBD65372992}"/>
               </a:ext>
             </a:extLst>
           </p:cNvPr>
@@ -20613,7 +20613,7 @@
           <p:cNvPr id="5" name="90 days of sales history. At least 60% sales-day coverage.">
             <a:extLst xmlns:a="http://schemas.openxmlformats.org/drawingml/2006/main">
               <a:ext uri="{FF2B5EF4-FFF2-40B4-BE49-F238E27FC236}">
-                <a16:creationId xmlns:a16="http://schemas.microsoft.com/office/drawing/2014/main" id="{2582D722-759D-4977-84F4-BF74E4204AC5}"/>
+                <a16:creationId xmlns:a16="http://schemas.microsoft.com/office/drawing/2014/main" id="{21651B72-4E11-449D-8404-344F41CAD1AD}"/>
               </a:ext>
             </a:extLst>
           </p:cNvPr>
@@ -20704,7 +20704,7 @@
           <p:cNvPr id="6" name="2 Compare feasible options">
             <a:extLst xmlns:a="http://schemas.openxmlformats.org/drawingml/2006/main">
               <a:ext uri="{FF2B5EF4-FFF2-40B4-BE49-F238E27FC236}">
-                <a16:creationId xmlns:a16="http://schemas.microsoft.com/office/drawing/2014/main" id="{7DC290C8-6A28-43F8-A163-464C281D2766}"/>
+                <a16:creationId xmlns:a16="http://schemas.microsoft.com/office/drawing/2014/main" id="{EF4CC1CE-E1A6-4110-906D-C264FC6E1A52}"/>
               </a:ext>
             </a:extLst>
           </p:cNvPr>
@@ -20772,7 +20772,7 @@
           <p:cNvPr id="7" name="AI can enrich the ranking. Code prices the offer.">
             <a:extLst xmlns:a="http://schemas.openxmlformats.org/drawingml/2006/main">
               <a:ext uri="{FF2B5EF4-FFF2-40B4-BE49-F238E27FC236}">
-                <a16:creationId xmlns:a16="http://schemas.microsoft.com/office/drawing/2014/main" id="{756B3C32-4344-49B6-8AFF-A5E44BBBD3A7}"/>
+                <a16:creationId xmlns:a16="http://schemas.microsoft.com/office/drawing/2014/main" id="{4D312B1F-7A34-461B-AEB4-C74BCE603889}"/>
               </a:ext>
             </a:extLst>
           </p:cNvPr>
@@ -20863,7 +20863,7 @@
           <p:cNvPr id="8" name="3 Review the terms">
             <a:extLst xmlns:a="http://schemas.openxmlformats.org/drawingml/2006/main">
               <a:ext uri="{FF2B5EF4-FFF2-40B4-BE49-F238E27FC236}">
-                <a16:creationId xmlns:a16="http://schemas.microsoft.com/office/drawing/2014/main" id="{91CCD318-8F86-4EA6-B73A-B87C92ECE575}"/>
+                <a16:creationId xmlns:a16="http://schemas.microsoft.com/office/drawing/2014/main" id="{1C9A94A5-63F1-4D5B-AC09-1CBC3D9F35A1}"/>
               </a:ext>
             </a:extLst>
           </p:cNvPr>
@@ -20931,7 +20931,7 @@
           <p:cNvPr id="9" name="Deterministic policies negotiate for up to three rounds.">
             <a:extLst xmlns:a="http://schemas.openxmlformats.org/drawingml/2006/main">
               <a:ext uri="{FF2B5EF4-FFF2-40B4-BE49-F238E27FC236}">
-                <a16:creationId xmlns:a16="http://schemas.microsoft.com/office/drawing/2014/main" id="{55A2031E-DC03-42E2-B751-E85F1200A98B}"/>
+                <a16:creationId xmlns:a16="http://schemas.microsoft.com/office/drawing/2014/main" id="{86CA20F4-F9D3-485D-BC5E-FA1B35BA5894}"/>
               </a:ext>
             </a:extLst>
           </p:cNvPr>
@@ -21022,7 +21022,7 @@
           <p:cNvPr id="10" name="7 simulated lenders / 12 seeded products">
             <a:extLst xmlns:a="http://schemas.openxmlformats.org/drawingml/2006/main">
               <a:ext uri="{FF2B5EF4-FFF2-40B4-BE49-F238E27FC236}">
-                <a16:creationId xmlns:a16="http://schemas.microsoft.com/office/drawing/2014/main" id="{8AA53C1B-6BBF-45E8-ACF1-79C01AF7C3F3}"/>
+                <a16:creationId xmlns:a16="http://schemas.microsoft.com/office/drawing/2014/main" id="{0A1D59E5-8B79-45D2-A183-D9C374AAB984}"/>
               </a:ext>
             </a:extLst>
           </p:cNvPr>
@@ -21090,7 +21090,7 @@
           <p:cNvPr id="11" name="">
             <a:extLst xmlns:a="http://schemas.openxmlformats.org/drawingml/2006/main">
               <a:ext uri="{FF2B5EF4-FFF2-40B4-BE49-F238E27FC236}">
-                <a16:creationId xmlns:a16="http://schemas.microsoft.com/office/drawing/2014/main" id="{85E6F0A0-34DF-4902-93C2-B25126B9FC30}"/>
+                <a16:creationId xmlns:a16="http://schemas.microsoft.com/office/drawing/2014/main" id="{CAC8F461-EC8A-41B1-BDD9-02772D6E4F6C}"/>
               </a:ext>
             </a:extLst>
           </p:cNvPr>
@@ -21100,7 +21100,7 @@
           <p:nvPr/>
         </p:nvPicPr>
         <p:blipFill>
-          <a:blip xmlns:r="http://schemas.openxmlformats.org/officeDocument/2006/relationships" xmlns:a="http://schemas.openxmlformats.org/drawingml/2006/main" r:embed="R3e2316a6729447e6"/>
+          <a:blip xmlns:r="http://schemas.openxmlformats.org/officeDocument/2006/relationships" xmlns:a="http://schemas.openxmlformats.org/drawingml/2006/main" r:embed="R6b75e70a0cfe4c11"/>
           <a:stretch xmlns:a="http://schemas.openxmlformats.org/drawingml/2006/main"/>
         </p:blipFill>
         <p:spPr>
@@ -21118,7 +21118,7 @@
           <p:cNvPr id="12" name="Live app with seeded demo records. Eligible matches do not g">
             <a:extLst xmlns:a="http://schemas.openxmlformats.org/drawingml/2006/main">
               <a:ext uri="{FF2B5EF4-FFF2-40B4-BE49-F238E27FC236}">
-                <a16:creationId xmlns:a16="http://schemas.microsoft.com/office/drawing/2014/main" id="{DE0D715A-C1BA-4C0D-B707-6FE345B0F1F6}"/>
+                <a16:creationId xmlns:a16="http://schemas.microsoft.com/office/drawing/2014/main" id="{5BE6A025-A51F-4B68-8172-DB3386E01003}"/>
               </a:ext>
             </a:extLst>
           </p:cNvPr>
@@ -21184,7 +21184,7 @@
     </p:spTree>
     <p:extLst>
       <p:ext uri="{BB962C8B-B14F-4D97-AF65-F5344CB8AC3E}">
-        <p14:creationId xmlns:p14="http://schemas.microsoft.com/office/powerpoint/2010/main" val="1572550933"/>
+        <p14:creationId xmlns:p14="http://schemas.microsoft.com/office/powerpoint/2010/main" val="1754373098"/>
       </p:ext>
     </p:extLst>
   </p:cSld>
@@ -21215,7 +21215,7 @@
           <p:cNvPr id="13" name="BizWizard">
             <a:extLst xmlns:a="http://schemas.openxmlformats.org/drawingml/2006/main">
               <a:ext uri="{FF2B5EF4-FFF2-40B4-BE49-F238E27FC236}">
-                <a16:creationId xmlns:a16="http://schemas.microsoft.com/office/drawing/2014/main" id="{AAA359B3-874B-44FA-970B-A619775240BA}"/>
+                <a16:creationId xmlns:a16="http://schemas.microsoft.com/office/drawing/2014/main" id="{00627071-CCCB-49C0-96F5-DB4B69F43349}"/>
               </a:ext>
             </a:extLst>
           </p:cNvPr>
@@ -21283,7 +21283,7 @@
           <p:cNvPr id="2" name="07">
             <a:extLst xmlns:a="http://schemas.openxmlformats.org/drawingml/2006/main">
               <a:ext uri="{FF2B5EF4-FFF2-40B4-BE49-F238E27FC236}">
-                <a16:creationId xmlns:a16="http://schemas.microsoft.com/office/drawing/2014/main" id="{CF587DE2-5321-44C8-B8D1-E46627885150}"/>
+                <a16:creationId xmlns:a16="http://schemas.microsoft.com/office/drawing/2014/main" id="{BCDAA1AB-F0C0-4014-AE80-F62A40FB92CA}"/>
               </a:ext>
             </a:extLst>
           </p:cNvPr>
@@ -21351,7 +21351,7 @@
           <p:cNvPr id="3" name="Slide heading">
             <a:extLst xmlns:a="http://schemas.openxmlformats.org/drawingml/2006/main">
               <a:ext uri="{FF2B5EF4-FFF2-40B4-BE49-F238E27FC236}">
-                <a16:creationId xmlns:a16="http://schemas.microsoft.com/office/drawing/2014/main" id="{7F15916B-4155-4F65-BBE3-23FE0CD053B3}"/>
+                <a16:creationId xmlns:a16="http://schemas.microsoft.com/office/drawing/2014/main" id="{685CD84F-C856-4B14-BA9B-5AF11F6FF913}"/>
               </a:ext>
             </a:extLst>
           </p:cNvPr>
@@ -21419,7 +21419,7 @@
           <p:cNvPr id="4" name="Ten eligibility rules run before AI sees the eligible produc">
             <a:extLst xmlns:a="http://schemas.openxmlformats.org/drawingml/2006/main">
               <a:ext uri="{FF2B5EF4-FFF2-40B4-BE49-F238E27FC236}">
-                <a16:creationId xmlns:a16="http://schemas.microsoft.com/office/drawing/2014/main" id="{848FB598-9458-4B4C-98D1-0A8C84B3F5B0}"/>
+                <a16:creationId xmlns:a16="http://schemas.microsoft.com/office/drawing/2014/main" id="{34B92A43-BABF-42BC-B558-7CF6894AE887}"/>
               </a:ext>
             </a:extLst>
           </p:cNvPr>
@@ -21487,7 +21487,7 @@
           <p:cNvPr id="5" name="">
             <a:extLst xmlns:a="http://schemas.openxmlformats.org/drawingml/2006/main">
               <a:ext uri="{FF2B5EF4-FFF2-40B4-BE49-F238E27FC236}">
-                <a16:creationId xmlns:a16="http://schemas.microsoft.com/office/drawing/2014/main" id="{654A591C-B5E4-4EA9-90AA-779B5A028F57}"/>
+                <a16:creationId xmlns:a16="http://schemas.microsoft.com/office/drawing/2014/main" id="{6999FD31-E0E0-4D9A-9BCD-5CFB3D79747C}"/>
               </a:ext>
             </a:extLst>
           </p:cNvPr>
@@ -21924,7 +21924,7 @@
           <p:cNvPr id="6" name="Final score = 60% rules + 40% AI">
             <a:extLst xmlns:a="http://schemas.openxmlformats.org/drawingml/2006/main">
               <a:ext uri="{FF2B5EF4-FFF2-40B4-BE49-F238E27FC236}">
-                <a16:creationId xmlns:a16="http://schemas.microsoft.com/office/drawing/2014/main" id="{C946A7E9-6B17-4E75-B430-3D5574FC0B83}"/>
+                <a16:creationId xmlns:a16="http://schemas.microsoft.com/office/drawing/2014/main" id="{D84BC20A-3820-45EE-B378-8C8077F24483}"/>
               </a:ext>
             </a:extLst>
           </p:cNvPr>
@@ -21992,7 +21992,7 @@
           <p:cNvPr id="7" name="The AI score stays within ±15 points of the rules score.">
             <a:extLst xmlns:a="http://schemas.openxmlformats.org/drawingml/2006/main">
               <a:ext uri="{FF2B5EF4-FFF2-40B4-BE49-F238E27FC236}">
-                <a16:creationId xmlns:a16="http://schemas.microsoft.com/office/drawing/2014/main" id="{A41669EA-1509-4F53-A815-E1B6C0943499}"/>
+                <a16:creationId xmlns:a16="http://schemas.microsoft.com/office/drawing/2014/main" id="{9E5F7C30-09C3-4082-886C-ACD85BF066FA}"/>
               </a:ext>
             </a:extLst>
           </p:cNvPr>
@@ -22060,7 +22060,7 @@
           <p:cNvPr id="8" name="Repayment capacity">
             <a:extLst xmlns:a="http://schemas.openxmlformats.org/drawingml/2006/main">
               <a:ext uri="{FF2B5EF4-FFF2-40B4-BE49-F238E27FC236}">
-                <a16:creationId xmlns:a16="http://schemas.microsoft.com/office/drawing/2014/main" id="{5890DAEC-338B-4C48-A15C-883755A5D351}"/>
+                <a16:creationId xmlns:a16="http://schemas.microsoft.com/office/drawing/2014/main" id="{59367556-6CCA-43BC-BEA4-182BDC53ABA3}"/>
               </a:ext>
             </a:extLst>
           </p:cNvPr>
@@ -22128,7 +22128,7 @@
           <p:cNvPr id="9" name="Monthly installment ≤50% of free cash flow. Secured principa">
             <a:extLst xmlns:a="http://schemas.openxmlformats.org/drawingml/2006/main">
               <a:ext uri="{FF2B5EF4-FFF2-40B4-BE49-F238E27FC236}">
-                <a16:creationId xmlns:a16="http://schemas.microsoft.com/office/drawing/2014/main" id="{7CF521D6-3CED-4410-8E49-CB17210064C4}"/>
+                <a16:creationId xmlns:a16="http://schemas.microsoft.com/office/drawing/2014/main" id="{D99091FF-3FF5-417B-80F9-4BCAA3B256D5}"/>
               </a:ext>
             </a:extLst>
           </p:cNvPr>
@@ -22219,7 +22219,7 @@
           <p:cNvPr id="10" name="Negotiation limits">
             <a:extLst xmlns:a="http://schemas.openxmlformats.org/drawingml/2006/main">
               <a:ext uri="{FF2B5EF4-FFF2-40B4-BE49-F238E27FC236}">
-                <a16:creationId xmlns:a16="http://schemas.microsoft.com/office/drawing/2014/main" id="{EDAC37C3-D444-4C48-8748-4C9999A686AF}"/>
+                <a16:creationId xmlns:a16="http://schemas.microsoft.com/office/drawing/2014/main" id="{BA9E11D7-470E-4055-AD8A-A0A46F81AC18}"/>
               </a:ext>
             </a:extLst>
           </p:cNvPr>
@@ -22287,7 +22287,7 @@
           <p:cNvPr id="11" name="Up to 3 rounds. Borrower acceptance tests a 35% installment ">
             <a:extLst xmlns:a="http://schemas.openxmlformats.org/drawingml/2006/main">
               <a:ext uri="{FF2B5EF4-FFF2-40B4-BE49-F238E27FC236}">
-                <a16:creationId xmlns:a16="http://schemas.microsoft.com/office/drawing/2014/main" id="{CD45C545-09C8-4238-85FF-DCF09D2AEEA0}"/>
+                <a16:creationId xmlns:a16="http://schemas.microsoft.com/office/drawing/2014/main" id="{A9982F49-BB79-4A51-8CF5-539AFA101B0B}"/>
               </a:ext>
             </a:extLst>
           </p:cNvPr>
@@ -22378,7 +22378,7 @@
           <p:cNvPr id="12" name="Code prices offers from risk and product limits. A guard bre">
             <a:extLst xmlns:a="http://schemas.openxmlformats.org/drawingml/2006/main">
               <a:ext uri="{FF2B5EF4-FFF2-40B4-BE49-F238E27FC236}">
-                <a16:creationId xmlns:a16="http://schemas.microsoft.com/office/drawing/2014/main" id="{35B6B1BF-4A4F-4641-8A90-1875C2EF62C6}"/>
+                <a16:creationId xmlns:a16="http://schemas.microsoft.com/office/drawing/2014/main" id="{904746A4-1E7D-4EE6-95DF-622546655887}"/>
               </a:ext>
             </a:extLst>
           </p:cNvPr>
@@ -22444,7 +22444,7 @@
     </p:spTree>
     <p:extLst>
       <p:ext uri="{BB962C8B-B14F-4D97-AF65-F5344CB8AC3E}">
-        <p14:creationId xmlns:p14="http://schemas.microsoft.com/office/powerpoint/2010/main" val="1782377643"/>
+        <p14:creationId xmlns:p14="http://schemas.microsoft.com/office/powerpoint/2010/main" val="1694861725"/>
       </p:ext>
     </p:extLst>
   </p:cSld>
@@ -22475,7 +22475,7 @@
           <p:cNvPr id="12" name="BizWizard">
             <a:extLst xmlns:a="http://schemas.openxmlformats.org/drawingml/2006/main">
               <a:ext uri="{FF2B5EF4-FFF2-40B4-BE49-F238E27FC236}">
-                <a16:creationId xmlns:a16="http://schemas.microsoft.com/office/drawing/2014/main" id="{A7BA545B-B054-43E3-828F-74D42D2C6354}"/>
+                <a16:creationId xmlns:a16="http://schemas.microsoft.com/office/drawing/2014/main" id="{07CF798F-C459-42ED-85B7-B2355DE18ABC}"/>
               </a:ext>
             </a:extLst>
           </p:cNvPr>
@@ -22543,7 +22543,7 @@
           <p:cNvPr id="2" name="08">
             <a:extLst xmlns:a="http://schemas.openxmlformats.org/drawingml/2006/main">
               <a:ext uri="{FF2B5EF4-FFF2-40B4-BE49-F238E27FC236}">
-                <a16:creationId xmlns:a16="http://schemas.microsoft.com/office/drawing/2014/main" id="{3D4D41CA-7ACF-4502-8AEF-2AD04ABD6BE8}"/>
+                <a16:creationId xmlns:a16="http://schemas.microsoft.com/office/drawing/2014/main" id="{5C57ADB1-0484-4BFF-A818-AB0567B6F37A}"/>
               </a:ext>
             </a:extLst>
           </p:cNvPr>
@@ -22611,7 +22611,7 @@
           <p:cNvPr id="3" name="Slide heading">
             <a:extLst xmlns:a="http://schemas.openxmlformats.org/drawingml/2006/main">
               <a:ext uri="{FF2B5EF4-FFF2-40B4-BE49-F238E27FC236}">
-                <a16:creationId xmlns:a16="http://schemas.microsoft.com/office/drawing/2014/main" id="{318253E8-009A-4221-86DD-003990C82728}"/>
+                <a16:creationId xmlns:a16="http://schemas.microsoft.com/office/drawing/2014/main" id="{045F36C7-8206-4495-A916-F15BBC99F15F}"/>
               </a:ext>
             </a:extLst>
           </p:cNvPr>
@@ -22679,7 +22679,7 @@
           <p:cNvPr id="4" name="">
             <a:extLst xmlns:a="http://schemas.openxmlformats.org/drawingml/2006/main">
               <a:ext uri="{FF2B5EF4-FFF2-40B4-BE49-F238E27FC236}">
-                <a16:creationId xmlns:a16="http://schemas.microsoft.com/office/drawing/2014/main" id="{C9A528B7-A3A0-4B9B-BC2B-F250C5229686}"/>
+                <a16:creationId xmlns:a16="http://schemas.microsoft.com/office/drawing/2014/main" id="{EB39A388-2EA7-446F-BAFB-2698073BCE5E}"/>
               </a:ext>
             </a:extLst>
           </p:cNvPr>
@@ -22689,7 +22689,7 @@
           <p:nvPr/>
         </p:nvPicPr>
         <p:blipFill>
-          <a:blip xmlns:r="http://schemas.openxmlformats.org/officeDocument/2006/relationships" xmlns:a="http://schemas.openxmlformats.org/drawingml/2006/main" r:embed="R1a8f84d1978e484c"/>
+          <a:blip xmlns:r="http://schemas.openxmlformats.org/officeDocument/2006/relationships" xmlns:a="http://schemas.openxmlformats.org/drawingml/2006/main" r:embed="R023be2381c394b79"/>
           <a:stretch xmlns:a="http://schemas.openxmlformats.org/drawingml/2006/main"/>
         </p:blipFill>
         <p:spPr>
@@ -22707,7 +22707,7 @@
           <p:cNvPr id="5" name="90-day projection">
             <a:extLst xmlns:a="http://schemas.openxmlformats.org/drawingml/2006/main">
               <a:ext uri="{FF2B5EF4-FFF2-40B4-BE49-F238E27FC236}">
-                <a16:creationId xmlns:a16="http://schemas.microsoft.com/office/drawing/2014/main" id="{FFFCACE4-4F95-4264-BF7F-E0F3FBEEE7F7}"/>
+                <a16:creationId xmlns:a16="http://schemas.microsoft.com/office/drawing/2014/main" id="{94B8A3E9-DED7-4A7E-8309-D90800549AC7}"/>
               </a:ext>
             </a:extLst>
           </p:cNvPr>
@@ -22775,7 +22775,7 @@
           <p:cNvPr id="6" name="History, dated commitments and weighted receivables.">
             <a:extLst xmlns:a="http://schemas.openxmlformats.org/drawingml/2006/main">
               <a:ext uri="{FF2B5EF4-FFF2-40B4-BE49-F238E27FC236}">
-                <a16:creationId xmlns:a16="http://schemas.microsoft.com/office/drawing/2014/main" id="{EEBD3A3D-E99D-4F9A-B609-4D7040D56C63}"/>
+                <a16:creationId xmlns:a16="http://schemas.microsoft.com/office/drawing/2014/main" id="{4AA22691-6595-4B58-AAEB-0987A9EE45BC}"/>
               </a:ext>
             </a:extLst>
           </p:cNvPr>
@@ -22866,7 +22866,7 @@
           <p:cNvPr id="7" name="Nine alert conditions">
             <a:extLst xmlns:a="http://schemas.openxmlformats.org/drawingml/2006/main">
               <a:ext uri="{FF2B5EF4-FFF2-40B4-BE49-F238E27FC236}">
-                <a16:creationId xmlns:a16="http://schemas.microsoft.com/office/drawing/2014/main" id="{B0740055-04F3-45A9-A75F-C479E1107A0D}"/>
+                <a16:creationId xmlns:a16="http://schemas.microsoft.com/office/drawing/2014/main" id="{FA04E30A-DB4C-4E2F-B3C8-88DDE578A6CF}"/>
               </a:ext>
             </a:extLst>
           </p:cNvPr>
@@ -22934,7 +22934,7 @@
           <p:cNvPr id="8" name="Shortfalls, cash buffers, aging debt and unusual costs.">
             <a:extLst xmlns:a="http://schemas.openxmlformats.org/drawingml/2006/main">
               <a:ext uri="{FF2B5EF4-FFF2-40B4-BE49-F238E27FC236}">
-                <a16:creationId xmlns:a16="http://schemas.microsoft.com/office/drawing/2014/main" id="{4BDAB51D-6C68-4C54-80DC-173C9DF853F6}"/>
+                <a16:creationId xmlns:a16="http://schemas.microsoft.com/office/drawing/2014/main" id="{E8B6EACF-46DC-4C81-B8B7-27DB355A99D5}"/>
               </a:ext>
             </a:extLst>
           </p:cNvPr>
@@ -23025,7 +23025,7 @@
           <p:cNvPr id="9" name="A reviewable next step">
             <a:extLst xmlns:a="http://schemas.openxmlformats.org/drawingml/2006/main">
               <a:ext uri="{FF2B5EF4-FFF2-40B4-BE49-F238E27FC236}">
-                <a16:creationId xmlns:a16="http://schemas.microsoft.com/office/drawing/2014/main" id="{7D6798CF-484E-4AAD-B1C5-FE1D1FB24A7B}"/>
+                <a16:creationId xmlns:a16="http://schemas.microsoft.com/office/drawing/2014/main" id="{C55ACF3C-ADCF-408C-A674-9BA1214373F4}"/>
               </a:ext>
             </a:extLst>
           </p:cNvPr>
@@ -23093,7 +23093,7 @@
           <p:cNvPr id="10" name="The owner can inspect a plan before approving it.">
             <a:extLst xmlns:a="http://schemas.openxmlformats.org/drawingml/2006/main">
               <a:ext uri="{FF2B5EF4-FFF2-40B4-BE49-F238E27FC236}">
-                <a16:creationId xmlns:a16="http://schemas.microsoft.com/office/drawing/2014/main" id="{F7EBD982-9598-49F5-9939-4DCC19877324}"/>
+                <a16:creationId xmlns:a16="http://schemas.microsoft.com/office/drawing/2014/main" id="{54B5C9ED-FED9-492F-8BAC-788ED08F561F}"/>
               </a:ext>
             </a:extLst>
           </p:cNvPr>
@@ -23184,7 +23184,7 @@
           <p:cNvPr id="11" name="Live app with seeded demo records. Projected cash and propos">
             <a:extLst xmlns:a="http://schemas.openxmlformats.org/drawingml/2006/main">
               <a:ext uri="{FF2B5EF4-FFF2-40B4-BE49-F238E27FC236}">
-                <a16:creationId xmlns:a16="http://schemas.microsoft.com/office/drawing/2014/main" id="{24AF0DC0-7B7B-4E29-B6EF-A3B7C852C4D7}"/>
+                <a16:creationId xmlns:a16="http://schemas.microsoft.com/office/drawing/2014/main" id="{61A220D3-DD5B-4241-A1AE-35CF67FD5600}"/>
               </a:ext>
             </a:extLst>
           </p:cNvPr>
@@ -23250,7 +23250,7 @@
     </p:spTree>
     <p:extLst>
       <p:ext uri="{BB962C8B-B14F-4D97-AF65-F5344CB8AC3E}">
-        <p14:creationId xmlns:p14="http://schemas.microsoft.com/office/powerpoint/2010/main" val="1411024838"/>
+        <p14:creationId xmlns:p14="http://schemas.microsoft.com/office/powerpoint/2010/main" val="755711808"/>
       </p:ext>
     </p:extLst>
   </p:cSld>
@@ -23281,7 +23281,7 @@
           <p:cNvPr id="13" name="BizWizard">
             <a:extLst xmlns:a="http://schemas.openxmlformats.org/drawingml/2006/main">
               <a:ext uri="{FF2B5EF4-FFF2-40B4-BE49-F238E27FC236}">
-                <a16:creationId xmlns:a16="http://schemas.microsoft.com/office/drawing/2014/main" id="{0DE0D877-5ED3-4162-B75F-D6E13DFF89F7}"/>
+                <a16:creationId xmlns:a16="http://schemas.microsoft.com/office/drawing/2014/main" id="{2937DC1F-F2DD-4209-8A3F-D7028AF7492C}"/>
               </a:ext>
             </a:extLst>
           </p:cNvPr>
@@ -23349,7 +23349,7 @@
           <p:cNvPr id="2" name="09">
             <a:extLst xmlns:a="http://schemas.openxmlformats.org/drawingml/2006/main">
               <a:ext uri="{FF2B5EF4-FFF2-40B4-BE49-F238E27FC236}">
-                <a16:creationId xmlns:a16="http://schemas.microsoft.com/office/drawing/2014/main" id="{B6DC551F-7079-4219-928D-DF6AD7FF8006}"/>
+                <a16:creationId xmlns:a16="http://schemas.microsoft.com/office/drawing/2014/main" id="{C626CC50-AF31-4B19-902E-3B4564936B35}"/>
               </a:ext>
             </a:extLst>
           </p:cNvPr>
@@ -23417,7 +23417,7 @@
           <p:cNvPr id="3" name="Slide heading">
             <a:extLst xmlns:a="http://schemas.openxmlformats.org/drawingml/2006/main">
               <a:ext uri="{FF2B5EF4-FFF2-40B4-BE49-F238E27FC236}">
-                <a16:creationId xmlns:a16="http://schemas.microsoft.com/office/drawing/2014/main" id="{077AEAB2-3B9E-4EA0-9AF6-ED70A4F0D836}"/>
+                <a16:creationId xmlns:a16="http://schemas.microsoft.com/office/drawing/2014/main" id="{9AB637EA-A4B5-4980-8E92-980270824965}"/>
               </a:ext>
             </a:extLst>
           </p:cNvPr>
@@ -23485,7 +23485,7 @@
           <p:cNvPr id="4" name="">
             <a:extLst xmlns:a="http://schemas.openxmlformats.org/drawingml/2006/main">
               <a:ext uri="{FF2B5EF4-FFF2-40B4-BE49-F238E27FC236}">
-                <a16:creationId xmlns:a16="http://schemas.microsoft.com/office/drawing/2014/main" id="{F7181052-7EB3-4A54-918E-38E895CEAE57}"/>
+                <a16:creationId xmlns:a16="http://schemas.microsoft.com/office/drawing/2014/main" id="{9FC5D470-B7D4-4BB7-834A-6A95FAA540A0}"/>
               </a:ext>
             </a:extLst>
           </p:cNvPr>
@@ -23764,7 +23764,7 @@
           <p:cNvPr id="5" name="Daily balance calculation">
             <a:extLst xmlns:a="http://schemas.openxmlformats.org/drawingml/2006/main">
               <a:ext uri="{FF2B5EF4-FFF2-40B4-BE49-F238E27FC236}">
-                <a16:creationId xmlns:a16="http://schemas.microsoft.com/office/drawing/2014/main" id="{007950C4-B8F1-4670-A8EA-0ABBCE078774}"/>
+                <a16:creationId xmlns:a16="http://schemas.microsoft.com/office/drawing/2014/main" id="{E5BE3364-1839-4E31-9574-C79AB6A4D066}"/>
               </a:ext>
             </a:extLst>
           </p:cNvPr>
@@ -23832,7 +23832,7 @@
           <p:cNvPr id="6" name="Weekday patterns and a trend clipped to ±30%. Dated bills an">
             <a:extLst xmlns:a="http://schemas.openxmlformats.org/drawingml/2006/main">
               <a:ext uri="{FF2B5EF4-FFF2-40B4-BE49-F238E27FC236}">
-                <a16:creationId xmlns:a16="http://schemas.microsoft.com/office/drawing/2014/main" id="{DCA2067D-28B0-484A-A074-80041EFDF2C7}"/>
+                <a16:creationId xmlns:a16="http://schemas.microsoft.com/office/drawing/2014/main" id="{88533CDC-2FC3-4D47-9A66-7EFEB0DBA5EC}"/>
               </a:ext>
             </a:extLst>
           </p:cNvPr>
@@ -23923,7 +23923,7 @@
           <p:cNvPr id="7" name="Collection assumptions">
             <a:extLst xmlns:a="http://schemas.openxmlformats.org/drawingml/2006/main">
               <a:ext uri="{FF2B5EF4-FFF2-40B4-BE49-F238E27FC236}">
-                <a16:creationId xmlns:a16="http://schemas.microsoft.com/office/drawing/2014/main" id="{61A2598B-6158-4C8E-8339-F4E93A970759}"/>
+                <a16:creationId xmlns:a16="http://schemas.microsoft.com/office/drawing/2014/main" id="{0CA0D6FB-C244-4389-8016-A0F681342CD5}"/>
               </a:ext>
             </a:extLst>
           </p:cNvPr>
@@ -23991,7 +23991,7 @@
           <p:cNvPr id="8" name="70% weight for receivables aged 0–7 days. 12% for balances a">
             <a:extLst xmlns:a="http://schemas.openxmlformats.org/drawingml/2006/main">
               <a:ext uri="{FF2B5EF4-FFF2-40B4-BE49-F238E27FC236}">
-                <a16:creationId xmlns:a16="http://schemas.microsoft.com/office/drawing/2014/main" id="{AF8A27CB-8B0C-4096-9BAD-2CE86EFA3584}"/>
+                <a16:creationId xmlns:a16="http://schemas.microsoft.com/office/drawing/2014/main" id="{D3BD2A2B-B54F-4D56-B050-8486A442067C}"/>
               </a:ext>
             </a:extLst>
           </p:cNvPr>
@@ -24082,7 +24082,7 @@
           <p:cNvPr id="9" name="Cash buffer">
             <a:extLst xmlns:a="http://schemas.openxmlformats.org/drawingml/2006/main">
               <a:ext uri="{FF2B5EF4-FFF2-40B4-BE49-F238E27FC236}">
-                <a16:creationId xmlns:a16="http://schemas.microsoft.com/office/drawing/2014/main" id="{50951D9F-B8C5-4CEE-96AC-3BA836C75235}"/>
+                <a16:creationId xmlns:a16="http://schemas.microsoft.com/office/drawing/2014/main" id="{AECCB402-02D8-4CFA-9001-D9FB16A2FC58}"/>
               </a:ext>
             </a:extLst>
           </p:cNvPr>
@@ -24150,7 +24150,7 @@
           <p:cNvPr id="10" name="Cash ÷ average daily outflow from the last 28 days.">
             <a:extLst xmlns:a="http://schemas.openxmlformats.org/drawingml/2006/main">
               <a:ext uri="{FF2B5EF4-FFF2-40B4-BE49-F238E27FC236}">
-                <a16:creationId xmlns:a16="http://schemas.microsoft.com/office/drawing/2014/main" id="{036E0158-C228-46CA-BB45-92E1E79B5A97}"/>
+                <a16:creationId xmlns:a16="http://schemas.microsoft.com/office/drawing/2014/main" id="{866C2667-6FE9-4D83-943C-463D3B446DC1}"/>
               </a:ext>
             </a:extLst>
           </p:cNvPr>
@@ -24241,7 +24241,7 @@
           <p:cNvPr id="11" name="Guarded proposals. Critical alerts notify the owner. A daily">
             <a:extLst xmlns:a="http://schemas.openxmlformats.org/drawingml/2006/main">
               <a:ext uri="{FF2B5EF4-FFF2-40B4-BE49-F238E27FC236}">
-                <a16:creationId xmlns:a16="http://schemas.microsoft.com/office/drawing/2014/main" id="{ADD0FC47-3A8C-4343-9BA8-63CF7CE83286}"/>
+                <a16:creationId xmlns:a16="http://schemas.microsoft.com/office/drawing/2014/main" id="{F4340ED8-14D5-4B34-8AC4-43AF271C8F2F}"/>
               </a:ext>
             </a:extLst>
           </p:cNvPr>
@@ -24309,7 +24309,7 @@
           <p:cNvPr id="12" name="The owner reviews a proposed action. A linked payment record">
             <a:extLst xmlns:a="http://schemas.openxmlformats.org/drawingml/2006/main">
               <a:ext uri="{FF2B5EF4-FFF2-40B4-BE49-F238E27FC236}">
-                <a16:creationId xmlns:a16="http://schemas.microsoft.com/office/drawing/2014/main" id="{D186DAC7-8B3C-42D2-99A1-6D5165177D6C}"/>
+                <a16:creationId xmlns:a16="http://schemas.microsoft.com/office/drawing/2014/main" id="{A41C0E99-47AD-4347-933A-38B876E9D924}"/>
               </a:ext>
             </a:extLst>
           </p:cNvPr>
@@ -24375,7 +24375,7 @@
     </p:spTree>
     <p:extLst>
       <p:ext uri="{BB962C8B-B14F-4D97-AF65-F5344CB8AC3E}">
-        <p14:creationId xmlns:p14="http://schemas.microsoft.com/office/powerpoint/2010/main" val="637143863"/>
+        <p14:creationId xmlns:p14="http://schemas.microsoft.com/office/powerpoint/2010/main" val="74062232"/>
       </p:ext>
     </p:extLst>
   </p:cSld>

</xml_diff>